<commit_message>
Add improved defenses, backdoor attack and NSL-KDD replication
- protocol.py: per-client weight cap and trimmed-mean second check for
  flagged updates
- defense_experiment.py: none / v1 / v2 / v2-Mondrian policies under
  label flipping and backdoor attacks, on FLNET2023 (5 seeds) and
  NSL-KDD (10 seeds); 120 runs, resumable
- preprocess_nslkdd.py + data/NSL-KDD: NSL-KDD restored as a
  replication dataset with a 10-client Dirichlet split
- multiclass.py: 11-class detection (results pending)
- Slides rebuilt from results files (10 slides); handbook script
  rewritten (PDF not yet regenerated)
- README: Phase 9 results, including the weight cap's downside and the
  backdoor failing on FLNET2023
</commit_message>
<xml_diff>
--- a/presentation/Krypsis_Presentation.pptx
+++ b/presentation/Krypsis_Presentation.pptx
@@ -13,6 +13,8 @@
     <p:sldId id="261" r:id="rId12"/>
     <p:sldId id="262" r:id="rId13"/>
     <p:sldId id="263" r:id="rId14"/>
+    <p:sldId id="264" r:id="rId15"/>
+    <p:sldId id="265" r:id="rId16"/>
   </p:sldIdLst>
   <p:sldSz cx="12191695" cy="6858000" type="screen4x3"/>
   <p:notesSz cx="6858000" cy="9144000"/>
@@ -3335,6 +3337,822 @@
 </p:sld>
 </file>
 
+<file path=ppt/slides/slide10.xml><?xml version="1.0" encoding="utf-8"?>
+<p:sld xmlns:a="http://schemas.openxmlformats.org/drawingml/2006/main" xmlns:p="http://schemas.openxmlformats.org/presentationml/2006/main" xmlns:r="http://schemas.openxmlformats.org/officeDocument/2006/relationships">
+  <p:cSld>
+    <p:spTree>
+      <p:nvGrpSpPr>
+        <p:cNvPr id="1" name=""/>
+        <p:cNvGrpSpPr/>
+        <p:nvPr/>
+      </p:nvGrpSpPr>
+      <p:grpSpPr/>
+      <p:sp>
+        <p:nvSpPr>
+          <p:cNvPr id="2" name="Rectangle 1"/>
+          <p:cNvSpPr/>
+          <p:nvPr/>
+        </p:nvSpPr>
+        <p:spPr>
+          <a:xfrm>
+            <a:off x="0" y="0"/>
+            <a:ext cx="12191695" cy="6858000"/>
+          </a:xfrm>
+          <a:prstGeom prst="rect">
+            <a:avLst/>
+          </a:prstGeom>
+          <a:solidFill>
+            <a:srgbClr val="F2F4F0"/>
+          </a:solidFill>
+          <a:ln>
+            <a:noFill/>
+          </a:ln>
+          <a:effectLst/>
+        </p:spPr>
+        <p:style>
+          <a:lnRef idx="1">
+            <a:schemeClr val="accent1"/>
+          </a:lnRef>
+          <a:fillRef idx="3">
+            <a:schemeClr val="accent1"/>
+          </a:fillRef>
+          <a:effectRef idx="2">
+            <a:schemeClr val="accent1"/>
+          </a:effectRef>
+          <a:fontRef idx="minor">
+            <a:schemeClr val="lt1"/>
+          </a:fontRef>
+        </p:style>
+        <p:txBody>
+          <a:bodyPr rtlCol="0" anchor="ctr"/>
+          <a:lstStyle/>
+          <a:p>
+            <a:pPr algn="ctr"/>
+          </a:p>
+        </p:txBody>
+      </p:sp>
+      <p:sp>
+        <p:nvSpPr>
+          <p:cNvPr id="3" name="Rounded Rectangle 2"/>
+          <p:cNvSpPr/>
+          <p:nvPr/>
+        </p:nvSpPr>
+        <p:spPr>
+          <a:xfrm>
+            <a:off x="640080" y="502920"/>
+            <a:ext cx="2377440" cy="384048"/>
+          </a:xfrm>
+          <a:prstGeom prst="roundRect">
+            <a:avLst>
+              <a:gd name="adj" fmla="val 50000"/>
+            </a:avLst>
+          </a:prstGeom>
+          <a:solidFill>
+            <a:srgbClr val="D7EBE7"/>
+          </a:solidFill>
+          <a:ln>
+            <a:noFill/>
+          </a:ln>
+          <a:effectLst/>
+        </p:spPr>
+        <p:style>
+          <a:lnRef idx="1">
+            <a:schemeClr val="accent1"/>
+          </a:lnRef>
+          <a:fillRef idx="3">
+            <a:schemeClr val="accent1"/>
+          </a:fillRef>
+          <a:effectRef idx="2">
+            <a:schemeClr val="accent1"/>
+          </a:effectRef>
+          <a:fontRef idx="minor">
+            <a:schemeClr val="lt1"/>
+          </a:fontRef>
+        </p:style>
+        <p:txBody>
+          <a:bodyPr rtlCol="0" anchor="ctr" wrap="none"/>
+          <a:lstStyle/>
+          <a:p>
+            <a:pPr algn="ctr"/>
+            <a:r>
+              <a:rPr sz="1200" b="1">
+                <a:solidFill>
+                  <a:srgbClr val="146B62"/>
+                </a:solidFill>
+                <a:latin typeface="Calibri"/>
+              </a:rPr>
+              <a:t>09  FINDINGS</a:t>
+            </a:r>
+          </a:p>
+        </p:txBody>
+      </p:sp>
+      <p:sp>
+        <p:nvSpPr>
+          <p:cNvPr id="4" name="TextBox 3"/>
+          <p:cNvSpPr txBox="1"/>
+          <p:nvPr/>
+        </p:nvSpPr>
+        <p:spPr>
+          <a:xfrm>
+            <a:off x="640080" y="1051560"/>
+            <a:ext cx="10515600" cy="822960"/>
+          </a:xfrm>
+          <a:prstGeom prst="rect">
+            <a:avLst/>
+          </a:prstGeom>
+          <a:noFill/>
+        </p:spPr>
+        <p:txBody>
+          <a:bodyPr wrap="square" anchor="t">
+            <a:spAutoFit/>
+          </a:bodyPr>
+          <a:lstStyle/>
+          <a:p>
+            <a:pPr algn="l">
+              <a:lnSpc>
+                <a:spcPct val="115000"/>
+              </a:lnSpc>
+            </a:pPr>
+            <a:r>
+              <a:rPr sz="3200" b="1" i="0">
+                <a:solidFill>
+                  <a:srgbClr val="172420"/>
+                </a:solidFill>
+                <a:latin typeface="Arial Black"/>
+              </a:rPr>
+              <a:t>What we learned — including what didn't work</a:t>
+            </a:r>
+          </a:p>
+        </p:txBody>
+      </p:sp>
+      <p:sp>
+        <p:nvSpPr>
+          <p:cNvPr id="5" name="Rounded Rectangle 4"/>
+          <p:cNvSpPr/>
+          <p:nvPr/>
+        </p:nvSpPr>
+        <p:spPr>
+          <a:xfrm>
+            <a:off x="640080" y="1965960"/>
+            <a:ext cx="10881360" cy="1005840"/>
+          </a:xfrm>
+          <a:prstGeom prst="roundRect">
+            <a:avLst>
+              <a:gd name="adj" fmla="val 5000"/>
+            </a:avLst>
+          </a:prstGeom>
+          <a:solidFill>
+            <a:srgbClr val="FFFFFF"/>
+          </a:solidFill>
+          <a:ln w="12700">
+            <a:solidFill>
+              <a:srgbClr val="CFD6CB"/>
+            </a:solidFill>
+          </a:ln>
+          <a:effectLst/>
+        </p:spPr>
+        <p:style>
+          <a:lnRef idx="1">
+            <a:schemeClr val="accent1"/>
+          </a:lnRef>
+          <a:fillRef idx="3">
+            <a:schemeClr val="accent1"/>
+          </a:fillRef>
+          <a:effectRef idx="2">
+            <a:schemeClr val="accent1"/>
+          </a:effectRef>
+          <a:fontRef idx="minor">
+            <a:schemeClr val="lt1"/>
+          </a:fontRef>
+        </p:style>
+        <p:txBody>
+          <a:bodyPr rtlCol="0" anchor="ctr"/>
+          <a:lstStyle/>
+          <a:p>
+            <a:pPr algn="ctr"/>
+          </a:p>
+        </p:txBody>
+      </p:sp>
+      <p:sp>
+        <p:nvSpPr>
+          <p:cNvPr id="6" name="TextBox 5"/>
+          <p:cNvSpPr txBox="1"/>
+          <p:nvPr/>
+        </p:nvSpPr>
+        <p:spPr>
+          <a:xfrm>
+            <a:off x="914400" y="2103120"/>
+            <a:ext cx="548640" cy="457200"/>
+          </a:xfrm>
+          <a:prstGeom prst="rect">
+            <a:avLst/>
+          </a:prstGeom>
+          <a:noFill/>
+        </p:spPr>
+        <p:txBody>
+          <a:bodyPr wrap="square" anchor="t">
+            <a:spAutoFit/>
+          </a:bodyPr>
+          <a:lstStyle/>
+          <a:p>
+            <a:pPr algn="l">
+              <a:lnSpc>
+                <a:spcPct val="115000"/>
+              </a:lnSpc>
+            </a:pPr>
+            <a:r>
+              <a:rPr sz="2200" b="1" i="0">
+                <a:solidFill>
+                  <a:srgbClr val="146B62"/>
+                </a:solidFill>
+                <a:latin typeface="Arial Black"/>
+              </a:rPr>
+              <a:t>1</a:t>
+            </a:r>
+          </a:p>
+        </p:txBody>
+      </p:sp>
+      <p:sp>
+        <p:nvSpPr>
+          <p:cNvPr id="7" name="TextBox 6"/>
+          <p:cNvSpPr txBox="1"/>
+          <p:nvPr/>
+        </p:nvSpPr>
+        <p:spPr>
+          <a:xfrm>
+            <a:off x="1554480" y="2103120"/>
+            <a:ext cx="9692640" cy="274320"/>
+          </a:xfrm>
+          <a:prstGeom prst="rect">
+            <a:avLst/>
+          </a:prstGeom>
+          <a:noFill/>
+        </p:spPr>
+        <p:txBody>
+          <a:bodyPr wrap="square" anchor="t">
+            <a:spAutoFit/>
+          </a:bodyPr>
+          <a:lstStyle/>
+          <a:p>
+            <a:pPr algn="l">
+              <a:lnSpc>
+                <a:spcPct val="115000"/>
+              </a:lnSpc>
+            </a:pPr>
+            <a:r>
+              <a:rPr sz="1400" b="1" i="0">
+                <a:solidFill>
+                  <a:srgbClr val="172420"/>
+                </a:solidFill>
+                <a:latin typeface="Calibri"/>
+              </a:rPr>
+              <a:t>Binary detection on FLNET2023 is too easy</a:t>
+            </a:r>
+          </a:p>
+        </p:txBody>
+      </p:sp>
+      <p:sp>
+        <p:nvSpPr>
+          <p:cNvPr id="8" name="TextBox 7"/>
+          <p:cNvSpPr txBox="1"/>
+          <p:nvPr/>
+        </p:nvSpPr>
+        <p:spPr>
+          <a:xfrm>
+            <a:off x="1554480" y="2423160"/>
+            <a:ext cx="9692640" cy="777240"/>
+          </a:xfrm>
+          <a:prstGeom prst="rect">
+            <a:avLst/>
+          </a:prstGeom>
+          <a:noFill/>
+        </p:spPr>
+        <p:txBody>
+          <a:bodyPr wrap="square" anchor="t">
+            <a:spAutoFit/>
+          </a:bodyPr>
+          <a:lstStyle/>
+          <a:p>
+            <a:pPr algn="l">
+              <a:lnSpc>
+                <a:spcPct val="115000"/>
+              </a:lnSpc>
+            </a:pPr>
+            <a:r>
+              <a:rPr sz="1200" b="0" i="0">
+                <a:solidFill>
+                  <a:srgbClr val="56655D"/>
+                </a:solidFill>
+                <a:latin typeface="Calibri"/>
+              </a:rPr>
+              <a:t>One feature alone (forward packet count) scores 97.5%; a 3-level decision tree 99.99%. We checked the 100% instead of trusting it — and moved to multi-class detection.</a:t>
+            </a:r>
+          </a:p>
+        </p:txBody>
+      </p:sp>
+      <p:sp>
+        <p:nvSpPr>
+          <p:cNvPr id="9" name="Rounded Rectangle 8"/>
+          <p:cNvSpPr/>
+          <p:nvPr/>
+        </p:nvSpPr>
+        <p:spPr>
+          <a:xfrm>
+            <a:off x="640080" y="3108960"/>
+            <a:ext cx="10881360" cy="1005840"/>
+          </a:xfrm>
+          <a:prstGeom prst="roundRect">
+            <a:avLst>
+              <a:gd name="adj" fmla="val 5000"/>
+            </a:avLst>
+          </a:prstGeom>
+          <a:solidFill>
+            <a:srgbClr val="FFFFFF"/>
+          </a:solidFill>
+          <a:ln w="12700">
+            <a:solidFill>
+              <a:srgbClr val="CFD6CB"/>
+            </a:solidFill>
+          </a:ln>
+          <a:effectLst/>
+        </p:spPr>
+        <p:style>
+          <a:lnRef idx="1">
+            <a:schemeClr val="accent1"/>
+          </a:lnRef>
+          <a:fillRef idx="3">
+            <a:schemeClr val="accent1"/>
+          </a:fillRef>
+          <a:effectRef idx="2">
+            <a:schemeClr val="accent1"/>
+          </a:effectRef>
+          <a:fontRef idx="minor">
+            <a:schemeClr val="lt1"/>
+          </a:fontRef>
+        </p:style>
+        <p:txBody>
+          <a:bodyPr rtlCol="0" anchor="ctr"/>
+          <a:lstStyle/>
+          <a:p>
+            <a:pPr algn="ctr"/>
+          </a:p>
+        </p:txBody>
+      </p:sp>
+      <p:sp>
+        <p:nvSpPr>
+          <p:cNvPr id="10" name="TextBox 9"/>
+          <p:cNvSpPr txBox="1"/>
+          <p:nvPr/>
+        </p:nvSpPr>
+        <p:spPr>
+          <a:xfrm>
+            <a:off x="914400" y="3246120"/>
+            <a:ext cx="548640" cy="457200"/>
+          </a:xfrm>
+          <a:prstGeom prst="rect">
+            <a:avLst/>
+          </a:prstGeom>
+          <a:noFill/>
+        </p:spPr>
+        <p:txBody>
+          <a:bodyPr wrap="square" anchor="t">
+            <a:spAutoFit/>
+          </a:bodyPr>
+          <a:lstStyle/>
+          <a:p>
+            <a:pPr algn="l">
+              <a:lnSpc>
+                <a:spcPct val="115000"/>
+              </a:lnSpc>
+            </a:pPr>
+            <a:r>
+              <a:rPr sz="2200" b="1" i="0">
+                <a:solidFill>
+                  <a:srgbClr val="146B62"/>
+                </a:solidFill>
+                <a:latin typeface="Arial Black"/>
+              </a:rPr>
+              <a:t>2</a:t>
+            </a:r>
+          </a:p>
+        </p:txBody>
+      </p:sp>
+      <p:sp>
+        <p:nvSpPr>
+          <p:cNvPr id="11" name="TextBox 10"/>
+          <p:cNvSpPr txBox="1"/>
+          <p:nvPr/>
+        </p:nvSpPr>
+        <p:spPr>
+          <a:xfrm>
+            <a:off x="1554480" y="3246120"/>
+            <a:ext cx="9692640" cy="274320"/>
+          </a:xfrm>
+          <a:prstGeom prst="rect">
+            <a:avLst/>
+          </a:prstGeom>
+          <a:noFill/>
+        </p:spPr>
+        <p:txBody>
+          <a:bodyPr wrap="square" anchor="t">
+            <a:spAutoFit/>
+          </a:bodyPr>
+          <a:lstStyle/>
+          <a:p>
+            <a:pPr algn="l">
+              <a:lnSpc>
+                <a:spcPct val="115000"/>
+              </a:lnSpc>
+            </a:pPr>
+            <a:r>
+              <a:rPr sz="1400" b="1" i="0">
+                <a:solidFill>
+                  <a:srgbClr val="172420"/>
+                </a:solidFill>
+                <a:latin typeface="Calibri"/>
+              </a:rPr>
+              <a:t>The first protocol design flagged honest clients</a:t>
+            </a:r>
+          </a:p>
+        </p:txBody>
+      </p:sp>
+      <p:sp>
+        <p:nvSpPr>
+          <p:cNvPr id="12" name="TextBox 11"/>
+          <p:cNvSpPr txBox="1"/>
+          <p:nvPr/>
+        </p:nvSpPr>
+        <p:spPr>
+          <a:xfrm>
+            <a:off x="1554480" y="3566160"/>
+            <a:ext cx="9692640" cy="777240"/>
+          </a:xfrm>
+          <a:prstGeom prst="rect">
+            <a:avLst/>
+          </a:prstGeom>
+          <a:noFill/>
+        </p:spPr>
+        <p:txBody>
+          <a:bodyPr wrap="square" anchor="t">
+            <a:spAutoFit/>
+          </a:bodyPr>
+          <a:lstStyle/>
+          <a:p>
+            <a:pPr algn="l">
+              <a:lnSpc>
+                <a:spcPct val="115000"/>
+              </a:lnSpc>
+            </a:pPr>
+            <a:r>
+              <a:rPr sz="1200" b="0" i="0">
+                <a:solidFill>
+                  <a:srgbClr val="56655D"/>
+                </a:solidFill>
+                <a:latin typeface="Calibri"/>
+              </a:rPr>
+              <a:t>Once training converges, every update looks noisy: 65–96% of honest updates were flagged. Fixed by scoring each update relative to the other clients in the same round.</a:t>
+            </a:r>
+          </a:p>
+        </p:txBody>
+      </p:sp>
+      <p:sp>
+        <p:nvSpPr>
+          <p:cNvPr id="13" name="Rounded Rectangle 12"/>
+          <p:cNvSpPr/>
+          <p:nvPr/>
+        </p:nvSpPr>
+        <p:spPr>
+          <a:xfrm>
+            <a:off x="640080" y="4251960"/>
+            <a:ext cx="10881360" cy="1005840"/>
+          </a:xfrm>
+          <a:prstGeom prst="roundRect">
+            <a:avLst>
+              <a:gd name="adj" fmla="val 5000"/>
+            </a:avLst>
+          </a:prstGeom>
+          <a:solidFill>
+            <a:srgbClr val="FFFFFF"/>
+          </a:solidFill>
+          <a:ln w="12700">
+            <a:solidFill>
+              <a:srgbClr val="CFD6CB"/>
+            </a:solidFill>
+          </a:ln>
+          <a:effectLst/>
+        </p:spPr>
+        <p:style>
+          <a:lnRef idx="1">
+            <a:schemeClr val="accent1"/>
+          </a:lnRef>
+          <a:fillRef idx="3">
+            <a:schemeClr val="accent1"/>
+          </a:fillRef>
+          <a:effectRef idx="2">
+            <a:schemeClr val="accent1"/>
+          </a:effectRef>
+          <a:fontRef idx="minor">
+            <a:schemeClr val="lt1"/>
+          </a:fontRef>
+        </p:style>
+        <p:txBody>
+          <a:bodyPr rtlCol="0" anchor="ctr"/>
+          <a:lstStyle/>
+          <a:p>
+            <a:pPr algn="ctr"/>
+          </a:p>
+        </p:txBody>
+      </p:sp>
+      <p:sp>
+        <p:nvSpPr>
+          <p:cNvPr id="14" name="TextBox 13"/>
+          <p:cNvSpPr txBox="1"/>
+          <p:nvPr/>
+        </p:nvSpPr>
+        <p:spPr>
+          <a:xfrm>
+            <a:off x="914400" y="4389120"/>
+            <a:ext cx="548640" cy="457200"/>
+          </a:xfrm>
+          <a:prstGeom prst="rect">
+            <a:avLst/>
+          </a:prstGeom>
+          <a:noFill/>
+        </p:spPr>
+        <p:txBody>
+          <a:bodyPr wrap="square" anchor="t">
+            <a:spAutoFit/>
+          </a:bodyPr>
+          <a:lstStyle/>
+          <a:p>
+            <a:pPr algn="l">
+              <a:lnSpc>
+                <a:spcPct val="115000"/>
+              </a:lnSpc>
+            </a:pPr>
+            <a:r>
+              <a:rPr sz="2200" b="1" i="0">
+                <a:solidFill>
+                  <a:srgbClr val="146B62"/>
+                </a:solidFill>
+                <a:latin typeface="Arial Black"/>
+              </a:rPr>
+              <a:t>3</a:t>
+            </a:r>
+          </a:p>
+        </p:txBody>
+      </p:sp>
+      <p:sp>
+        <p:nvSpPr>
+          <p:cNvPr id="15" name="TextBox 14"/>
+          <p:cNvSpPr txBox="1"/>
+          <p:nvPr/>
+        </p:nvSpPr>
+        <p:spPr>
+          <a:xfrm>
+            <a:off x="1554480" y="4389120"/>
+            <a:ext cx="9692640" cy="274320"/>
+          </a:xfrm>
+          <a:prstGeom prst="rect">
+            <a:avLst/>
+          </a:prstGeom>
+          <a:noFill/>
+        </p:spPr>
+        <p:txBody>
+          <a:bodyPr wrap="square" anchor="t">
+            <a:spAutoFit/>
+          </a:bodyPr>
+          <a:lstStyle/>
+          <a:p>
+            <a:pPr algn="l">
+              <a:lnSpc>
+                <a:spcPct val="115000"/>
+              </a:lnSpc>
+            </a:pPr>
+            <a:r>
+              <a:rPr sz="1400" b="1" i="0">
+                <a:solidFill>
+                  <a:srgbClr val="172420"/>
+                </a:solidFill>
+                <a:latin typeface="Calibri"/>
+              </a:rPr>
+              <a:t>Mondrian thresholds did not significantly beat a global threshold</a:t>
+            </a:r>
+          </a:p>
+        </p:txBody>
+      </p:sp>
+      <p:sp>
+        <p:nvSpPr>
+          <p:cNvPr id="16" name="TextBox 15"/>
+          <p:cNvSpPr txBox="1"/>
+          <p:nvPr/>
+        </p:nvSpPr>
+        <p:spPr>
+          <a:xfrm>
+            <a:off x="1554480" y="4709160"/>
+            <a:ext cx="9692640" cy="777240"/>
+          </a:xfrm>
+          <a:prstGeom prst="rect">
+            <a:avLst/>
+          </a:prstGeom>
+          <a:noFill/>
+        </p:spPr>
+        <p:txBody>
+          <a:bodyPr wrap="square" anchor="t">
+            <a:spAutoFit/>
+          </a:bodyPr>
+          <a:lstStyle/>
+          <a:p>
+            <a:pPr algn="l">
+              <a:lnSpc>
+                <a:spcPct val="115000"/>
+              </a:lnSpc>
+            </a:pPr>
+            <a:r>
+              <a:rPr sz="1200" b="0" i="0">
+                <a:solidFill>
+                  <a:srgbClr val="56655D"/>
+                </a:solidFill>
+                <a:latin typeface="Calibri"/>
+              </a:rPr>
+              <a:t>Our research question, answered honestly: with 10 clients and 5 calibration rounds, each cluster has too little data for reliable thresholds.</a:t>
+            </a:r>
+          </a:p>
+        </p:txBody>
+      </p:sp>
+      <p:sp>
+        <p:nvSpPr>
+          <p:cNvPr id="17" name="Rounded Rectangle 16"/>
+          <p:cNvSpPr/>
+          <p:nvPr/>
+        </p:nvSpPr>
+        <p:spPr>
+          <a:xfrm>
+            <a:off x="640080" y="5394960"/>
+            <a:ext cx="10881360" cy="1005840"/>
+          </a:xfrm>
+          <a:prstGeom prst="roundRect">
+            <a:avLst>
+              <a:gd name="adj" fmla="val 5000"/>
+            </a:avLst>
+          </a:prstGeom>
+          <a:solidFill>
+            <a:srgbClr val="FFFFFF"/>
+          </a:solidFill>
+          <a:ln w="12700">
+            <a:solidFill>
+              <a:srgbClr val="CFD6CB"/>
+            </a:solidFill>
+          </a:ln>
+          <a:effectLst/>
+        </p:spPr>
+        <p:style>
+          <a:lnRef idx="1">
+            <a:schemeClr val="accent1"/>
+          </a:lnRef>
+          <a:fillRef idx="3">
+            <a:schemeClr val="accent1"/>
+          </a:fillRef>
+          <a:effectRef idx="2">
+            <a:schemeClr val="accent1"/>
+          </a:effectRef>
+          <a:fontRef idx="minor">
+            <a:schemeClr val="lt1"/>
+          </a:fontRef>
+        </p:style>
+        <p:txBody>
+          <a:bodyPr rtlCol="0" anchor="ctr"/>
+          <a:lstStyle/>
+          <a:p>
+            <a:pPr algn="ctr"/>
+          </a:p>
+        </p:txBody>
+      </p:sp>
+      <p:sp>
+        <p:nvSpPr>
+          <p:cNvPr id="18" name="TextBox 17"/>
+          <p:cNvSpPr txBox="1"/>
+          <p:nvPr/>
+        </p:nvSpPr>
+        <p:spPr>
+          <a:xfrm>
+            <a:off x="914400" y="5532120"/>
+            <a:ext cx="548640" cy="457200"/>
+          </a:xfrm>
+          <a:prstGeom prst="rect">
+            <a:avLst/>
+          </a:prstGeom>
+          <a:noFill/>
+        </p:spPr>
+        <p:txBody>
+          <a:bodyPr wrap="square" anchor="t">
+            <a:spAutoFit/>
+          </a:bodyPr>
+          <a:lstStyle/>
+          <a:p>
+            <a:pPr algn="l">
+              <a:lnSpc>
+                <a:spcPct val="115000"/>
+              </a:lnSpc>
+            </a:pPr>
+            <a:r>
+              <a:rPr sz="2200" b="1" i="0">
+                <a:solidFill>
+                  <a:srgbClr val="146B62"/>
+                </a:solidFill>
+                <a:latin typeface="Arial Black"/>
+              </a:rPr>
+              <a:t>4</a:t>
+            </a:r>
+          </a:p>
+        </p:txBody>
+      </p:sp>
+      <p:sp>
+        <p:nvSpPr>
+          <p:cNvPr id="19" name="TextBox 18"/>
+          <p:cNvSpPr txBox="1"/>
+          <p:nvPr/>
+        </p:nvSpPr>
+        <p:spPr>
+          <a:xfrm>
+            <a:off x="1554480" y="5532120"/>
+            <a:ext cx="9692640" cy="274320"/>
+          </a:xfrm>
+          <a:prstGeom prst="rect">
+            <a:avLst/>
+          </a:prstGeom>
+          <a:noFill/>
+        </p:spPr>
+        <p:txBody>
+          <a:bodyPr wrap="square" anchor="t">
+            <a:spAutoFit/>
+          </a:bodyPr>
+          <a:lstStyle/>
+          <a:p>
+            <a:pPr algn="l">
+              <a:lnSpc>
+                <a:spcPct val="115000"/>
+              </a:lnSpc>
+            </a:pPr>
+            <a:r>
+              <a:rPr sz="1400" b="1" i="0">
+                <a:solidFill>
+                  <a:srgbClr val="172420"/>
+                </a:solidFill>
+                <a:latin typeface="Calibri"/>
+              </a:rPr>
+              <a:t>A fixed weight cap is not a free fix</a:t>
+            </a:r>
+          </a:p>
+        </p:txBody>
+      </p:sp>
+      <p:sp>
+        <p:nvSpPr>
+          <p:cNvPr id="20" name="TextBox 19"/>
+          <p:cNvSpPr txBox="1"/>
+          <p:nvPr/>
+        </p:nvSpPr>
+        <p:spPr>
+          <a:xfrm>
+            <a:off x="1554480" y="5852160"/>
+            <a:ext cx="9692640" cy="777240"/>
+          </a:xfrm>
+          <a:prstGeom prst="rect">
+            <a:avLst/>
+          </a:prstGeom>
+          <a:noFill/>
+        </p:spPr>
+        <p:txBody>
+          <a:bodyPr wrap="square" anchor="t">
+            <a:spAutoFit/>
+          </a:bodyPr>
+          <a:lstStyle/>
+          <a:p>
+            <a:pPr algn="l">
+              <a:lnSpc>
+                <a:spcPct val="115000"/>
+              </a:lnSpc>
+            </a:pPr>
+            <a:r>
+              <a:rPr sz="1200" b="0" i="0">
+                <a:solidFill>
+                  <a:srgbClr val="56655D"/>
+                </a:solidFill>
+                <a:latin typeface="Calibri"/>
+              </a:rPr>
+              <a:t>Capping a large router stops it dominating when it attacks — but when it is honest, its lost weight partly goes to the attackers (one FLNET2023 seed: 97.3% → 83.8%).</a:t>
+            </a:r>
+          </a:p>
+        </p:txBody>
+      </p:sp>
+    </p:spTree>
+  </p:cSld>
+  <p:clrMapOvr>
+    <a:masterClrMapping/>
+  </p:clrMapOvr>
+</p:sld>
+</file>
+
 <file path=ppt/slides/slide2.xml><?xml version="1.0" encoding="utf-8"?>
 <p:sld xmlns:a="http://schemas.openxmlformats.org/drawingml/2006/main" xmlns:p="http://schemas.openxmlformats.org/presentationml/2006/main" xmlns:r="http://schemas.openxmlformats.org/officeDocument/2006/relationships">
   <p:cSld>
@@ -3697,7 +4515,7 @@
                 </a:solidFill>
                 <a:latin typeface="Calibri"/>
               </a:rPr>
-              <a:t>▪  Trained using Federated Learning: multiple simulated clients train one shared detector without ever sending raw traffic anywhere.</a:t>
+              <a:t>▪  Trained using Federated Learning: 10 routers train one shared detector without ever sending raw traffic anywhere.</a:t>
             </a:r>
           </a:p>
           <a:p>
@@ -3716,7 +4534,7 @@
                 </a:solidFill>
                 <a:latin typeface="Calibri"/>
               </a:rPr>
-              <a:t>▪  Extended with a custom communication protocol (in progress) for exchanging model updates — instead of plain HTTP/gRPC.</a:t>
+              <a:t>▪  Model updates travel over our own security-fused protocol — integrity tag + fingerprint — instead of plain HTTP/gRPC.</a:t>
             </a:r>
           </a:p>
         </p:txBody>
@@ -4072,7 +4890,7 @@
                 </a:solidFill>
                 <a:latin typeface="Calibri"/>
               </a:rPr>
-              <a:t>▪  Simulated 5 independent clients, each holding its own slice of network traffic data.</a:t>
+              <a:t>▪  Used FLNET2023: traffic captured at 10 real (emulated) routers — each router is one federated client with its own mix of attacks.</a:t>
             </a:r>
           </a:p>
           <a:p>
@@ -4091,7 +4909,7 @@
                 </a:solidFill>
                 <a:latin typeface="Calibri"/>
               </a:rPr>
-              <a:t>▪  Trained one shared detection model across all 5 using Federated Averaging (FedAvg).</a:t>
+              <a:t>▪  Trained one shared detection model across all 10 using Federated Averaging (FedAvg).</a:t>
             </a:r>
           </a:p>
           <a:p>
@@ -4110,7 +4928,7 @@
                 </a:solidFill>
                 <a:latin typeface="Calibri"/>
               </a:rPr>
-              <a:t>▪  Tested both similar-traffic clients (IID) and very different-traffic clients (non-IID) — mimicking real organizational diversity.</a:t>
+              <a:t>▪  Built and attacked our custom protocol: poisoned updates, tampered messages, backdoors — and repeated it on NSL-KDD.</a:t>
             </a:r>
           </a:p>
         </p:txBody>
@@ -4896,7 +5714,7 @@
                 </a:solidFill>
                 <a:latin typeface="Calibri"/>
               </a:rPr>
-              <a:t>NSL-KDD dataset</a:t>
+              <a:t>FLNET2023 + NSL-KDD</a:t>
             </a:r>
           </a:p>
         </p:txBody>
@@ -4935,7 +5753,7 @@
                 </a:solidFill>
                 <a:latin typeface="Calibri"/>
               </a:rPr>
-              <a:t>Benchmark network-traffic records</a:t>
+              <a:t>Router flow captures + classic benchmark</a:t>
             </a:r>
           </a:p>
         </p:txBody>
@@ -5343,7 +6161,7 @@
                 </a:solidFill>
                 <a:latin typeface="Calibri"/>
               </a:rPr>
-              <a:t>Preprocess NSL-KDD: encode protocol/service/flag, scale numeric features</a:t>
+              <a:t>Preprocess FLNET2023: 66 flow features, drop IP/port/time identifiers</a:t>
             </a:r>
           </a:p>
         </p:txBody>
@@ -5469,7 +6287,7 @@
                 </a:solidFill>
                 <a:latin typeface="Calibri"/>
               </a:rPr>
-              <a:t>Split data across 5 simulated clients (IID and non-IID)</a:t>
+              <a:t>One client per router — real non-IID data (19%–92% attack per router)</a:t>
             </a:r>
           </a:p>
         </p:txBody>
@@ -5721,7 +6539,7 @@
                 </a:solidFill>
                 <a:latin typeface="Calibri"/>
               </a:rPr>
-              <a:t>Run FedAvg: local training → weighted averaging → repeat</a:t>
+              <a:t>Run FedAvg over the Krypsis protocol: train → verify → filter → average</a:t>
             </a:r>
           </a:p>
         </p:txBody>
@@ -5850,7 +6668,7 @@
                 </a:solidFill>
                 <a:latin typeface="Calibri"/>
               </a:rPr>
-              <a:t>▪  Server sends the current shared model to all 5 clients.</a:t>
+              <a:t>▪  Server sends the current shared model to all 10 router clients.</a:t>
             </a:r>
           </a:p>
           <a:p>
@@ -5888,7 +6706,7 @@
                 </a:solidFill>
                 <a:latin typeface="Calibri"/>
               </a:rPr>
-              <a:t>▪  Clients send back only the updated numbers (weights), never raw traffic.</a:t>
+              <a:t>▪  Clients send back only the updated weights, never raw traffic — wrapped in a Krypsis message (tag + fingerprint).</a:t>
             </a:r>
           </a:p>
           <a:p>
@@ -5907,7 +6725,7 @@
                 </a:solidFill>
                 <a:latin typeface="Calibri"/>
               </a:rPr>
-              <a:t>▪  Server combines everyone's weights into one improved model, weighted by how much data each client had.</a:t>
+              <a:t>▪  Server verifies each message, filters suspicious ones, then combines the rest weighted by data size (capped per client).</a:t>
             </a:r>
           </a:p>
           <a:p>
@@ -6169,7 +6987,7 @@
                 </a:solidFill>
                 <a:latin typeface="Arial Black"/>
               </a:rPr>
-              <a:t>83.3%</a:t>
+              <a:t>100.0%</a:t>
             </a:r>
           </a:p>
         </p:txBody>
@@ -6208,7 +7026,7 @@
                 </a:solidFill>
                 <a:latin typeface="Calibri"/>
               </a:rPr>
-              <a:t>Centralized baseline accuracy</a:t>
+              <a:t>Centralized accuracy (FLNET2023)</a:t>
             </a:r>
           </a:p>
         </p:txBody>
@@ -6295,7 +7113,7 @@
                 </a:solidFill>
                 <a:latin typeface="Arial Black"/>
               </a:rPr>
-              <a:t>80.2%</a:t>
+              <a:t>99.93%</a:t>
             </a:r>
           </a:p>
         </p:txBody>
@@ -6334,7 +7152,7 @@
                 </a:solidFill>
                 <a:latin typeface="Calibri"/>
               </a:rPr>
-              <a:t>Federated accuracy, IID clients</a:t>
+              <a:t>FedAvg, 10 real router clients</a:t>
             </a:r>
           </a:p>
         </p:txBody>
@@ -6421,7 +7239,7 @@
                 </a:solidFill>
                 <a:latin typeface="Arial Black"/>
               </a:rPr>
-              <a:t>79.1%</a:t>
+              <a:t>99.999%</a:t>
             </a:r>
           </a:p>
         </p:txBody>
@@ -6460,7 +7278,7 @@
                 </a:solidFill>
                 <a:latin typeface="Calibri"/>
               </a:rPr>
-              <a:t>Federated accuracy, non-IID clients</a:t>
+              <a:t>FedAvg, IID control split</a:t>
             </a:r>
           </a:p>
         </p:txBody>
@@ -6547,7 +7365,7 @@
                 </a:solidFill>
                 <a:latin typeface="Arial Black"/>
               </a:rPr>
-              <a:t>99.0%</a:t>
+              <a:t>105/105</a:t>
             </a:r>
           </a:p>
         </p:txBody>
@@ -6586,7 +7404,7 @@
                 </a:solidFill>
                 <a:latin typeface="Calibri"/>
               </a:rPr>
-              <a:t>In-distribution diagnostic</a:t>
+              <a:t>Tampered messages rejected</a:t>
             </a:r>
           </a:p>
         </p:txBody>
@@ -6673,7 +7491,7 @@
                 </a:solidFill>
                 <a:latin typeface="Calibri"/>
               </a:rPr>
-              <a:t>Phase 1-2 — Environment &amp; dataset setup</a:t>
+              <a:t>Dataset switch: NSL-KDD → FLNET2023 (real router clients)</a:t>
             </a:r>
           </a:p>
         </p:txBody>
@@ -6751,7 +7569,7 @@
                 </a:solidFill>
                 <a:latin typeface="Calibri"/>
               </a:rPr>
-              <a:t>Phase 3 — Preprocessing</a:t>
+              <a:t>Preprocessing, router split, MLP, FedAvg</a:t>
             </a:r>
           </a:p>
         </p:txBody>
@@ -6829,7 +7647,7 @@
                 </a:solidFill>
                 <a:latin typeface="Calibri"/>
               </a:rPr>
-              <a:t>Phase 4 — Client simulation (IID + non-IID)</a:t>
+              <a:t>Custom protocol: HMAC tag + fingerprint + anomaly filter</a:t>
             </a:r>
           </a:p>
         </p:txBody>
@@ -6907,7 +7725,7 @@
                 </a:solidFill>
                 <a:latin typeface="Calibri"/>
               </a:rPr>
-              <a:t>Phase 5 — Model design &amp; tuning</a:t>
+              <a:t>Global vs. Mondrian thresholds (research question)</a:t>
             </a:r>
           </a:p>
         </p:txBody>
@@ -6946,7 +7764,7 @@
                 </a:solidFill>
                 <a:latin typeface="Calibri"/>
               </a:rPr>
-              <a:t>Complete</a:t>
+              <a:t>Answered</a:t>
             </a:r>
           </a:p>
         </p:txBody>
@@ -6985,7 +7803,7 @@
                 </a:solidFill>
                 <a:latin typeface="Calibri"/>
               </a:rPr>
-              <a:t>Phase 6 — Federated training loop (FedAvg)</a:t>
+              <a:t>Weight cap + second check, backdoor attack, NSL-KDD replication</a:t>
             </a:r>
           </a:p>
         </p:txBody>
@@ -7063,7 +7881,7 @@
                 </a:solidFill>
                 <a:latin typeface="Calibri"/>
               </a:rPr>
-              <a:t>Phase 7 — Custom security-fused protocol</a:t>
+              <a:t>Multi-class detection (11 traffic types)</a:t>
             </a:r>
           </a:p>
         </p:txBody>
@@ -7219,7 +8037,7 @@
                 </a:solidFill>
                 <a:latin typeface="Calibri"/>
               </a:rPr>
-              <a:t>06  LEARNING</a:t>
+              <a:t>06  THE KRYPSIS PROTOCOL</a:t>
             </a:r>
           </a:p>
         </p:txBody>
@@ -7258,60 +8076,273 @@
                 </a:solidFill>
                 <a:latin typeface="Arial Black"/>
               </a:rPr>
-              <a:t>How this connects to our syllabus</a:t>
-            </a:r>
-          </a:p>
-        </p:txBody>
-      </p:sp>
-      <p:sp>
-        <p:nvSpPr>
-          <p:cNvPr id="5" name="TextBox 4"/>
-          <p:cNvSpPr txBox="1"/>
-          <p:nvPr/>
-        </p:nvSpPr>
-        <p:spPr>
-          <a:xfrm>
-            <a:off x="640080" y="1783080"/>
-            <a:ext cx="10698480" cy="457200"/>
-          </a:xfrm>
-          <a:prstGeom prst="rect">
-            <a:avLst/>
-          </a:prstGeom>
-          <a:noFill/>
-        </p:spPr>
-        <p:txBody>
-          <a:bodyPr wrap="square" anchor="t">
-            <a:spAutoFit/>
-          </a:bodyPr>
-          <a:lstStyle/>
-          <a:p>
-            <a:pPr algn="l">
-              <a:lnSpc>
-                <a:spcPct val="115000"/>
-              </a:lnSpc>
-            </a:pPr>
-            <a:r>
-              <a:rPr sz="1300" b="0" i="1">
-                <a:solidFill>
-                  <a:srgbClr val="56655D"/>
-                </a:solidFill>
-                <a:latin typeface="Calibri"/>
-              </a:rPr>
-              <a:t>Every unit of this course shows up somewhere in this project — intrusion detection is fundamentally a networking problem.</a:t>
-            </a:r>
-          </a:p>
-        </p:txBody>
-      </p:sp>
-      <p:sp>
-        <p:nvSpPr>
-          <p:cNvPr id="6" name="Rounded Rectangle 5"/>
+              <a:t>What one update message looks like</a:t>
+            </a:r>
+          </a:p>
+        </p:txBody>
+      </p:sp>
+      <p:sp>
+        <p:nvSpPr>
+          <p:cNvPr id="5" name="Rounded Rectangle 4"/>
           <p:cNvSpPr/>
           <p:nvPr/>
         </p:nvSpPr>
         <p:spPr>
           <a:xfrm>
-            <a:off x="640080" y="2423160"/>
-            <a:ext cx="10881360" cy="1280160"/>
+            <a:off x="640080" y="2011680"/>
+            <a:ext cx="914400" cy="1051560"/>
+          </a:xfrm>
+          <a:prstGeom prst="roundRect">
+            <a:avLst>
+              <a:gd name="adj" fmla="val 5000"/>
+            </a:avLst>
+          </a:prstGeom>
+          <a:solidFill>
+            <a:srgbClr val="E7EBE4"/>
+          </a:solidFill>
+          <a:ln w="12700">
+            <a:solidFill>
+              <a:srgbClr val="CFD6CB"/>
+            </a:solidFill>
+          </a:ln>
+          <a:effectLst/>
+        </p:spPr>
+        <p:style>
+          <a:lnRef idx="1">
+            <a:schemeClr val="accent1"/>
+          </a:lnRef>
+          <a:fillRef idx="3">
+            <a:schemeClr val="accent1"/>
+          </a:fillRef>
+          <a:effectRef idx="2">
+            <a:schemeClr val="accent1"/>
+          </a:effectRef>
+          <a:fontRef idx="minor">
+            <a:schemeClr val="lt1"/>
+          </a:fontRef>
+        </p:style>
+        <p:txBody>
+          <a:bodyPr rtlCol="0" anchor="ctr"/>
+          <a:lstStyle/>
+          <a:p>
+            <a:pPr algn="ctr"/>
+          </a:p>
+        </p:txBody>
+      </p:sp>
+      <p:sp>
+        <p:nvSpPr>
+          <p:cNvPr id="6" name="TextBox 5"/>
+          <p:cNvSpPr txBox="1"/>
+          <p:nvPr/>
+        </p:nvSpPr>
+        <p:spPr>
+          <a:xfrm>
+            <a:off x="749808" y="2103120"/>
+            <a:ext cx="694944" cy="320040"/>
+          </a:xfrm>
+          <a:prstGeom prst="rect">
+            <a:avLst/>
+          </a:prstGeom>
+          <a:noFill/>
+        </p:spPr>
+        <p:txBody>
+          <a:bodyPr wrap="square" anchor="t">
+            <a:spAutoFit/>
+          </a:bodyPr>
+          <a:lstStyle/>
+          <a:p>
+            <a:pPr algn="l">
+              <a:lnSpc>
+                <a:spcPct val="115000"/>
+              </a:lnSpc>
+            </a:pPr>
+            <a:r>
+              <a:rPr sz="1100" b="1" i="0">
+                <a:solidFill>
+                  <a:srgbClr val="146B62"/>
+                </a:solidFill>
+                <a:latin typeface="Calibri"/>
+              </a:rPr>
+              <a:t>LENGTH</a:t>
+            </a:r>
+          </a:p>
+        </p:txBody>
+      </p:sp>
+      <p:sp>
+        <p:nvSpPr>
+          <p:cNvPr id="7" name="TextBox 6"/>
+          <p:cNvSpPr txBox="1"/>
+          <p:nvPr/>
+        </p:nvSpPr>
+        <p:spPr>
+          <a:xfrm>
+            <a:off x="749808" y="2450592"/>
+            <a:ext cx="694944" cy="548640"/>
+          </a:xfrm>
+          <a:prstGeom prst="rect">
+            <a:avLst/>
+          </a:prstGeom>
+          <a:noFill/>
+        </p:spPr>
+        <p:txBody>
+          <a:bodyPr wrap="square" anchor="t">
+            <a:spAutoFit/>
+          </a:bodyPr>
+          <a:lstStyle/>
+          <a:p>
+            <a:pPr algn="l">
+              <a:lnSpc>
+                <a:spcPct val="115000"/>
+              </a:lnSpc>
+            </a:pPr>
+            <a:r>
+              <a:rPr sz="1100" b="0" i="0">
+                <a:solidFill>
+                  <a:srgbClr val="172420"/>
+                </a:solidFill>
+                <a:latin typeface="Calibri"/>
+              </a:rPr>
+              <a:t>4 B</a:t>
+            </a:r>
+          </a:p>
+        </p:txBody>
+      </p:sp>
+      <p:sp>
+        <p:nvSpPr>
+          <p:cNvPr id="8" name="Rounded Rectangle 7"/>
+          <p:cNvSpPr/>
+          <p:nvPr/>
+        </p:nvSpPr>
+        <p:spPr>
+          <a:xfrm>
+            <a:off x="1554480" y="2011680"/>
+            <a:ext cx="3291840" cy="1051560"/>
+          </a:xfrm>
+          <a:prstGeom prst="roundRect">
+            <a:avLst>
+              <a:gd name="adj" fmla="val 5000"/>
+            </a:avLst>
+          </a:prstGeom>
+          <a:solidFill>
+            <a:srgbClr val="D7EBE7"/>
+          </a:solidFill>
+          <a:ln w="12700">
+            <a:solidFill>
+              <a:srgbClr val="CFD6CB"/>
+            </a:solidFill>
+          </a:ln>
+          <a:effectLst/>
+        </p:spPr>
+        <p:style>
+          <a:lnRef idx="1">
+            <a:schemeClr val="accent1"/>
+          </a:lnRef>
+          <a:fillRef idx="3">
+            <a:schemeClr val="accent1"/>
+          </a:fillRef>
+          <a:effectRef idx="2">
+            <a:schemeClr val="accent1"/>
+          </a:effectRef>
+          <a:fontRef idx="minor">
+            <a:schemeClr val="lt1"/>
+          </a:fontRef>
+        </p:style>
+        <p:txBody>
+          <a:bodyPr rtlCol="0" anchor="ctr"/>
+          <a:lstStyle/>
+          <a:p>
+            <a:pPr algn="ctr"/>
+          </a:p>
+        </p:txBody>
+      </p:sp>
+      <p:sp>
+        <p:nvSpPr>
+          <p:cNvPr id="9" name="TextBox 8"/>
+          <p:cNvSpPr txBox="1"/>
+          <p:nvPr/>
+        </p:nvSpPr>
+        <p:spPr>
+          <a:xfrm>
+            <a:off x="1664208" y="2103120"/>
+            <a:ext cx="3072384" cy="320040"/>
+          </a:xfrm>
+          <a:prstGeom prst="rect">
+            <a:avLst/>
+          </a:prstGeom>
+          <a:noFill/>
+        </p:spPr>
+        <p:txBody>
+          <a:bodyPr wrap="square" anchor="t">
+            <a:spAutoFit/>
+          </a:bodyPr>
+          <a:lstStyle/>
+          <a:p>
+            <a:pPr algn="l">
+              <a:lnSpc>
+                <a:spcPct val="115000"/>
+              </a:lnSpc>
+            </a:pPr>
+            <a:r>
+              <a:rPr sz="1100" b="1" i="0">
+                <a:solidFill>
+                  <a:srgbClr val="146B62"/>
+                </a:solidFill>
+                <a:latin typeface="Calibri"/>
+              </a:rPr>
+              <a:t>HEADER + FINGERPRINT</a:t>
+            </a:r>
+          </a:p>
+        </p:txBody>
+      </p:sp>
+      <p:sp>
+        <p:nvSpPr>
+          <p:cNvPr id="10" name="TextBox 9"/>
+          <p:cNvSpPr txBox="1"/>
+          <p:nvPr/>
+        </p:nvSpPr>
+        <p:spPr>
+          <a:xfrm>
+            <a:off x="1664208" y="2450592"/>
+            <a:ext cx="3072384" cy="548640"/>
+          </a:xfrm>
+          <a:prstGeom prst="rect">
+            <a:avLst/>
+          </a:prstGeom>
+          <a:noFill/>
+        </p:spPr>
+        <p:txBody>
+          <a:bodyPr wrap="square" anchor="t">
+            <a:spAutoFit/>
+          </a:bodyPr>
+          <a:lstStyle/>
+          <a:p>
+            <a:pPr algn="l">
+              <a:lnSpc>
+                <a:spcPct val="115000"/>
+              </a:lnSpc>
+            </a:pPr>
+            <a:r>
+              <a:rPr sz="1100" b="0" i="0">
+                <a:solidFill>
+                  <a:srgbClr val="172420"/>
+                </a:solidFill>
+                <a:latin typeface="Calibri"/>
+              </a:rPr>
+              <a:t>client, round, L2 norms, 64-number sketch</a:t>
+            </a:r>
+          </a:p>
+        </p:txBody>
+      </p:sp>
+      <p:sp>
+        <p:nvSpPr>
+          <p:cNvPr id="11" name="Rounded Rectangle 10"/>
+          <p:cNvSpPr/>
+          <p:nvPr/>
+        </p:nvSpPr>
+        <p:spPr>
+          <a:xfrm>
+            <a:off x="4846320" y="2011680"/>
+            <a:ext cx="4937760" cy="1051560"/>
           </a:xfrm>
           <a:prstGeom prst="roundRect">
             <a:avLst>
@@ -7352,23 +8383,105 @@
       </p:sp>
       <p:sp>
         <p:nvSpPr>
-          <p:cNvPr id="7" name="Rectangle 6"/>
+          <p:cNvPr id="12" name="TextBox 11"/>
+          <p:cNvSpPr txBox="1"/>
+          <p:nvPr/>
+        </p:nvSpPr>
+        <p:spPr>
+          <a:xfrm>
+            <a:off x="4956048" y="2103120"/>
+            <a:ext cx="4718304" cy="320040"/>
+          </a:xfrm>
+          <a:prstGeom prst="rect">
+            <a:avLst/>
+          </a:prstGeom>
+          <a:noFill/>
+        </p:spPr>
+        <p:txBody>
+          <a:bodyPr wrap="square" anchor="t">
+            <a:spAutoFit/>
+          </a:bodyPr>
+          <a:lstStyle/>
+          <a:p>
+            <a:pPr algn="l">
+              <a:lnSpc>
+                <a:spcPct val="115000"/>
+              </a:lnSpc>
+            </a:pPr>
+            <a:r>
+              <a:rPr sz="1100" b="1" i="0">
+                <a:solidFill>
+                  <a:srgbClr val="146B62"/>
+                </a:solidFill>
+                <a:latin typeface="Calibri"/>
+              </a:rPr>
+              <a:t>PAYLOAD</a:t>
+            </a:r>
+          </a:p>
+        </p:txBody>
+      </p:sp>
+      <p:sp>
+        <p:nvSpPr>
+          <p:cNvPr id="13" name="TextBox 12"/>
+          <p:cNvSpPr txBox="1"/>
+          <p:nvPr/>
+        </p:nvSpPr>
+        <p:spPr>
+          <a:xfrm>
+            <a:off x="4956048" y="2450592"/>
+            <a:ext cx="4718304" cy="548640"/>
+          </a:xfrm>
+          <a:prstGeom prst="rect">
+            <a:avLst/>
+          </a:prstGeom>
+          <a:noFill/>
+        </p:spPr>
+        <p:txBody>
+          <a:bodyPr wrap="square" anchor="t">
+            <a:spAutoFit/>
+          </a:bodyPr>
+          <a:lstStyle/>
+          <a:p>
+            <a:pPr algn="l">
+              <a:lnSpc>
+                <a:spcPct val="115000"/>
+              </a:lnSpc>
+            </a:pPr>
+            <a:r>
+              <a:rPr sz="1100" b="0" i="0">
+                <a:solidFill>
+                  <a:srgbClr val="172420"/>
+                </a:solidFill>
+                <a:latin typeface="Calibri"/>
+              </a:rPr>
+              <a:t>model update, 233,476 B</a:t>
+            </a:r>
+          </a:p>
+        </p:txBody>
+      </p:sp>
+      <p:sp>
+        <p:nvSpPr>
+          <p:cNvPr id="14" name="Rounded Rectangle 13"/>
           <p:cNvSpPr/>
           <p:nvPr/>
         </p:nvSpPr>
         <p:spPr>
           <a:xfrm>
-            <a:off x="640080" y="2423160"/>
-            <a:ext cx="73152" cy="1280160"/>
-          </a:xfrm>
-          <a:prstGeom prst="rect">
-            <a:avLst/>
+            <a:off x="9784080" y="2011680"/>
+            <a:ext cx="1737360" cy="1051560"/>
+          </a:xfrm>
+          <a:prstGeom prst="roundRect">
+            <a:avLst>
+              <a:gd name="adj" fmla="val 5000"/>
+            </a:avLst>
           </a:prstGeom>
           <a:solidFill>
-            <a:srgbClr val="146B62"/>
+            <a:srgbClr val="F5E2C8"/>
           </a:solidFill>
-          <a:ln>
-            <a:noFill/>
+          <a:ln w="12700">
+            <a:solidFill>
+              <a:srgbClr val="CFD6CB"/>
+            </a:solidFill>
           </a:ln>
           <a:effectLst/>
         </p:spPr>
@@ -7396,92 +8509,170 @@
       </p:sp>
       <p:sp>
         <p:nvSpPr>
-          <p:cNvPr id="8" name="TextBox 7"/>
-          <p:cNvSpPr txBox="1"/>
-          <p:nvPr/>
-        </p:nvSpPr>
-        <p:spPr>
-          <a:xfrm>
-            <a:off x="914400" y="2560320"/>
-            <a:ext cx="10332720" cy="274320"/>
-          </a:xfrm>
-          <a:prstGeom prst="rect">
-            <a:avLst/>
-          </a:prstGeom>
-          <a:noFill/>
-        </p:spPr>
-        <p:txBody>
-          <a:bodyPr wrap="square" anchor="t">
-            <a:spAutoFit/>
-          </a:bodyPr>
-          <a:lstStyle/>
-          <a:p>
-            <a:pPr algn="l">
-              <a:lnSpc>
-                <a:spcPct val="115000"/>
-              </a:lnSpc>
-            </a:pPr>
-            <a:r>
-              <a:rPr sz="1200" b="1" i="0">
+          <p:cNvPr id="15" name="TextBox 14"/>
+          <p:cNvSpPr txBox="1"/>
+          <p:nvPr/>
+        </p:nvSpPr>
+        <p:spPr>
+          <a:xfrm>
+            <a:off x="9893808" y="2103120"/>
+            <a:ext cx="1517904" cy="320040"/>
+          </a:xfrm>
+          <a:prstGeom prst="rect">
+            <a:avLst/>
+          </a:prstGeom>
+          <a:noFill/>
+        </p:spPr>
+        <p:txBody>
+          <a:bodyPr wrap="square" anchor="t">
+            <a:spAutoFit/>
+          </a:bodyPr>
+          <a:lstStyle/>
+          <a:p>
+            <a:pPr algn="l">
+              <a:lnSpc>
+                <a:spcPct val="115000"/>
+              </a:lnSpc>
+            </a:pPr>
+            <a:r>
+              <a:rPr sz="1100" b="1" i="0">
                 <a:solidFill>
                   <a:srgbClr val="146B62"/>
                 </a:solidFill>
                 <a:latin typeface="Calibri"/>
               </a:rPr>
-              <a:t>UNIT 1 — NETWORK EDGE, OSI LAYERS, PACKET SWITCHING</a:t>
-            </a:r>
-          </a:p>
-        </p:txBody>
-      </p:sp>
-      <p:sp>
-        <p:nvSpPr>
-          <p:cNvPr id="9" name="TextBox 8"/>
-          <p:cNvSpPr txBox="1"/>
-          <p:nvPr/>
-        </p:nvSpPr>
-        <p:spPr>
-          <a:xfrm>
-            <a:off x="914400" y="2880360"/>
-            <a:ext cx="10332720" cy="777240"/>
-          </a:xfrm>
-          <a:prstGeom prst="rect">
-            <a:avLst/>
-          </a:prstGeom>
-          <a:noFill/>
-        </p:spPr>
-        <p:txBody>
-          <a:bodyPr wrap="square" anchor="t">
-            <a:spAutoFit/>
-          </a:bodyPr>
-          <a:lstStyle/>
-          <a:p>
-            <a:pPr algn="l">
-              <a:lnSpc>
-                <a:spcPct val="115000"/>
-              </a:lnSpc>
-            </a:pPr>
-            <a:r>
-              <a:rPr sz="1250" b="0" i="0">
+              <a:t>TAG</a:t>
+            </a:r>
+          </a:p>
+        </p:txBody>
+      </p:sp>
+      <p:sp>
+        <p:nvSpPr>
+          <p:cNvPr id="16" name="TextBox 15"/>
+          <p:cNvSpPr txBox="1"/>
+          <p:nvPr/>
+        </p:nvSpPr>
+        <p:spPr>
+          <a:xfrm>
+            <a:off x="9893808" y="2450592"/>
+            <a:ext cx="1517904" cy="548640"/>
+          </a:xfrm>
+          <a:prstGeom prst="rect">
+            <a:avLst/>
+          </a:prstGeom>
+          <a:noFill/>
+        </p:spPr>
+        <p:txBody>
+          <a:bodyPr wrap="square" anchor="t">
+            <a:spAutoFit/>
+          </a:bodyPr>
+          <a:lstStyle/>
+          <a:p>
+            <a:pPr algn="l">
+              <a:lnSpc>
+                <a:spcPct val="115000"/>
+              </a:lnSpc>
+            </a:pPr>
+            <a:r>
+              <a:rPr sz="1100" b="0" i="0">
                 <a:solidFill>
                   <a:srgbClr val="172420"/>
                 </a:solidFill>
                 <a:latin typeface="Calibri"/>
               </a:rPr>
-              <a:t>Every NSL-KDD record is packet/flow-level data: protocol_type (Network layer), flag (Transport layer), service (Application layer). Our federated clients act as network edge nodes.</a:t>
-            </a:r>
-          </a:p>
-        </p:txBody>
-      </p:sp>
-      <p:sp>
-        <p:nvSpPr>
-          <p:cNvPr id="10" name="Rounded Rectangle 9"/>
+              <a:t>HMAC-SHA256, 32 B</a:t>
+            </a:r>
+          </a:p>
+        </p:txBody>
+      </p:sp>
+      <p:sp>
+        <p:nvSpPr>
+          <p:cNvPr id="17" name="TextBox 16"/>
+          <p:cNvSpPr txBox="1"/>
+          <p:nvPr/>
+        </p:nvSpPr>
+        <p:spPr>
+          <a:xfrm>
+            <a:off x="640080" y="3154680"/>
+            <a:ext cx="10881360" cy="365760"/>
+          </a:xfrm>
+          <a:prstGeom prst="rect">
+            <a:avLst/>
+          </a:prstGeom>
+          <a:noFill/>
+        </p:spPr>
+        <p:txBody>
+          <a:bodyPr wrap="square" anchor="t">
+            <a:spAutoFit/>
+          </a:bodyPr>
+          <a:lstStyle/>
+          <a:p>
+            <a:pPr algn="l">
+              <a:lnSpc>
+                <a:spcPct val="115000"/>
+              </a:lnSpc>
+            </a:pPr>
+            <a:r>
+              <a:rPr sz="1300" b="0" i="1">
+                <a:solidFill>
+                  <a:srgbClr val="56655D"/>
+                </a:solidFill>
+                <a:latin typeface="Calibri"/>
+              </a:rPr>
+              <a:t>Protocol overhead: +1,559 B (0.67%) per update — the same update as plain HTTP/JSON is 5.6x larger.</a:t>
+            </a:r>
+          </a:p>
+        </p:txBody>
+      </p:sp>
+      <p:sp>
+        <p:nvSpPr>
+          <p:cNvPr id="18" name="TextBox 17"/>
+          <p:cNvSpPr txBox="1"/>
+          <p:nvPr/>
+        </p:nvSpPr>
+        <p:spPr>
+          <a:xfrm>
+            <a:off x="640080" y="3657600"/>
+            <a:ext cx="5486400" cy="365760"/>
+          </a:xfrm>
+          <a:prstGeom prst="rect">
+            <a:avLst/>
+          </a:prstGeom>
+          <a:noFill/>
+        </p:spPr>
+        <p:txBody>
+          <a:bodyPr wrap="square" anchor="t">
+            <a:spAutoFit/>
+          </a:bodyPr>
+          <a:lstStyle/>
+          <a:p>
+            <a:pPr algn="l">
+              <a:lnSpc>
+                <a:spcPct val="115000"/>
+              </a:lnSpc>
+            </a:pPr>
+            <a:r>
+              <a:rPr sz="1400" b="1" i="0">
+                <a:solidFill>
+                  <a:srgbClr val="146B62"/>
+                </a:solidFill>
+                <a:latin typeface="Calibri"/>
+              </a:rPr>
+              <a:t>WHAT THE SERVER DOES, BEFORE AVERAGING</a:t>
+            </a:r>
+          </a:p>
+        </p:txBody>
+      </p:sp>
+      <p:sp>
+        <p:nvSpPr>
+          <p:cNvPr id="19" name="Rounded Rectangle 18"/>
           <p:cNvSpPr/>
           <p:nvPr/>
         </p:nvSpPr>
         <p:spPr>
           <a:xfrm>
-            <a:off x="640080" y="3886200"/>
-            <a:ext cx="10881360" cy="1280160"/>
+            <a:off x="640080" y="4069080"/>
+            <a:ext cx="10881360" cy="2377440"/>
           </a:xfrm>
           <a:prstGeom prst="roundRect">
             <a:avLst>
@@ -7522,292 +8713,118 @@
       </p:sp>
       <p:sp>
         <p:nvSpPr>
-          <p:cNvPr id="11" name="Rectangle 10"/>
-          <p:cNvSpPr/>
-          <p:nvPr/>
-        </p:nvSpPr>
-        <p:spPr>
-          <a:xfrm>
-            <a:off x="640080" y="3886200"/>
-            <a:ext cx="73152" cy="1280160"/>
-          </a:xfrm>
-          <a:prstGeom prst="rect">
-            <a:avLst/>
-          </a:prstGeom>
-          <a:solidFill>
-            <a:srgbClr val="146B62"/>
-          </a:solidFill>
-          <a:ln>
-            <a:noFill/>
-          </a:ln>
-          <a:effectLst/>
-        </p:spPr>
-        <p:style>
-          <a:lnRef idx="1">
-            <a:schemeClr val="accent1"/>
-          </a:lnRef>
-          <a:fillRef idx="3">
-            <a:schemeClr val="accent1"/>
-          </a:fillRef>
-          <a:effectRef idx="2">
-            <a:schemeClr val="accent1"/>
-          </a:effectRef>
-          <a:fontRef idx="minor">
-            <a:schemeClr val="lt1"/>
-          </a:fontRef>
-        </p:style>
-        <p:txBody>
-          <a:bodyPr rtlCol="0" anchor="ctr"/>
-          <a:lstStyle/>
-          <a:p>
-            <a:pPr algn="ctr"/>
-          </a:p>
-        </p:txBody>
-      </p:sp>
-      <p:sp>
-        <p:nvSpPr>
-          <p:cNvPr id="12" name="TextBox 11"/>
-          <p:cNvSpPr txBox="1"/>
-          <p:nvPr/>
-        </p:nvSpPr>
-        <p:spPr>
-          <a:xfrm>
-            <a:off x="914400" y="4023360"/>
-            <a:ext cx="10332720" cy="274320"/>
-          </a:xfrm>
-          <a:prstGeom prst="rect">
-            <a:avLst/>
-          </a:prstGeom>
-          <a:noFill/>
-        </p:spPr>
-        <p:txBody>
-          <a:bodyPr wrap="square" anchor="t">
-            <a:spAutoFit/>
-          </a:bodyPr>
-          <a:lstStyle/>
-          <a:p>
-            <a:pPr algn="l">
-              <a:lnSpc>
-                <a:spcPct val="115000"/>
-              </a:lnSpc>
-            </a:pPr>
-            <a:r>
-              <a:rPr sz="1200" b="1" i="0">
-                <a:solidFill>
-                  <a:srgbClr val="146B62"/>
-                </a:solidFill>
-                <a:latin typeface="Calibri"/>
-              </a:rPr>
-              <a:t>UNIT 2 — APPLICATION LAYER, TRANSPORT LAYER, SOCKETS, ROUTING</a:t>
-            </a:r>
-          </a:p>
-        </p:txBody>
-      </p:sp>
-      <p:sp>
-        <p:nvSpPr>
-          <p:cNvPr id="13" name="TextBox 12"/>
-          <p:cNvSpPr txBox="1"/>
-          <p:nvPr/>
-        </p:nvSpPr>
-        <p:spPr>
-          <a:xfrm>
-            <a:off x="914400" y="4343400"/>
-            <a:ext cx="10332720" cy="777240"/>
-          </a:xfrm>
-          <a:prstGeom prst="rect">
-            <a:avLst/>
-          </a:prstGeom>
-          <a:noFill/>
-        </p:spPr>
-        <p:txBody>
-          <a:bodyPr wrap="square" anchor="t">
-            <a:spAutoFit/>
-          </a:bodyPr>
-          <a:lstStyle/>
-          <a:p>
-            <a:pPr algn="l">
-              <a:lnSpc>
-                <a:spcPct val="115000"/>
-              </a:lnSpc>
-            </a:pPr>
-            <a:r>
-              <a:rPr sz="1250" b="0" i="0">
+          <p:cNvPr id="20" name="TextBox 19"/>
+          <p:cNvSpPr txBox="1"/>
+          <p:nvPr/>
+        </p:nvSpPr>
+        <p:spPr>
+          <a:xfrm>
+            <a:off x="914400" y="4206240"/>
+            <a:ext cx="10332720" cy="2194560"/>
+          </a:xfrm>
+          <a:prstGeom prst="rect">
+            <a:avLst/>
+          </a:prstGeom>
+          <a:noFill/>
+        </p:spPr>
+        <p:txBody>
+          <a:bodyPr wrap="square">
+            <a:spAutoFit/>
+          </a:bodyPr>
+          <a:lstStyle/>
+          <a:p>
+            <a:pPr>
+              <a:lnSpc>
+                <a:spcPct val="120000"/>
+              </a:lnSpc>
+              <a:spcAft>
+                <a:spcPts val="600"/>
+              </a:spcAft>
+            </a:pPr>
+            <a:r>
+              <a:rPr sz="1300">
                 <a:solidFill>
                   <a:srgbClr val="172420"/>
                 </a:solidFill>
                 <a:latin typeface="Calibri"/>
               </a:rPr>
-              <a:t>Our custom protocol design is application-layer protocol design (vs. HTTP/gRPC). Client-server exchange mirrors socket-based communication. dst_host_count ties to routing/host addressing.</a:t>
-            </a:r>
-          </a:p>
-        </p:txBody>
-      </p:sp>
-      <p:sp>
-        <p:nvSpPr>
-          <p:cNvPr id="14" name="Rounded Rectangle 13"/>
-          <p:cNvSpPr/>
-          <p:nvPr/>
-        </p:nvSpPr>
-        <p:spPr>
-          <a:xfrm>
-            <a:off x="640080" y="5349240"/>
-            <a:ext cx="10881360" cy="1280160"/>
-          </a:xfrm>
-          <a:prstGeom prst="roundRect">
-            <a:avLst>
-              <a:gd name="adj" fmla="val 5000"/>
-            </a:avLst>
-          </a:prstGeom>
-          <a:solidFill>
-            <a:srgbClr val="FFFFFF"/>
-          </a:solidFill>
-          <a:ln w="12700">
-            <a:solidFill>
-              <a:srgbClr val="CFD6CB"/>
-            </a:solidFill>
-          </a:ln>
-          <a:effectLst/>
-        </p:spPr>
-        <p:style>
-          <a:lnRef idx="1">
-            <a:schemeClr val="accent1"/>
-          </a:lnRef>
-          <a:fillRef idx="3">
-            <a:schemeClr val="accent1"/>
-          </a:fillRef>
-          <a:effectRef idx="2">
-            <a:schemeClr val="accent1"/>
-          </a:effectRef>
-          <a:fontRef idx="minor">
-            <a:schemeClr val="lt1"/>
-          </a:fontRef>
-        </p:style>
-        <p:txBody>
-          <a:bodyPr rtlCol="0" anchor="ctr"/>
-          <a:lstStyle/>
-          <a:p>
-            <a:pPr algn="ctr"/>
-          </a:p>
-        </p:txBody>
-      </p:sp>
-      <p:sp>
-        <p:nvSpPr>
-          <p:cNvPr id="15" name="Rectangle 14"/>
-          <p:cNvSpPr/>
-          <p:nvPr/>
-        </p:nvSpPr>
-        <p:spPr>
-          <a:xfrm>
-            <a:off x="640080" y="5349240"/>
-            <a:ext cx="73152" cy="1280160"/>
-          </a:xfrm>
-          <a:prstGeom prst="rect">
-            <a:avLst/>
-          </a:prstGeom>
-          <a:solidFill>
-            <a:srgbClr val="146B62"/>
-          </a:solidFill>
-          <a:ln>
-            <a:noFill/>
-          </a:ln>
-          <a:effectLst/>
-        </p:spPr>
-        <p:style>
-          <a:lnRef idx="1">
-            <a:schemeClr val="accent1"/>
-          </a:lnRef>
-          <a:fillRef idx="3">
-            <a:schemeClr val="accent1"/>
-          </a:fillRef>
-          <a:effectRef idx="2">
-            <a:schemeClr val="accent1"/>
-          </a:effectRef>
-          <a:fontRef idx="minor">
-            <a:schemeClr val="lt1"/>
-          </a:fontRef>
-        </p:style>
-        <p:txBody>
-          <a:bodyPr rtlCol="0" anchor="ctr"/>
-          <a:lstStyle/>
-          <a:p>
-            <a:pPr algn="ctr"/>
-          </a:p>
-        </p:txBody>
-      </p:sp>
-      <p:sp>
-        <p:nvSpPr>
-          <p:cNvPr id="16" name="TextBox 15"/>
-          <p:cNvSpPr txBox="1"/>
-          <p:nvPr/>
-        </p:nvSpPr>
-        <p:spPr>
-          <a:xfrm>
-            <a:off x="914400" y="5486400"/>
-            <a:ext cx="10332720" cy="274320"/>
-          </a:xfrm>
-          <a:prstGeom prst="rect">
-            <a:avLst/>
-          </a:prstGeom>
-          <a:noFill/>
-        </p:spPr>
-        <p:txBody>
-          <a:bodyPr wrap="square" anchor="t">
-            <a:spAutoFit/>
-          </a:bodyPr>
-          <a:lstStyle/>
-          <a:p>
-            <a:pPr algn="l">
-              <a:lnSpc>
-                <a:spcPct val="115000"/>
-              </a:lnSpc>
-            </a:pPr>
-            <a:r>
-              <a:rPr sz="1200" b="1" i="0">
-                <a:solidFill>
-                  <a:srgbClr val="146B62"/>
-                </a:solidFill>
-                <a:latin typeface="Calibri"/>
-              </a:rPr>
-              <a:t>UNIT 3 — IOT, FOG/CLOUD COMPUTING, SDN</a:t>
-            </a:r>
-          </a:p>
-        </p:txBody>
-      </p:sp>
-      <p:sp>
-        <p:nvSpPr>
-          <p:cNvPr id="17" name="TextBox 16"/>
-          <p:cNvSpPr txBox="1"/>
-          <p:nvPr/>
-        </p:nvSpPr>
-        <p:spPr>
-          <a:xfrm>
-            <a:off x="914400" y="5806440"/>
-            <a:ext cx="10332720" cy="777240"/>
-          </a:xfrm>
-          <a:prstGeom prst="rect">
-            <a:avLst/>
-          </a:prstGeom>
-          <a:noFill/>
-        </p:spPr>
-        <p:txBody>
-          <a:bodyPr wrap="square" anchor="t">
-            <a:spAutoFit/>
-          </a:bodyPr>
-          <a:lstStyle/>
-          <a:p>
-            <a:pPr algn="l">
-              <a:lnSpc>
-                <a:spcPct val="115000"/>
-              </a:lnSpc>
-            </a:pPr>
-            <a:r>
-              <a:rPr sz="1250" b="0" i="0">
+              <a:t>▪  1. Check the HMAC tag — any change in transit → reject.</a:t>
+            </a:r>
+          </a:p>
+          <a:p>
+            <a:pPr>
+              <a:lnSpc>
+                <a:spcPct val="120000"/>
+              </a:lnSpc>
+              <a:spcAft>
+                <a:spcPts val="600"/>
+              </a:spcAft>
+            </a:pPr>
+            <a:r>
+              <a:rPr sz="1300">
                 <a:solidFill>
                   <a:srgbClr val="172420"/>
                 </a:solidFill>
                 <a:latin typeface="Calibri"/>
               </a:rPr>
-              <a:t>Federated Learning's architecture IS fog computing: local processing at the edge, summarized results to a central aggregator. Our custom protocol mirrors SDN/OpenFlow — customizing behavior beyond fixed defaults.</a:t>
+              <a:t>▪  2. Recompute the fingerprint from the payload — a client cannot lie about it.</a:t>
+            </a:r>
+          </a:p>
+          <a:p>
+            <a:pPr>
+              <a:lnSpc>
+                <a:spcPct val="120000"/>
+              </a:lnSpc>
+              <a:spcAft>
+                <a:spcPts val="600"/>
+              </a:spcAft>
+            </a:pPr>
+            <a:r>
+              <a:rPr sz="1300">
+                <a:solidFill>
+                  <a:srgbClr val="172420"/>
+                </a:solidFill>
+                <a:latin typeface="Calibri"/>
+              </a:rPr>
+              <a:t>▪  3. Score the update vs. the other clients this round: size, direction vs. consensus, change vs. its own last update.</a:t>
+            </a:r>
+          </a:p>
+          <a:p>
+            <a:pPr>
+              <a:lnSpc>
+                <a:spcPct val="120000"/>
+              </a:lnSpc>
+              <a:spcAft>
+                <a:spcPts val="600"/>
+              </a:spcAft>
+            </a:pPr>
+            <a:r>
+              <a:rPr sz="1300">
+                <a:solidFill>
+                  <a:srgbClr val="172420"/>
+                </a:solidFill>
+                <a:latin typeface="Calibri"/>
+              </a:rPr>
+              <a:t>▪  4. Over the calibrated threshold → flagged → second check against a trimmed-mean reference (rescue or drop).</a:t>
+            </a:r>
+          </a:p>
+          <a:p>
+            <a:pPr>
+              <a:lnSpc>
+                <a:spcPct val="120000"/>
+              </a:lnSpc>
+              <a:spcAft>
+                <a:spcPts val="600"/>
+              </a:spcAft>
+            </a:pPr>
+            <a:r>
+              <a:rPr sz="1300">
+                <a:solidFill>
+                  <a:srgbClr val="172420"/>
+                </a:solidFill>
+                <a:latin typeface="Calibri"/>
+              </a:rPr>
+              <a:t>▪  5. Average the accepted updates, with no client weighted above 15%.</a:t>
             </a:r>
           </a:p>
         </p:txBody>
@@ -7924,7 +8941,7 @@
                 </a:solidFill>
                 <a:latin typeface="Calibri"/>
               </a:rPr>
-              <a:t>07  ROADMAP</a:t>
+              <a:t>07  PROTOCOL RESULTS</a:t>
             </a:r>
           </a:p>
         </p:txBody>
@@ -7957,13 +8974,13 @@
               </a:lnSpc>
             </a:pPr>
             <a:r>
-              <a:rPr sz="3600" b="1" i="0">
+              <a:rPr sz="3400" b="1" i="0">
                 <a:solidFill>
                   <a:srgbClr val="172420"/>
                 </a:solidFill>
                 <a:latin typeface="Arial Black"/>
               </a:rPr>
-              <a:t>What's left, and exactly how</a:t>
+              <a:t>Does it stop the attacks?</a:t>
             </a:r>
           </a:p>
         </p:txBody>
@@ -8002,7 +9019,7 @@
                 </a:solidFill>
                 <a:latin typeface="Calibri"/>
               </a:rPr>
-              <a:t>The first half (Objective 1) is fully complete and proven. The remaining work is scoped precisely, not vaguely.</a:t>
+              <a:t>2 of 10 clients attack after 5 clean rounds. Mean over random seeds; v1 = protocol drops flagged updates, v2 = + weight cap + second check.</a:t>
             </a:r>
           </a:p>
         </p:txBody>
@@ -8016,7 +9033,7 @@
         <p:spPr>
           <a:xfrm>
             <a:off x="640080" y="2377440"/>
-            <a:ext cx="10881360" cy="1234440"/>
+            <a:ext cx="10881360" cy="2788920"/>
           </a:xfrm>
           <a:prstGeom prst="roundRect">
             <a:avLst>
@@ -8063,125 +9080,1217 @@
         </p:nvSpPr>
         <p:spPr>
           <a:xfrm>
-            <a:off x="914400" y="2514600"/>
-            <a:ext cx="548640" cy="457200"/>
-          </a:xfrm>
-          <a:prstGeom prst="rect">
-            <a:avLst/>
-          </a:prstGeom>
-          <a:noFill/>
-        </p:spPr>
-        <p:txBody>
-          <a:bodyPr wrap="square" anchor="t">
-            <a:spAutoFit/>
-          </a:bodyPr>
-          <a:lstStyle/>
-          <a:p>
-            <a:pPr algn="l">
-              <a:lnSpc>
-                <a:spcPct val="115000"/>
-              </a:lnSpc>
-            </a:pPr>
-            <a:r>
-              <a:rPr sz="2200" b="1" i="0">
+            <a:off x="868680" y="2514600"/>
+            <a:ext cx="3017520" cy="457200"/>
+          </a:xfrm>
+          <a:prstGeom prst="rect">
+            <a:avLst/>
+          </a:prstGeom>
+          <a:noFill/>
+        </p:spPr>
+        <p:txBody>
+          <a:bodyPr wrap="square" anchor="t">
+            <a:spAutoFit/>
+          </a:bodyPr>
+          <a:lstStyle/>
+          <a:p>
+            <a:pPr algn="l">
+              <a:lnSpc>
+                <a:spcPct val="115000"/>
+              </a:lnSpc>
+            </a:pPr>
+            <a:r>
+              <a:rPr sz="1300" b="1" i="0">
                 <a:solidFill>
                   <a:srgbClr val="146B62"/>
                 </a:solidFill>
+                <a:latin typeface="Calibri"/>
+              </a:rPr>
+              <a:t>Dataset / attack</a:t>
+            </a:r>
+          </a:p>
+        </p:txBody>
+      </p:sp>
+      <p:sp>
+        <p:nvSpPr>
+          <p:cNvPr id="8" name="TextBox 7"/>
+          <p:cNvSpPr txBox="1"/>
+          <p:nvPr/>
+        </p:nvSpPr>
+        <p:spPr>
+          <a:xfrm>
+            <a:off x="3886200" y="2514600"/>
+            <a:ext cx="2103120" cy="457200"/>
+          </a:xfrm>
+          <a:prstGeom prst="rect">
+            <a:avLst/>
+          </a:prstGeom>
+          <a:noFill/>
+        </p:spPr>
+        <p:txBody>
+          <a:bodyPr wrap="square" anchor="t">
+            <a:spAutoFit/>
+          </a:bodyPr>
+          <a:lstStyle/>
+          <a:p>
+            <a:pPr algn="l">
+              <a:lnSpc>
+                <a:spcPct val="115000"/>
+              </a:lnSpc>
+            </a:pPr>
+            <a:r>
+              <a:rPr sz="1300" b="1" i="0">
+                <a:solidFill>
+                  <a:srgbClr val="146B62"/>
+                </a:solidFill>
+                <a:latin typeface="Calibri"/>
+              </a:rPr>
+              <a:t>Metric</a:t>
+            </a:r>
+          </a:p>
+        </p:txBody>
+      </p:sp>
+      <p:sp>
+        <p:nvSpPr>
+          <p:cNvPr id="9" name="TextBox 8"/>
+          <p:cNvSpPr txBox="1"/>
+          <p:nvPr/>
+        </p:nvSpPr>
+        <p:spPr>
+          <a:xfrm>
+            <a:off x="5989320" y="2514600"/>
+            <a:ext cx="1920240" cy="457200"/>
+          </a:xfrm>
+          <a:prstGeom prst="rect">
+            <a:avLst/>
+          </a:prstGeom>
+          <a:noFill/>
+        </p:spPr>
+        <p:txBody>
+          <a:bodyPr wrap="square" anchor="t">
+            <a:spAutoFit/>
+          </a:bodyPr>
+          <a:lstStyle/>
+          <a:p>
+            <a:pPr algn="l">
+              <a:lnSpc>
+                <a:spcPct val="115000"/>
+              </a:lnSpc>
+            </a:pPr>
+            <a:r>
+              <a:rPr sz="1300" b="1" i="0">
+                <a:solidFill>
+                  <a:srgbClr val="146B62"/>
+                </a:solidFill>
+                <a:latin typeface="Calibri"/>
+              </a:rPr>
+              <a:t>No defense</a:t>
+            </a:r>
+          </a:p>
+        </p:txBody>
+      </p:sp>
+      <p:sp>
+        <p:nvSpPr>
+          <p:cNvPr id="10" name="TextBox 9"/>
+          <p:cNvSpPr txBox="1"/>
+          <p:nvPr/>
+        </p:nvSpPr>
+        <p:spPr>
+          <a:xfrm>
+            <a:off x="7909560" y="2514600"/>
+            <a:ext cx="1920240" cy="457200"/>
+          </a:xfrm>
+          <a:prstGeom prst="rect">
+            <a:avLst/>
+          </a:prstGeom>
+          <a:noFill/>
+        </p:spPr>
+        <p:txBody>
+          <a:bodyPr wrap="square" anchor="t">
+            <a:spAutoFit/>
+          </a:bodyPr>
+          <a:lstStyle/>
+          <a:p>
+            <a:pPr algn="l">
+              <a:lnSpc>
+                <a:spcPct val="115000"/>
+              </a:lnSpc>
+            </a:pPr>
+            <a:r>
+              <a:rPr sz="1300" b="1" i="0">
+                <a:solidFill>
+                  <a:srgbClr val="146B62"/>
+                </a:solidFill>
+                <a:latin typeface="Calibri"/>
+              </a:rPr>
+              <a:t>Protocol v1</a:t>
+            </a:r>
+          </a:p>
+        </p:txBody>
+      </p:sp>
+      <p:sp>
+        <p:nvSpPr>
+          <p:cNvPr id="11" name="TextBox 10"/>
+          <p:cNvSpPr txBox="1"/>
+          <p:nvPr/>
+        </p:nvSpPr>
+        <p:spPr>
+          <a:xfrm>
+            <a:off x="9829800" y="2514600"/>
+            <a:ext cx="1920240" cy="457200"/>
+          </a:xfrm>
+          <a:prstGeom prst="rect">
+            <a:avLst/>
+          </a:prstGeom>
+          <a:noFill/>
+        </p:spPr>
+        <p:txBody>
+          <a:bodyPr wrap="square" anchor="t">
+            <a:spAutoFit/>
+          </a:bodyPr>
+          <a:lstStyle/>
+          <a:p>
+            <a:pPr algn="l">
+              <a:lnSpc>
+                <a:spcPct val="115000"/>
+              </a:lnSpc>
+            </a:pPr>
+            <a:r>
+              <a:rPr sz="1300" b="1" i="0">
+                <a:solidFill>
+                  <a:srgbClr val="146B62"/>
+                </a:solidFill>
+                <a:latin typeface="Calibri"/>
+              </a:rPr>
+              <a:t>Protocol v2</a:t>
+            </a:r>
+          </a:p>
+        </p:txBody>
+      </p:sp>
+      <p:sp>
+        <p:nvSpPr>
+          <p:cNvPr id="12" name="TextBox 11"/>
+          <p:cNvSpPr txBox="1"/>
+          <p:nvPr/>
+        </p:nvSpPr>
+        <p:spPr>
+          <a:xfrm>
+            <a:off x="868680" y="3017520"/>
+            <a:ext cx="3017520" cy="457200"/>
+          </a:xfrm>
+          <a:prstGeom prst="rect">
+            <a:avLst/>
+          </a:prstGeom>
+          <a:noFill/>
+        </p:spPr>
+        <p:txBody>
+          <a:bodyPr wrap="square" anchor="t">
+            <a:spAutoFit/>
+          </a:bodyPr>
+          <a:lstStyle/>
+          <a:p>
+            <a:pPr algn="l">
+              <a:lnSpc>
+                <a:spcPct val="115000"/>
+              </a:lnSpc>
+            </a:pPr>
+            <a:r>
+              <a:rPr sz="1300" b="0" i="0">
+                <a:solidFill>
+                  <a:srgbClr val="172420"/>
+                </a:solidFill>
+                <a:latin typeface="Calibri"/>
+              </a:rPr>
+              <a:t>FLNET2023 · label flip</a:t>
+            </a:r>
+          </a:p>
+        </p:txBody>
+      </p:sp>
+      <p:sp>
+        <p:nvSpPr>
+          <p:cNvPr id="13" name="TextBox 12"/>
+          <p:cNvSpPr txBox="1"/>
+          <p:nvPr/>
+        </p:nvSpPr>
+        <p:spPr>
+          <a:xfrm>
+            <a:off x="3886200" y="3017520"/>
+            <a:ext cx="2103120" cy="457200"/>
+          </a:xfrm>
+          <a:prstGeom prst="rect">
+            <a:avLst/>
+          </a:prstGeom>
+          <a:noFill/>
+        </p:spPr>
+        <p:txBody>
+          <a:bodyPr wrap="square" anchor="t">
+            <a:spAutoFit/>
+          </a:bodyPr>
+          <a:lstStyle/>
+          <a:p>
+            <a:pPr algn="l">
+              <a:lnSpc>
+                <a:spcPct val="115000"/>
+              </a:lnSpc>
+            </a:pPr>
+            <a:r>
+              <a:rPr sz="1300" b="0" i="0">
+                <a:solidFill>
+                  <a:srgbClr val="172420"/>
+                </a:solidFill>
+                <a:latin typeface="Calibri"/>
+              </a:rPr>
+              <a:t>Accuracy ↑</a:t>
+            </a:r>
+          </a:p>
+        </p:txBody>
+      </p:sp>
+      <p:sp>
+        <p:nvSpPr>
+          <p:cNvPr id="14" name="TextBox 13"/>
+          <p:cNvSpPr txBox="1"/>
+          <p:nvPr/>
+        </p:nvSpPr>
+        <p:spPr>
+          <a:xfrm>
+            <a:off x="5989320" y="3017520"/>
+            <a:ext cx="1920240" cy="457200"/>
+          </a:xfrm>
+          <a:prstGeom prst="rect">
+            <a:avLst/>
+          </a:prstGeom>
+          <a:noFill/>
+        </p:spPr>
+        <p:txBody>
+          <a:bodyPr wrap="square" anchor="t">
+            <a:spAutoFit/>
+          </a:bodyPr>
+          <a:lstStyle/>
+          <a:p>
+            <a:pPr algn="l">
+              <a:lnSpc>
+                <a:spcPct val="115000"/>
+              </a:lnSpc>
+            </a:pPr>
+            <a:r>
+              <a:rPr sz="1300" b="0" i="0">
+                <a:solidFill>
+                  <a:srgbClr val="172420"/>
+                </a:solidFill>
+                <a:latin typeface="Calibri"/>
+              </a:rPr>
+              <a:t>92.4%</a:t>
+            </a:r>
+          </a:p>
+        </p:txBody>
+      </p:sp>
+      <p:sp>
+        <p:nvSpPr>
+          <p:cNvPr id="15" name="TextBox 14"/>
+          <p:cNvSpPr txBox="1"/>
+          <p:nvPr/>
+        </p:nvSpPr>
+        <p:spPr>
+          <a:xfrm>
+            <a:off x="7909560" y="3017520"/>
+            <a:ext cx="1920240" cy="457200"/>
+          </a:xfrm>
+          <a:prstGeom prst="rect">
+            <a:avLst/>
+          </a:prstGeom>
+          <a:noFill/>
+        </p:spPr>
+        <p:txBody>
+          <a:bodyPr wrap="square" anchor="t">
+            <a:spAutoFit/>
+          </a:bodyPr>
+          <a:lstStyle/>
+          <a:p>
+            <a:pPr algn="l">
+              <a:lnSpc>
+                <a:spcPct val="115000"/>
+              </a:lnSpc>
+            </a:pPr>
+            <a:r>
+              <a:rPr sz="1300" b="0" i="0">
+                <a:solidFill>
+                  <a:srgbClr val="172420"/>
+                </a:solidFill>
+                <a:latin typeface="Calibri"/>
+              </a:rPr>
+              <a:t>99.4%</a:t>
+            </a:r>
+          </a:p>
+        </p:txBody>
+      </p:sp>
+      <p:sp>
+        <p:nvSpPr>
+          <p:cNvPr id="16" name="TextBox 15"/>
+          <p:cNvSpPr txBox="1"/>
+          <p:nvPr/>
+        </p:nvSpPr>
+        <p:spPr>
+          <a:xfrm>
+            <a:off x="9829800" y="3017520"/>
+            <a:ext cx="1920240" cy="457200"/>
+          </a:xfrm>
+          <a:prstGeom prst="rect">
+            <a:avLst/>
+          </a:prstGeom>
+          <a:noFill/>
+        </p:spPr>
+        <p:txBody>
+          <a:bodyPr wrap="square" anchor="t">
+            <a:spAutoFit/>
+          </a:bodyPr>
+          <a:lstStyle/>
+          <a:p>
+            <a:pPr algn="l">
+              <a:lnSpc>
+                <a:spcPct val="115000"/>
+              </a:lnSpc>
+            </a:pPr>
+            <a:r>
+              <a:rPr sz="1300" b="1" i="0">
+                <a:solidFill>
+                  <a:srgbClr val="172420"/>
+                </a:solidFill>
+                <a:latin typeface="Calibri"/>
+              </a:rPr>
+              <a:t>96.7%</a:t>
+            </a:r>
+          </a:p>
+        </p:txBody>
+      </p:sp>
+      <p:sp>
+        <p:nvSpPr>
+          <p:cNvPr id="17" name="TextBox 16"/>
+          <p:cNvSpPr txBox="1"/>
+          <p:nvPr/>
+        </p:nvSpPr>
+        <p:spPr>
+          <a:xfrm>
+            <a:off x="868680" y="3520440"/>
+            <a:ext cx="3017520" cy="457200"/>
+          </a:xfrm>
+          <a:prstGeom prst="rect">
+            <a:avLst/>
+          </a:prstGeom>
+          <a:noFill/>
+        </p:spPr>
+        <p:txBody>
+          <a:bodyPr wrap="square" anchor="t">
+            <a:spAutoFit/>
+          </a:bodyPr>
+          <a:lstStyle/>
+          <a:p>
+            <a:pPr algn="l">
+              <a:lnSpc>
+                <a:spcPct val="115000"/>
+              </a:lnSpc>
+            </a:pPr>
+            <a:r>
+              <a:rPr sz="1300" b="0" i="0">
+                <a:solidFill>
+                  <a:srgbClr val="172420"/>
+                </a:solidFill>
+                <a:latin typeface="Calibri"/>
+              </a:rPr>
+              <a:t>NSL-KDD · label flip</a:t>
+            </a:r>
+          </a:p>
+        </p:txBody>
+      </p:sp>
+      <p:sp>
+        <p:nvSpPr>
+          <p:cNvPr id="18" name="TextBox 17"/>
+          <p:cNvSpPr txBox="1"/>
+          <p:nvPr/>
+        </p:nvSpPr>
+        <p:spPr>
+          <a:xfrm>
+            <a:off x="3886200" y="3520440"/>
+            <a:ext cx="2103120" cy="457200"/>
+          </a:xfrm>
+          <a:prstGeom prst="rect">
+            <a:avLst/>
+          </a:prstGeom>
+          <a:noFill/>
+        </p:spPr>
+        <p:txBody>
+          <a:bodyPr wrap="square" anchor="t">
+            <a:spAutoFit/>
+          </a:bodyPr>
+          <a:lstStyle/>
+          <a:p>
+            <a:pPr algn="l">
+              <a:lnSpc>
+                <a:spcPct val="115000"/>
+              </a:lnSpc>
+            </a:pPr>
+            <a:r>
+              <a:rPr sz="1300" b="0" i="0">
+                <a:solidFill>
+                  <a:srgbClr val="172420"/>
+                </a:solidFill>
+                <a:latin typeface="Calibri"/>
+              </a:rPr>
+              <a:t>Accuracy ↑</a:t>
+            </a:r>
+          </a:p>
+        </p:txBody>
+      </p:sp>
+      <p:sp>
+        <p:nvSpPr>
+          <p:cNvPr id="19" name="TextBox 18"/>
+          <p:cNvSpPr txBox="1"/>
+          <p:nvPr/>
+        </p:nvSpPr>
+        <p:spPr>
+          <a:xfrm>
+            <a:off x="5989320" y="3520440"/>
+            <a:ext cx="1920240" cy="457200"/>
+          </a:xfrm>
+          <a:prstGeom prst="rect">
+            <a:avLst/>
+          </a:prstGeom>
+          <a:noFill/>
+        </p:spPr>
+        <p:txBody>
+          <a:bodyPr wrap="square" anchor="t">
+            <a:spAutoFit/>
+          </a:bodyPr>
+          <a:lstStyle/>
+          <a:p>
+            <a:pPr algn="l">
+              <a:lnSpc>
+                <a:spcPct val="115000"/>
+              </a:lnSpc>
+            </a:pPr>
+            <a:r>
+              <a:rPr sz="1300" b="0" i="0">
+                <a:solidFill>
+                  <a:srgbClr val="172420"/>
+                </a:solidFill>
+                <a:latin typeface="Calibri"/>
+              </a:rPr>
+              <a:t>68.8%</a:t>
+            </a:r>
+          </a:p>
+        </p:txBody>
+      </p:sp>
+      <p:sp>
+        <p:nvSpPr>
+          <p:cNvPr id="20" name="TextBox 19"/>
+          <p:cNvSpPr txBox="1"/>
+          <p:nvPr/>
+        </p:nvSpPr>
+        <p:spPr>
+          <a:xfrm>
+            <a:off x="7909560" y="3520440"/>
+            <a:ext cx="1920240" cy="457200"/>
+          </a:xfrm>
+          <a:prstGeom prst="rect">
+            <a:avLst/>
+          </a:prstGeom>
+          <a:noFill/>
+        </p:spPr>
+        <p:txBody>
+          <a:bodyPr wrap="square" anchor="t">
+            <a:spAutoFit/>
+          </a:bodyPr>
+          <a:lstStyle/>
+          <a:p>
+            <a:pPr algn="l">
+              <a:lnSpc>
+                <a:spcPct val="115000"/>
+              </a:lnSpc>
+            </a:pPr>
+            <a:r>
+              <a:rPr sz="1300" b="0" i="0">
+                <a:solidFill>
+                  <a:srgbClr val="172420"/>
+                </a:solidFill>
+                <a:latin typeface="Calibri"/>
+              </a:rPr>
+              <a:t>78.6%</a:t>
+            </a:r>
+          </a:p>
+        </p:txBody>
+      </p:sp>
+      <p:sp>
+        <p:nvSpPr>
+          <p:cNvPr id="21" name="TextBox 20"/>
+          <p:cNvSpPr txBox="1"/>
+          <p:nvPr/>
+        </p:nvSpPr>
+        <p:spPr>
+          <a:xfrm>
+            <a:off x="9829800" y="3520440"/>
+            <a:ext cx="1920240" cy="457200"/>
+          </a:xfrm>
+          <a:prstGeom prst="rect">
+            <a:avLst/>
+          </a:prstGeom>
+          <a:noFill/>
+        </p:spPr>
+        <p:txBody>
+          <a:bodyPr wrap="square" anchor="t">
+            <a:spAutoFit/>
+          </a:bodyPr>
+          <a:lstStyle/>
+          <a:p>
+            <a:pPr algn="l">
+              <a:lnSpc>
+                <a:spcPct val="115000"/>
+              </a:lnSpc>
+            </a:pPr>
+            <a:r>
+              <a:rPr sz="1300" b="1" i="0">
+                <a:solidFill>
+                  <a:srgbClr val="172420"/>
+                </a:solidFill>
+                <a:latin typeface="Calibri"/>
+              </a:rPr>
+              <a:t>79.2%</a:t>
+            </a:r>
+          </a:p>
+        </p:txBody>
+      </p:sp>
+      <p:sp>
+        <p:nvSpPr>
+          <p:cNvPr id="22" name="TextBox 21"/>
+          <p:cNvSpPr txBox="1"/>
+          <p:nvPr/>
+        </p:nvSpPr>
+        <p:spPr>
+          <a:xfrm>
+            <a:off x="868680" y="4023360"/>
+            <a:ext cx="3017520" cy="457200"/>
+          </a:xfrm>
+          <a:prstGeom prst="rect">
+            <a:avLst/>
+          </a:prstGeom>
+          <a:noFill/>
+        </p:spPr>
+        <p:txBody>
+          <a:bodyPr wrap="square" anchor="t">
+            <a:spAutoFit/>
+          </a:bodyPr>
+          <a:lstStyle/>
+          <a:p>
+            <a:pPr algn="l">
+              <a:lnSpc>
+                <a:spcPct val="115000"/>
+              </a:lnSpc>
+            </a:pPr>
+            <a:r>
+              <a:rPr sz="1300" b="0" i="0">
+                <a:solidFill>
+                  <a:srgbClr val="172420"/>
+                </a:solidFill>
+                <a:latin typeface="Calibri"/>
+              </a:rPr>
+              <a:t>FLNET2023 · backdoor</a:t>
+            </a:r>
+          </a:p>
+        </p:txBody>
+      </p:sp>
+      <p:sp>
+        <p:nvSpPr>
+          <p:cNvPr id="23" name="TextBox 22"/>
+          <p:cNvSpPr txBox="1"/>
+          <p:nvPr/>
+        </p:nvSpPr>
+        <p:spPr>
+          <a:xfrm>
+            <a:off x="3886200" y="4023360"/>
+            <a:ext cx="2103120" cy="457200"/>
+          </a:xfrm>
+          <a:prstGeom prst="rect">
+            <a:avLst/>
+          </a:prstGeom>
+          <a:noFill/>
+        </p:spPr>
+        <p:txBody>
+          <a:bodyPr wrap="square" anchor="t">
+            <a:spAutoFit/>
+          </a:bodyPr>
+          <a:lstStyle/>
+          <a:p>
+            <a:pPr algn="l">
+              <a:lnSpc>
+                <a:spcPct val="115000"/>
+              </a:lnSpc>
+            </a:pPr>
+            <a:r>
+              <a:rPr sz="1300" b="0" i="0">
+                <a:solidFill>
+                  <a:srgbClr val="172420"/>
+                </a:solidFill>
+                <a:latin typeface="Calibri"/>
+              </a:rPr>
+              <a:t>Backdoor success ↓</a:t>
+            </a:r>
+          </a:p>
+        </p:txBody>
+      </p:sp>
+      <p:sp>
+        <p:nvSpPr>
+          <p:cNvPr id="24" name="TextBox 23"/>
+          <p:cNvSpPr txBox="1"/>
+          <p:nvPr/>
+        </p:nvSpPr>
+        <p:spPr>
+          <a:xfrm>
+            <a:off x="5989320" y="4023360"/>
+            <a:ext cx="1920240" cy="457200"/>
+          </a:xfrm>
+          <a:prstGeom prst="rect">
+            <a:avLst/>
+          </a:prstGeom>
+          <a:noFill/>
+        </p:spPr>
+        <p:txBody>
+          <a:bodyPr wrap="square" anchor="t">
+            <a:spAutoFit/>
+          </a:bodyPr>
+          <a:lstStyle/>
+          <a:p>
+            <a:pPr algn="l">
+              <a:lnSpc>
+                <a:spcPct val="115000"/>
+              </a:lnSpc>
+            </a:pPr>
+            <a:r>
+              <a:rPr sz="1300" b="0" i="0">
+                <a:solidFill>
+                  <a:srgbClr val="172420"/>
+                </a:solidFill>
+                <a:latin typeface="Calibri"/>
+              </a:rPr>
+              <a:t>0.0%</a:t>
+            </a:r>
+          </a:p>
+        </p:txBody>
+      </p:sp>
+      <p:sp>
+        <p:nvSpPr>
+          <p:cNvPr id="25" name="TextBox 24"/>
+          <p:cNvSpPr txBox="1"/>
+          <p:nvPr/>
+        </p:nvSpPr>
+        <p:spPr>
+          <a:xfrm>
+            <a:off x="7909560" y="4023360"/>
+            <a:ext cx="1920240" cy="457200"/>
+          </a:xfrm>
+          <a:prstGeom prst="rect">
+            <a:avLst/>
+          </a:prstGeom>
+          <a:noFill/>
+        </p:spPr>
+        <p:txBody>
+          <a:bodyPr wrap="square" anchor="t">
+            <a:spAutoFit/>
+          </a:bodyPr>
+          <a:lstStyle/>
+          <a:p>
+            <a:pPr algn="l">
+              <a:lnSpc>
+                <a:spcPct val="115000"/>
+              </a:lnSpc>
+            </a:pPr>
+            <a:r>
+              <a:rPr sz="1300" b="0" i="0">
+                <a:solidFill>
+                  <a:srgbClr val="172420"/>
+                </a:solidFill>
+                <a:latin typeface="Calibri"/>
+              </a:rPr>
+              <a:t>0.0%</a:t>
+            </a:r>
+          </a:p>
+        </p:txBody>
+      </p:sp>
+      <p:sp>
+        <p:nvSpPr>
+          <p:cNvPr id="26" name="TextBox 25"/>
+          <p:cNvSpPr txBox="1"/>
+          <p:nvPr/>
+        </p:nvSpPr>
+        <p:spPr>
+          <a:xfrm>
+            <a:off x="9829800" y="4023360"/>
+            <a:ext cx="1920240" cy="457200"/>
+          </a:xfrm>
+          <a:prstGeom prst="rect">
+            <a:avLst/>
+          </a:prstGeom>
+          <a:noFill/>
+        </p:spPr>
+        <p:txBody>
+          <a:bodyPr wrap="square" anchor="t">
+            <a:spAutoFit/>
+          </a:bodyPr>
+          <a:lstStyle/>
+          <a:p>
+            <a:pPr algn="l">
+              <a:lnSpc>
+                <a:spcPct val="115000"/>
+              </a:lnSpc>
+            </a:pPr>
+            <a:r>
+              <a:rPr sz="1300" b="1" i="0">
+                <a:solidFill>
+                  <a:srgbClr val="172420"/>
+                </a:solidFill>
+                <a:latin typeface="Calibri"/>
+              </a:rPr>
+              <a:t>0.0%</a:t>
+            </a:r>
+          </a:p>
+        </p:txBody>
+      </p:sp>
+      <p:sp>
+        <p:nvSpPr>
+          <p:cNvPr id="27" name="TextBox 26"/>
+          <p:cNvSpPr txBox="1"/>
+          <p:nvPr/>
+        </p:nvSpPr>
+        <p:spPr>
+          <a:xfrm>
+            <a:off x="868680" y="4526280"/>
+            <a:ext cx="3017520" cy="457200"/>
+          </a:xfrm>
+          <a:prstGeom prst="rect">
+            <a:avLst/>
+          </a:prstGeom>
+          <a:noFill/>
+        </p:spPr>
+        <p:txBody>
+          <a:bodyPr wrap="square" anchor="t">
+            <a:spAutoFit/>
+          </a:bodyPr>
+          <a:lstStyle/>
+          <a:p>
+            <a:pPr algn="l">
+              <a:lnSpc>
+                <a:spcPct val="115000"/>
+              </a:lnSpc>
+            </a:pPr>
+            <a:r>
+              <a:rPr sz="1300" b="0" i="0">
+                <a:solidFill>
+                  <a:srgbClr val="172420"/>
+                </a:solidFill>
+                <a:latin typeface="Calibri"/>
+              </a:rPr>
+              <a:t>NSL-KDD · backdoor</a:t>
+            </a:r>
+          </a:p>
+        </p:txBody>
+      </p:sp>
+      <p:sp>
+        <p:nvSpPr>
+          <p:cNvPr id="28" name="TextBox 27"/>
+          <p:cNvSpPr txBox="1"/>
+          <p:nvPr/>
+        </p:nvSpPr>
+        <p:spPr>
+          <a:xfrm>
+            <a:off x="3886200" y="4526280"/>
+            <a:ext cx="2103120" cy="457200"/>
+          </a:xfrm>
+          <a:prstGeom prst="rect">
+            <a:avLst/>
+          </a:prstGeom>
+          <a:noFill/>
+        </p:spPr>
+        <p:txBody>
+          <a:bodyPr wrap="square" anchor="t">
+            <a:spAutoFit/>
+          </a:bodyPr>
+          <a:lstStyle/>
+          <a:p>
+            <a:pPr algn="l">
+              <a:lnSpc>
+                <a:spcPct val="115000"/>
+              </a:lnSpc>
+            </a:pPr>
+            <a:r>
+              <a:rPr sz="1300" b="0" i="0">
+                <a:solidFill>
+                  <a:srgbClr val="172420"/>
+                </a:solidFill>
+                <a:latin typeface="Calibri"/>
+              </a:rPr>
+              <a:t>Backdoor success ↓</a:t>
+            </a:r>
+          </a:p>
+        </p:txBody>
+      </p:sp>
+      <p:sp>
+        <p:nvSpPr>
+          <p:cNvPr id="29" name="TextBox 28"/>
+          <p:cNvSpPr txBox="1"/>
+          <p:nvPr/>
+        </p:nvSpPr>
+        <p:spPr>
+          <a:xfrm>
+            <a:off x="5989320" y="4526280"/>
+            <a:ext cx="1920240" cy="457200"/>
+          </a:xfrm>
+          <a:prstGeom prst="rect">
+            <a:avLst/>
+          </a:prstGeom>
+          <a:noFill/>
+        </p:spPr>
+        <p:txBody>
+          <a:bodyPr wrap="square" anchor="t">
+            <a:spAutoFit/>
+          </a:bodyPr>
+          <a:lstStyle/>
+          <a:p>
+            <a:pPr algn="l">
+              <a:lnSpc>
+                <a:spcPct val="115000"/>
+              </a:lnSpc>
+            </a:pPr>
+            <a:r>
+              <a:rPr sz="1300" b="0" i="0">
+                <a:solidFill>
+                  <a:srgbClr val="172420"/>
+                </a:solidFill>
+                <a:latin typeface="Calibri"/>
+              </a:rPr>
+              <a:t>34.1%</a:t>
+            </a:r>
+          </a:p>
+        </p:txBody>
+      </p:sp>
+      <p:sp>
+        <p:nvSpPr>
+          <p:cNvPr id="30" name="TextBox 29"/>
+          <p:cNvSpPr txBox="1"/>
+          <p:nvPr/>
+        </p:nvSpPr>
+        <p:spPr>
+          <a:xfrm>
+            <a:off x="7909560" y="4526280"/>
+            <a:ext cx="1920240" cy="457200"/>
+          </a:xfrm>
+          <a:prstGeom prst="rect">
+            <a:avLst/>
+          </a:prstGeom>
+          <a:noFill/>
+        </p:spPr>
+        <p:txBody>
+          <a:bodyPr wrap="square" anchor="t">
+            <a:spAutoFit/>
+          </a:bodyPr>
+          <a:lstStyle/>
+          <a:p>
+            <a:pPr algn="l">
+              <a:lnSpc>
+                <a:spcPct val="115000"/>
+              </a:lnSpc>
+            </a:pPr>
+            <a:r>
+              <a:rPr sz="1300" b="0" i="0">
+                <a:solidFill>
+                  <a:srgbClr val="172420"/>
+                </a:solidFill>
+                <a:latin typeface="Calibri"/>
+              </a:rPr>
+              <a:t>10.8%</a:t>
+            </a:r>
+          </a:p>
+        </p:txBody>
+      </p:sp>
+      <p:sp>
+        <p:nvSpPr>
+          <p:cNvPr id="31" name="TextBox 30"/>
+          <p:cNvSpPr txBox="1"/>
+          <p:nvPr/>
+        </p:nvSpPr>
+        <p:spPr>
+          <a:xfrm>
+            <a:off x="9829800" y="4526280"/>
+            <a:ext cx="1920240" cy="457200"/>
+          </a:xfrm>
+          <a:prstGeom prst="rect">
+            <a:avLst/>
+          </a:prstGeom>
+          <a:noFill/>
+        </p:spPr>
+        <p:txBody>
+          <a:bodyPr wrap="square" anchor="t">
+            <a:spAutoFit/>
+          </a:bodyPr>
+          <a:lstStyle/>
+          <a:p>
+            <a:pPr algn="l">
+              <a:lnSpc>
+                <a:spcPct val="115000"/>
+              </a:lnSpc>
+            </a:pPr>
+            <a:r>
+              <a:rPr sz="1300" b="1" i="0">
+                <a:solidFill>
+                  <a:srgbClr val="172420"/>
+                </a:solidFill>
+                <a:latin typeface="Calibri"/>
+              </a:rPr>
+              <a:t>8.7%</a:t>
+            </a:r>
+          </a:p>
+        </p:txBody>
+      </p:sp>
+      <p:sp>
+        <p:nvSpPr>
+          <p:cNvPr id="32" name="TextBox 31"/>
+          <p:cNvSpPr txBox="1"/>
+          <p:nvPr/>
+        </p:nvSpPr>
+        <p:spPr>
+          <a:xfrm>
+            <a:off x="640080" y="5394960"/>
+            <a:ext cx="10881360" cy="1097280"/>
+          </a:xfrm>
+          <a:prstGeom prst="rect">
+            <a:avLst/>
+          </a:prstGeom>
+          <a:noFill/>
+        </p:spPr>
+        <p:txBody>
+          <a:bodyPr wrap="square" anchor="t">
+            <a:spAutoFit/>
+          </a:bodyPr>
+          <a:lstStyle/>
+          <a:p>
+            <a:pPr algn="l">
+              <a:lnSpc>
+                <a:spcPct val="115000"/>
+              </a:lnSpc>
+            </a:pPr>
+            <a:r>
+              <a:rPr sz="1300" b="0" i="0">
+                <a:solidFill>
+                  <a:srgbClr val="172420"/>
+                </a:solidFill>
+                <a:latin typeface="Calibri"/>
+              </a:rPr>
+              <a:t>Research question — global vs. Mondrian thresholds (15 seeds): Mondrian caught 57.6% vs 53.3% of poisoned updates and wrongly flagged 4.6% vs 2.7% of honest ones — neither difference is statistically significant.</a:t>
+            </a:r>
+          </a:p>
+        </p:txBody>
+      </p:sp>
+    </p:spTree>
+  </p:cSld>
+  <p:clrMapOvr>
+    <a:masterClrMapping/>
+  </p:clrMapOvr>
+</p:sld>
+</file>
+
+<file path=ppt/slides/slide9.xml><?xml version="1.0" encoding="utf-8"?>
+<p:sld xmlns:a="http://schemas.openxmlformats.org/drawingml/2006/main" xmlns:p="http://schemas.openxmlformats.org/presentationml/2006/main" xmlns:r="http://schemas.openxmlformats.org/officeDocument/2006/relationships">
+  <p:cSld>
+    <p:spTree>
+      <p:nvGrpSpPr>
+        <p:cNvPr id="1" name=""/>
+        <p:cNvGrpSpPr/>
+        <p:nvPr/>
+      </p:nvGrpSpPr>
+      <p:grpSpPr/>
+      <p:sp>
+        <p:nvSpPr>
+          <p:cNvPr id="2" name="Rectangle 1"/>
+          <p:cNvSpPr/>
+          <p:nvPr/>
+        </p:nvSpPr>
+        <p:spPr>
+          <a:xfrm>
+            <a:off x="0" y="0"/>
+            <a:ext cx="12191695" cy="6858000"/>
+          </a:xfrm>
+          <a:prstGeom prst="rect">
+            <a:avLst/>
+          </a:prstGeom>
+          <a:solidFill>
+            <a:srgbClr val="F2F4F0"/>
+          </a:solidFill>
+          <a:ln>
+            <a:noFill/>
+          </a:ln>
+          <a:effectLst/>
+        </p:spPr>
+        <p:style>
+          <a:lnRef idx="1">
+            <a:schemeClr val="accent1"/>
+          </a:lnRef>
+          <a:fillRef idx="3">
+            <a:schemeClr val="accent1"/>
+          </a:fillRef>
+          <a:effectRef idx="2">
+            <a:schemeClr val="accent1"/>
+          </a:effectRef>
+          <a:fontRef idx="minor">
+            <a:schemeClr val="lt1"/>
+          </a:fontRef>
+        </p:style>
+        <p:txBody>
+          <a:bodyPr rtlCol="0" anchor="ctr"/>
+          <a:lstStyle/>
+          <a:p>
+            <a:pPr algn="ctr"/>
+          </a:p>
+        </p:txBody>
+      </p:sp>
+      <p:sp>
+        <p:nvSpPr>
+          <p:cNvPr id="3" name="Rounded Rectangle 2"/>
+          <p:cNvSpPr/>
+          <p:nvPr/>
+        </p:nvSpPr>
+        <p:spPr>
+          <a:xfrm>
+            <a:off x="640080" y="502920"/>
+            <a:ext cx="2377440" cy="384048"/>
+          </a:xfrm>
+          <a:prstGeom prst="roundRect">
+            <a:avLst>
+              <a:gd name="adj" fmla="val 50000"/>
+            </a:avLst>
+          </a:prstGeom>
+          <a:solidFill>
+            <a:srgbClr val="D7EBE7"/>
+          </a:solidFill>
+          <a:ln>
+            <a:noFill/>
+          </a:ln>
+          <a:effectLst/>
+        </p:spPr>
+        <p:style>
+          <a:lnRef idx="1">
+            <a:schemeClr val="accent1"/>
+          </a:lnRef>
+          <a:fillRef idx="3">
+            <a:schemeClr val="accent1"/>
+          </a:fillRef>
+          <a:effectRef idx="2">
+            <a:schemeClr val="accent1"/>
+          </a:effectRef>
+          <a:fontRef idx="minor">
+            <a:schemeClr val="lt1"/>
+          </a:fontRef>
+        </p:style>
+        <p:txBody>
+          <a:bodyPr rtlCol="0" anchor="ctr" wrap="none"/>
+          <a:lstStyle/>
+          <a:p>
+            <a:pPr algn="ctr"/>
+            <a:r>
+              <a:rPr sz="1200" b="1">
+                <a:solidFill>
+                  <a:srgbClr val="146B62"/>
+                </a:solidFill>
+                <a:latin typeface="Calibri"/>
+              </a:rPr>
+              <a:t>08  LEARNING</a:t>
+            </a:r>
+          </a:p>
+        </p:txBody>
+      </p:sp>
+      <p:sp>
+        <p:nvSpPr>
+          <p:cNvPr id="4" name="TextBox 3"/>
+          <p:cNvSpPr txBox="1"/>
+          <p:nvPr/>
+        </p:nvSpPr>
+        <p:spPr>
+          <a:xfrm>
+            <a:off x="640080" y="1051560"/>
+            <a:ext cx="10515600" cy="822960"/>
+          </a:xfrm>
+          <a:prstGeom prst="rect">
+            <a:avLst/>
+          </a:prstGeom>
+          <a:noFill/>
+        </p:spPr>
+        <p:txBody>
+          <a:bodyPr wrap="square" anchor="t">
+            <a:spAutoFit/>
+          </a:bodyPr>
+          <a:lstStyle/>
+          <a:p>
+            <a:pPr algn="l">
+              <a:lnSpc>
+                <a:spcPct val="115000"/>
+              </a:lnSpc>
+            </a:pPr>
+            <a:r>
+              <a:rPr sz="3400" b="1" i="0">
+                <a:solidFill>
+                  <a:srgbClr val="172420"/>
+                </a:solidFill>
                 <a:latin typeface="Arial Black"/>
               </a:rPr>
-              <a:t>1</a:t>
-            </a:r>
-          </a:p>
-        </p:txBody>
-      </p:sp>
-      <p:sp>
-        <p:nvSpPr>
-          <p:cNvPr id="8" name="TextBox 7"/>
-          <p:cNvSpPr txBox="1"/>
-          <p:nvPr/>
-        </p:nvSpPr>
-        <p:spPr>
-          <a:xfrm>
-            <a:off x="1554480" y="2514600"/>
-            <a:ext cx="9692640" cy="274320"/>
-          </a:xfrm>
-          <a:prstGeom prst="rect">
-            <a:avLst/>
-          </a:prstGeom>
-          <a:noFill/>
-        </p:spPr>
-        <p:txBody>
-          <a:bodyPr wrap="square" anchor="t">
-            <a:spAutoFit/>
-          </a:bodyPr>
-          <a:lstStyle/>
-          <a:p>
-            <a:pPr algn="l">
-              <a:lnSpc>
-                <a:spcPct val="115000"/>
-              </a:lnSpc>
-            </a:pPr>
-            <a:r>
-              <a:rPr sz="1400" b="1" i="0">
-                <a:solidFill>
-                  <a:srgbClr val="172420"/>
-                </a:solidFill>
-                <a:latin typeface="Calibri"/>
-              </a:rPr>
-              <a:t>Integrity + fingerprint protocol</a:t>
-            </a:r>
-          </a:p>
-        </p:txBody>
-      </p:sp>
-      <p:sp>
-        <p:nvSpPr>
-          <p:cNvPr id="9" name="TextBox 8"/>
-          <p:cNvSpPr txBox="1"/>
-          <p:nvPr/>
-        </p:nvSpPr>
-        <p:spPr>
-          <a:xfrm>
-            <a:off x="1554480" y="2834640"/>
-            <a:ext cx="9692640" cy="685800"/>
-          </a:xfrm>
-          <a:prstGeom prst="rect">
-            <a:avLst/>
-          </a:prstGeom>
-          <a:noFill/>
-        </p:spPr>
-        <p:txBody>
-          <a:bodyPr wrap="square" anchor="t">
-            <a:spAutoFit/>
-          </a:bodyPr>
-          <a:lstStyle/>
-          <a:p>
-            <a:pPr algn="l">
-              <a:lnSpc>
-                <a:spcPct val="115000"/>
-              </a:lnSpc>
-            </a:pPr>
-            <a:r>
-              <a:rPr sz="1200" b="0" i="0">
+              <a:t>How this connects to our syllabus</a:t>
+            </a:r>
+          </a:p>
+        </p:txBody>
+      </p:sp>
+      <p:sp>
+        <p:nvSpPr>
+          <p:cNvPr id="5" name="TextBox 4"/>
+          <p:cNvSpPr txBox="1"/>
+          <p:nvPr/>
+        </p:nvSpPr>
+        <p:spPr>
+          <a:xfrm>
+            <a:off x="640080" y="1783080"/>
+            <a:ext cx="10698480" cy="457200"/>
+          </a:xfrm>
+          <a:prstGeom prst="rect">
+            <a:avLst/>
+          </a:prstGeom>
+          <a:noFill/>
+        </p:spPr>
+        <p:txBody>
+          <a:bodyPr wrap="square" anchor="t">
+            <a:spAutoFit/>
+          </a:bodyPr>
+          <a:lstStyle/>
+          <a:p>
+            <a:pPr algn="l">
+              <a:lnSpc>
+                <a:spcPct val="115000"/>
+              </a:lnSpc>
+            </a:pPr>
+            <a:r>
+              <a:rPr sz="1300" b="0" i="1">
                 <a:solidFill>
                   <a:srgbClr val="56655D"/>
                 </a:solidFill>
                 <a:latin typeface="Calibri"/>
               </a:rPr>
-              <a:t>Attach a lightweight integrity tag and a compact statistical fingerprint (per-layer L2 norm + cosine similarity to consensus) to every client update.</a:t>
-            </a:r>
-          </a:p>
-        </p:txBody>
-      </p:sp>
-      <p:sp>
-        <p:nvSpPr>
-          <p:cNvPr id="10" name="Rounded Rectangle 9"/>
+              <a:t>Every unit of this course shows up somewhere in this project — intrusion detection is fundamentally a networking problem.</a:t>
+            </a:r>
+          </a:p>
+        </p:txBody>
+      </p:sp>
+      <p:sp>
+        <p:nvSpPr>
+          <p:cNvPr id="6" name="Rounded Rectangle 5"/>
           <p:cNvSpPr/>
           <p:nvPr/>
         </p:nvSpPr>
         <p:spPr>
           <a:xfrm>
-            <a:off x="640080" y="3794760"/>
-            <a:ext cx="10881360" cy="1234440"/>
+            <a:off x="640080" y="2423160"/>
+            <a:ext cx="10881360" cy="1280160"/>
           </a:xfrm>
           <a:prstGeom prst="roundRect">
             <a:avLst>
@@ -8222,131 +10331,136 @@
       </p:sp>
       <p:sp>
         <p:nvSpPr>
-          <p:cNvPr id="11" name="TextBox 10"/>
-          <p:cNvSpPr txBox="1"/>
-          <p:nvPr/>
-        </p:nvSpPr>
-        <p:spPr>
-          <a:xfrm>
-            <a:off x="914400" y="3931920"/>
-            <a:ext cx="548640" cy="457200"/>
-          </a:xfrm>
-          <a:prstGeom prst="rect">
-            <a:avLst/>
-          </a:prstGeom>
-          <a:noFill/>
-        </p:spPr>
-        <p:txBody>
-          <a:bodyPr wrap="square" anchor="t">
-            <a:spAutoFit/>
-          </a:bodyPr>
-          <a:lstStyle/>
-          <a:p>
-            <a:pPr algn="l">
-              <a:lnSpc>
-                <a:spcPct val="115000"/>
-              </a:lnSpc>
-            </a:pPr>
-            <a:r>
-              <a:rPr sz="2200" b="1" i="0">
+          <p:cNvPr id="7" name="Rectangle 6"/>
+          <p:cNvSpPr/>
+          <p:nvPr/>
+        </p:nvSpPr>
+        <p:spPr>
+          <a:xfrm>
+            <a:off x="640080" y="2423160"/>
+            <a:ext cx="73152" cy="1280160"/>
+          </a:xfrm>
+          <a:prstGeom prst="rect">
+            <a:avLst/>
+          </a:prstGeom>
+          <a:solidFill>
+            <a:srgbClr val="146B62"/>
+          </a:solidFill>
+          <a:ln>
+            <a:noFill/>
+          </a:ln>
+          <a:effectLst/>
+        </p:spPr>
+        <p:style>
+          <a:lnRef idx="1">
+            <a:schemeClr val="accent1"/>
+          </a:lnRef>
+          <a:fillRef idx="3">
+            <a:schemeClr val="accent1"/>
+          </a:fillRef>
+          <a:effectRef idx="2">
+            <a:schemeClr val="accent1"/>
+          </a:effectRef>
+          <a:fontRef idx="minor">
+            <a:schemeClr val="lt1"/>
+          </a:fontRef>
+        </p:style>
+        <p:txBody>
+          <a:bodyPr rtlCol="0" anchor="ctr"/>
+          <a:lstStyle/>
+          <a:p>
+            <a:pPr algn="ctr"/>
+          </a:p>
+        </p:txBody>
+      </p:sp>
+      <p:sp>
+        <p:nvSpPr>
+          <p:cNvPr id="8" name="TextBox 7"/>
+          <p:cNvSpPr txBox="1"/>
+          <p:nvPr/>
+        </p:nvSpPr>
+        <p:spPr>
+          <a:xfrm>
+            <a:off x="914400" y="2560320"/>
+            <a:ext cx="10332720" cy="274320"/>
+          </a:xfrm>
+          <a:prstGeom prst="rect">
+            <a:avLst/>
+          </a:prstGeom>
+          <a:noFill/>
+        </p:spPr>
+        <p:txBody>
+          <a:bodyPr wrap="square" anchor="t">
+            <a:spAutoFit/>
+          </a:bodyPr>
+          <a:lstStyle/>
+          <a:p>
+            <a:pPr algn="l">
+              <a:lnSpc>
+                <a:spcPct val="115000"/>
+              </a:lnSpc>
+            </a:pPr>
+            <a:r>
+              <a:rPr sz="1200" b="1" i="0">
                 <a:solidFill>
                   <a:srgbClr val="146B62"/>
                 </a:solidFill>
-                <a:latin typeface="Arial Black"/>
-              </a:rPr>
-              <a:t>2</a:t>
-            </a:r>
-          </a:p>
-        </p:txBody>
-      </p:sp>
-      <p:sp>
-        <p:nvSpPr>
-          <p:cNvPr id="12" name="TextBox 11"/>
-          <p:cNvSpPr txBox="1"/>
-          <p:nvPr/>
-        </p:nvSpPr>
-        <p:spPr>
-          <a:xfrm>
-            <a:off x="1554480" y="3931920"/>
-            <a:ext cx="9692640" cy="274320"/>
-          </a:xfrm>
-          <a:prstGeom prst="rect">
-            <a:avLst/>
-          </a:prstGeom>
-          <a:noFill/>
-        </p:spPr>
-        <p:txBody>
-          <a:bodyPr wrap="square" anchor="t">
-            <a:spAutoFit/>
-          </a:bodyPr>
-          <a:lstStyle/>
-          <a:p>
-            <a:pPr algn="l">
-              <a:lnSpc>
-                <a:spcPct val="115000"/>
-              </a:lnSpc>
-            </a:pPr>
-            <a:r>
-              <a:rPr sz="1400" b="1" i="0">
+                <a:latin typeface="Calibri"/>
+              </a:rPr>
+              <a:t>UNIT 1 — NETWORK EDGE, OSI LAYERS, PACKET SWITCHING</a:t>
+            </a:r>
+          </a:p>
+        </p:txBody>
+      </p:sp>
+      <p:sp>
+        <p:nvSpPr>
+          <p:cNvPr id="9" name="TextBox 8"/>
+          <p:cNvSpPr txBox="1"/>
+          <p:nvPr/>
+        </p:nvSpPr>
+        <p:spPr>
+          <a:xfrm>
+            <a:off x="914400" y="2880360"/>
+            <a:ext cx="10332720" cy="777240"/>
+          </a:xfrm>
+          <a:prstGeom prst="rect">
+            <a:avLst/>
+          </a:prstGeom>
+          <a:noFill/>
+        </p:spPr>
+        <p:txBody>
+          <a:bodyPr wrap="square" anchor="t">
+            <a:spAutoFit/>
+          </a:bodyPr>
+          <a:lstStyle/>
+          <a:p>
+            <a:pPr algn="l">
+              <a:lnSpc>
+                <a:spcPct val="115000"/>
+              </a:lnSpc>
+            </a:pPr>
+            <a:r>
+              <a:rPr sz="1250" b="0" i="0">
                 <a:solidFill>
                   <a:srgbClr val="172420"/>
                 </a:solidFill>
                 <a:latin typeface="Calibri"/>
               </a:rPr>
-              <a:t>One poisoning attack</a:t>
-            </a:r>
-          </a:p>
-        </p:txBody>
-      </p:sp>
-      <p:sp>
-        <p:nvSpPr>
-          <p:cNvPr id="13" name="TextBox 12"/>
-          <p:cNvSpPr txBox="1"/>
-          <p:nvPr/>
-        </p:nvSpPr>
-        <p:spPr>
-          <a:xfrm>
-            <a:off x="1554480" y="4251960"/>
-            <a:ext cx="9692640" cy="685800"/>
-          </a:xfrm>
-          <a:prstGeom prst="rect">
-            <a:avLst/>
-          </a:prstGeom>
-          <a:noFill/>
-        </p:spPr>
-        <p:txBody>
-          <a:bodyPr wrap="square" anchor="t">
-            <a:spAutoFit/>
-          </a:bodyPr>
-          <a:lstStyle/>
-          <a:p>
-            <a:pPr algn="l">
-              <a:lnSpc>
-                <a:spcPct val="115000"/>
-              </a:lnSpc>
-            </a:pPr>
-            <a:r>
-              <a:rPr sz="1200" b="0" i="0">
-                <a:solidFill>
-                  <a:srgbClr val="56655D"/>
-                </a:solidFill>
-                <a:latin typeface="Calibri"/>
-              </a:rPr>
-              <a:t>Simulate label-flipping attacks from malicious clients to have something real to test detection against.</a:t>
-            </a:r>
-          </a:p>
-        </p:txBody>
-      </p:sp>
-      <p:sp>
-        <p:nvSpPr>
-          <p:cNvPr id="14" name="Rounded Rectangle 13"/>
+              <a:t>Every FLNET2023 record is a network flow captured at a router: ports, packet counts and sizes, TCP flags, inter-arrival times. Our federated clients ARE routers — network edge nodes.</a:t>
+            </a:r>
+          </a:p>
+        </p:txBody>
+      </p:sp>
+      <p:sp>
+        <p:nvSpPr>
+          <p:cNvPr id="10" name="Rounded Rectangle 9"/>
           <p:cNvSpPr/>
           <p:nvPr/>
         </p:nvSpPr>
         <p:spPr>
           <a:xfrm>
-            <a:off x="640080" y="5212080"/>
-            <a:ext cx="10881360" cy="1234440"/>
+            <a:off x="640080" y="3886200"/>
+            <a:ext cx="10881360" cy="1280160"/>
           </a:xfrm>
           <a:prstGeom prst="roundRect">
             <a:avLst>
@@ -8387,40 +10501,215 @@
       </p:sp>
       <p:sp>
         <p:nvSpPr>
-          <p:cNvPr id="15" name="TextBox 14"/>
-          <p:cNvSpPr txBox="1"/>
-          <p:nvPr/>
-        </p:nvSpPr>
-        <p:spPr>
-          <a:xfrm>
-            <a:off x="914400" y="5349240"/>
-            <a:ext cx="548640" cy="457200"/>
-          </a:xfrm>
-          <a:prstGeom prst="rect">
-            <a:avLst/>
-          </a:prstGeom>
-          <a:noFill/>
-        </p:spPr>
-        <p:txBody>
-          <a:bodyPr wrap="square" anchor="t">
-            <a:spAutoFit/>
-          </a:bodyPr>
-          <a:lstStyle/>
-          <a:p>
-            <a:pPr algn="l">
-              <a:lnSpc>
-                <a:spcPct val="115000"/>
-              </a:lnSpc>
-            </a:pPr>
-            <a:r>
-              <a:rPr sz="2200" b="1" i="0">
+          <p:cNvPr id="11" name="Rectangle 10"/>
+          <p:cNvSpPr/>
+          <p:nvPr/>
+        </p:nvSpPr>
+        <p:spPr>
+          <a:xfrm>
+            <a:off x="640080" y="3886200"/>
+            <a:ext cx="73152" cy="1280160"/>
+          </a:xfrm>
+          <a:prstGeom prst="rect">
+            <a:avLst/>
+          </a:prstGeom>
+          <a:solidFill>
+            <a:srgbClr val="146B62"/>
+          </a:solidFill>
+          <a:ln>
+            <a:noFill/>
+          </a:ln>
+          <a:effectLst/>
+        </p:spPr>
+        <p:style>
+          <a:lnRef idx="1">
+            <a:schemeClr val="accent1"/>
+          </a:lnRef>
+          <a:fillRef idx="3">
+            <a:schemeClr val="accent1"/>
+          </a:fillRef>
+          <a:effectRef idx="2">
+            <a:schemeClr val="accent1"/>
+          </a:effectRef>
+          <a:fontRef idx="minor">
+            <a:schemeClr val="lt1"/>
+          </a:fontRef>
+        </p:style>
+        <p:txBody>
+          <a:bodyPr rtlCol="0" anchor="ctr"/>
+          <a:lstStyle/>
+          <a:p>
+            <a:pPr algn="ctr"/>
+          </a:p>
+        </p:txBody>
+      </p:sp>
+      <p:sp>
+        <p:nvSpPr>
+          <p:cNvPr id="12" name="TextBox 11"/>
+          <p:cNvSpPr txBox="1"/>
+          <p:nvPr/>
+        </p:nvSpPr>
+        <p:spPr>
+          <a:xfrm>
+            <a:off x="914400" y="4023360"/>
+            <a:ext cx="10332720" cy="274320"/>
+          </a:xfrm>
+          <a:prstGeom prst="rect">
+            <a:avLst/>
+          </a:prstGeom>
+          <a:noFill/>
+        </p:spPr>
+        <p:txBody>
+          <a:bodyPr wrap="square" anchor="t">
+            <a:spAutoFit/>
+          </a:bodyPr>
+          <a:lstStyle/>
+          <a:p>
+            <a:pPr algn="l">
+              <a:lnSpc>
+                <a:spcPct val="115000"/>
+              </a:lnSpc>
+            </a:pPr>
+            <a:r>
+              <a:rPr sz="1200" b="1" i="0">
                 <a:solidFill>
                   <a:srgbClr val="146B62"/>
                 </a:solidFill>
-                <a:latin typeface="Arial Black"/>
-              </a:rPr>
-              <a:t>3</a:t>
-            </a:r>
+                <a:latin typeface="Calibri"/>
+              </a:rPr>
+              <a:t>UNIT 2 — APPLICATION LAYER, TRANSPORT LAYER, SOCKETS, ROUTING</a:t>
+            </a:r>
+          </a:p>
+        </p:txBody>
+      </p:sp>
+      <p:sp>
+        <p:nvSpPr>
+          <p:cNvPr id="13" name="TextBox 12"/>
+          <p:cNvSpPr txBox="1"/>
+          <p:nvPr/>
+        </p:nvSpPr>
+        <p:spPr>
+          <a:xfrm>
+            <a:off x="914400" y="4343400"/>
+            <a:ext cx="10332720" cy="777240"/>
+          </a:xfrm>
+          <a:prstGeom prst="rect">
+            <a:avLst/>
+          </a:prstGeom>
+          <a:noFill/>
+        </p:spPr>
+        <p:txBody>
+          <a:bodyPr wrap="square" anchor="t">
+            <a:spAutoFit/>
+          </a:bodyPr>
+          <a:lstStyle/>
+          <a:p>
+            <a:pPr algn="l">
+              <a:lnSpc>
+                <a:spcPct val="115000"/>
+              </a:lnSpc>
+            </a:pPr>
+            <a:r>
+              <a:rPr sz="1250" b="0" i="0">
+                <a:solidFill>
+                  <a:srgbClr val="172420"/>
+                </a:solidFill>
+                <a:latin typeface="Calibri"/>
+              </a:rPr>
+              <a:t>Our custom protocol design is application-layer protocol design (vs. HTTP/gRPC). Client-server exchange mirrors socket-based communication. dst_host_count ties to routing/host addressing.</a:t>
+            </a:r>
+          </a:p>
+        </p:txBody>
+      </p:sp>
+      <p:sp>
+        <p:nvSpPr>
+          <p:cNvPr id="14" name="Rounded Rectangle 13"/>
+          <p:cNvSpPr/>
+          <p:nvPr/>
+        </p:nvSpPr>
+        <p:spPr>
+          <a:xfrm>
+            <a:off x="640080" y="5349240"/>
+            <a:ext cx="10881360" cy="1280160"/>
+          </a:xfrm>
+          <a:prstGeom prst="roundRect">
+            <a:avLst>
+              <a:gd name="adj" fmla="val 5000"/>
+            </a:avLst>
+          </a:prstGeom>
+          <a:solidFill>
+            <a:srgbClr val="FFFFFF"/>
+          </a:solidFill>
+          <a:ln w="12700">
+            <a:solidFill>
+              <a:srgbClr val="CFD6CB"/>
+            </a:solidFill>
+          </a:ln>
+          <a:effectLst/>
+        </p:spPr>
+        <p:style>
+          <a:lnRef idx="1">
+            <a:schemeClr val="accent1"/>
+          </a:lnRef>
+          <a:fillRef idx="3">
+            <a:schemeClr val="accent1"/>
+          </a:fillRef>
+          <a:effectRef idx="2">
+            <a:schemeClr val="accent1"/>
+          </a:effectRef>
+          <a:fontRef idx="minor">
+            <a:schemeClr val="lt1"/>
+          </a:fontRef>
+        </p:style>
+        <p:txBody>
+          <a:bodyPr rtlCol="0" anchor="ctr"/>
+          <a:lstStyle/>
+          <a:p>
+            <a:pPr algn="ctr"/>
+          </a:p>
+        </p:txBody>
+      </p:sp>
+      <p:sp>
+        <p:nvSpPr>
+          <p:cNvPr id="15" name="Rectangle 14"/>
+          <p:cNvSpPr/>
+          <p:nvPr/>
+        </p:nvSpPr>
+        <p:spPr>
+          <a:xfrm>
+            <a:off x="640080" y="5349240"/>
+            <a:ext cx="73152" cy="1280160"/>
+          </a:xfrm>
+          <a:prstGeom prst="rect">
+            <a:avLst/>
+          </a:prstGeom>
+          <a:solidFill>
+            <a:srgbClr val="146B62"/>
+          </a:solidFill>
+          <a:ln>
+            <a:noFill/>
+          </a:ln>
+          <a:effectLst/>
+        </p:spPr>
+        <p:style>
+          <a:lnRef idx="1">
+            <a:schemeClr val="accent1"/>
+          </a:lnRef>
+          <a:fillRef idx="3">
+            <a:schemeClr val="accent1"/>
+          </a:fillRef>
+          <a:effectRef idx="2">
+            <a:schemeClr val="accent1"/>
+          </a:effectRef>
+          <a:fontRef idx="minor">
+            <a:schemeClr val="lt1"/>
+          </a:fontRef>
+        </p:style>
+        <p:txBody>
+          <a:bodyPr rtlCol="0" anchor="ctr"/>
+          <a:lstStyle/>
+          <a:p>
+            <a:pPr algn="ctr"/>
           </a:p>
         </p:txBody>
       </p:sp>
@@ -8432,72 +10721,72 @@
         </p:nvSpPr>
         <p:spPr>
           <a:xfrm>
-            <a:off x="1554480" y="5349240"/>
-            <a:ext cx="9692640" cy="274320"/>
-          </a:xfrm>
-          <a:prstGeom prst="rect">
-            <a:avLst/>
-          </a:prstGeom>
-          <a:noFill/>
-        </p:spPr>
-        <p:txBody>
-          <a:bodyPr wrap="square" anchor="t">
-            <a:spAutoFit/>
-          </a:bodyPr>
-          <a:lstStyle/>
-          <a:p>
-            <a:pPr algn="l">
-              <a:lnSpc>
-                <a:spcPct val="115000"/>
-              </a:lnSpc>
-            </a:pPr>
-            <a:r>
-              <a:rPr sz="1400" b="1" i="0">
+            <a:off x="914400" y="5486400"/>
+            <a:ext cx="10332720" cy="274320"/>
+          </a:xfrm>
+          <a:prstGeom prst="rect">
+            <a:avLst/>
+          </a:prstGeom>
+          <a:noFill/>
+        </p:spPr>
+        <p:txBody>
+          <a:bodyPr wrap="square" anchor="t">
+            <a:spAutoFit/>
+          </a:bodyPr>
+          <a:lstStyle/>
+          <a:p>
+            <a:pPr algn="l">
+              <a:lnSpc>
+                <a:spcPct val="115000"/>
+              </a:lnSpc>
+            </a:pPr>
+            <a:r>
+              <a:rPr sz="1200" b="1" i="0">
+                <a:solidFill>
+                  <a:srgbClr val="146B62"/>
+                </a:solidFill>
+                <a:latin typeface="Calibri"/>
+              </a:rPr>
+              <a:t>UNIT 3 — IOT, FOG/CLOUD COMPUTING, SDN</a:t>
+            </a:r>
+          </a:p>
+        </p:txBody>
+      </p:sp>
+      <p:sp>
+        <p:nvSpPr>
+          <p:cNvPr id="17" name="TextBox 16"/>
+          <p:cNvSpPr txBox="1"/>
+          <p:nvPr/>
+        </p:nvSpPr>
+        <p:spPr>
+          <a:xfrm>
+            <a:off x="914400" y="5806440"/>
+            <a:ext cx="10332720" cy="777240"/>
+          </a:xfrm>
+          <a:prstGeom prst="rect">
+            <a:avLst/>
+          </a:prstGeom>
+          <a:noFill/>
+        </p:spPr>
+        <p:txBody>
+          <a:bodyPr wrap="square" anchor="t">
+            <a:spAutoFit/>
+          </a:bodyPr>
+          <a:lstStyle/>
+          <a:p>
+            <a:pPr algn="l">
+              <a:lnSpc>
+                <a:spcPct val="115000"/>
+              </a:lnSpc>
+            </a:pPr>
+            <a:r>
+              <a:rPr sz="1250" b="0" i="0">
                 <a:solidFill>
                   <a:srgbClr val="172420"/>
                 </a:solidFill>
                 <a:latin typeface="Calibri"/>
               </a:rPr>
-              <a:t>Global vs. Mondrian threshold comparison</a:t>
-            </a:r>
-          </a:p>
-        </p:txBody>
-      </p:sp>
-      <p:sp>
-        <p:nvSpPr>
-          <p:cNvPr id="17" name="TextBox 16"/>
-          <p:cNvSpPr txBox="1"/>
-          <p:nvPr/>
-        </p:nvSpPr>
-        <p:spPr>
-          <a:xfrm>
-            <a:off x="1554480" y="5669280"/>
-            <a:ext cx="9692640" cy="685800"/>
-          </a:xfrm>
-          <a:prstGeom prst="rect">
-            <a:avLst/>
-          </a:prstGeom>
-          <a:noFill/>
-        </p:spPr>
-        <p:txBody>
-          <a:bodyPr wrap="square" anchor="t">
-            <a:spAutoFit/>
-          </a:bodyPr>
-          <a:lstStyle/>
-          <a:p>
-            <a:pPr algn="l">
-              <a:lnSpc>
-                <a:spcPct val="115000"/>
-              </a:lnSpc>
-            </a:pPr>
-            <a:r>
-              <a:rPr sz="1200" b="0" i="0">
-                <a:solidFill>
-                  <a:srgbClr val="56655D"/>
-                </a:solidFill>
-                <a:latin typeface="Calibri"/>
-              </a:rPr>
-              <a:t>The core experiment: does one global anomaly threshold wrongly flag honest non-IID clients, and does a per-cluster threshold fix that without losing real detection?</a:t>
+              <a:t>Federated Learning's architecture IS fog computing: local processing at the edge, summarized results to a central aggregator. Our custom protocol mirrors SDN/OpenFlow — customizing behavior beyond fixed defaults.</a:t>
             </a:r>
           </a:p>
         </p:txBody>

</xml_diff>

<commit_message>
Add multi-class results, rebuild slides and handbook, fix README
- results/multiclass.json: 11-class detection; router-split FedAvg
  reaches macro-F1 0.389 vs 0.759 IID and 0.790 centralized, with 0%
  recall on every attack type held by only one or two routers
- README: Phase 10 write-up; remove a duplicated Phase 7-8 block that
  the previous commit introduced; updated next steps
- Slides: multi-class finding, clearer label for the FLNET2023
  backdoor row (attack failed even undefended)
- Handbook PDF regenerated for the 10-slide deck
- requirements.txt: add reportlab
</commit_message>
<xml_diff>
--- a/presentation/Krypsis_Presentation.pptx
+++ b/presentation/Krypsis_Presentation.pptx
@@ -3606,7 +3606,7 @@
                 </a:solidFill>
                 <a:latin typeface="Calibri"/>
               </a:rPr>
-              <a:t>Binary detection on FLNET2023 is too easy</a:t>
+              <a:t>Binary detection on FLNET2023 is too easy — naming the attack is not</a:t>
             </a:r>
           </a:p>
         </p:txBody>
@@ -3645,7 +3645,7 @@
                 </a:solidFill>
                 <a:latin typeface="Calibri"/>
               </a:rPr>
-              <a:t>One feature alone (forward packet count) scores 97.5%; a 3-level decision tree 99.99%. We checked the 100% instead of trusting it — and moved to multi-class detection.</a:t>
+              <a:t>One feature alone scores 97.5% on attack vs normal. Asked for the exact attack type, federated training on real routers reaches macro-F1 0.39 vs 0.76 with IID data: attacks seen at only one router are never learned.</a:t>
             </a:r>
           </a:p>
         </p:txBody>
@@ -7916,11 +7916,11 @@
             <a:r>
               <a:rPr sz="1350" b="1" i="0">
                 <a:solidFill>
-                  <a:srgbClr val="C97A2B"/>
-                </a:solidFill>
-                <a:latin typeface="Calibri"/>
-              </a:rPr>
-              <a:t>In progress</a:t>
+                  <a:srgbClr val="2E7D4F"/>
+                </a:solidFill>
+                <a:latin typeface="Calibri"/>
+              </a:rPr>
+              <a:t>Complete</a:t>
             </a:r>
           </a:p>
         </p:txBody>
@@ -9691,7 +9691,7 @@
                 </a:solidFill>
                 <a:latin typeface="Calibri"/>
               </a:rPr>
-              <a:t>FLNET2023 · backdoor</a:t>
+              <a:t>FLNET2023 · backdoor (failed)</a:t>
             </a:r>
           </a:p>
         </p:txBody>

</xml_diff>

<commit_message>
Slides: add robustness slide and status row
Adds an 11th slide (dropout figure plus dropout, traffic-shift and scalability cards) and a robustness row on the status slide.
</commit_message>
<xml_diff>
--- a/presentation/Krypsis_Presentation.pptx
+++ b/presentation/Krypsis_Presentation.pptx
@@ -15,6 +15,7 @@
     <p:sldId id="263" r:id="rId14"/>
     <p:sldId id="264" r:id="rId15"/>
     <p:sldId id="265" r:id="rId16"/>
+    <p:sldId id="266" r:id="rId17"/>
   </p:sldIdLst>
   <p:sldSz cx="12191695" cy="6858000" type="screen4x3"/>
   <p:notesSz cx="6858000" cy="9144000"/>
@@ -3441,7 +3442,712 @@
                 </a:solidFill>
                 <a:latin typeface="Calibri"/>
               </a:rPr>
-              <a:t>09  FINDINGS</a:t>
+              <a:t>09  LEARNING</a:t>
+            </a:r>
+          </a:p>
+        </p:txBody>
+      </p:sp>
+      <p:sp>
+        <p:nvSpPr>
+          <p:cNvPr id="4" name="TextBox 3"/>
+          <p:cNvSpPr txBox="1"/>
+          <p:nvPr/>
+        </p:nvSpPr>
+        <p:spPr>
+          <a:xfrm>
+            <a:off x="640080" y="1051560"/>
+            <a:ext cx="10515600" cy="822960"/>
+          </a:xfrm>
+          <a:prstGeom prst="rect">
+            <a:avLst/>
+          </a:prstGeom>
+          <a:noFill/>
+        </p:spPr>
+        <p:txBody>
+          <a:bodyPr wrap="square" anchor="t">
+            <a:spAutoFit/>
+          </a:bodyPr>
+          <a:lstStyle/>
+          <a:p>
+            <a:pPr algn="l">
+              <a:lnSpc>
+                <a:spcPct val="115000"/>
+              </a:lnSpc>
+            </a:pPr>
+            <a:r>
+              <a:rPr sz="3400" b="1" i="0">
+                <a:solidFill>
+                  <a:srgbClr val="172420"/>
+                </a:solidFill>
+                <a:latin typeface="Arial Black"/>
+              </a:rPr>
+              <a:t>How this connects to our syllabus</a:t>
+            </a:r>
+          </a:p>
+        </p:txBody>
+      </p:sp>
+      <p:sp>
+        <p:nvSpPr>
+          <p:cNvPr id="5" name="TextBox 4"/>
+          <p:cNvSpPr txBox="1"/>
+          <p:nvPr/>
+        </p:nvSpPr>
+        <p:spPr>
+          <a:xfrm>
+            <a:off x="640080" y="1783080"/>
+            <a:ext cx="10698480" cy="457200"/>
+          </a:xfrm>
+          <a:prstGeom prst="rect">
+            <a:avLst/>
+          </a:prstGeom>
+          <a:noFill/>
+        </p:spPr>
+        <p:txBody>
+          <a:bodyPr wrap="square" anchor="t">
+            <a:spAutoFit/>
+          </a:bodyPr>
+          <a:lstStyle/>
+          <a:p>
+            <a:pPr algn="l">
+              <a:lnSpc>
+                <a:spcPct val="115000"/>
+              </a:lnSpc>
+            </a:pPr>
+            <a:r>
+              <a:rPr sz="1300" b="0" i="1">
+                <a:solidFill>
+                  <a:srgbClr val="56655D"/>
+                </a:solidFill>
+                <a:latin typeface="Calibri"/>
+              </a:rPr>
+              <a:t>Every unit of this course shows up somewhere in this project — intrusion detection is fundamentally a networking problem.</a:t>
+            </a:r>
+          </a:p>
+        </p:txBody>
+      </p:sp>
+      <p:sp>
+        <p:nvSpPr>
+          <p:cNvPr id="6" name="Rounded Rectangle 5"/>
+          <p:cNvSpPr/>
+          <p:nvPr/>
+        </p:nvSpPr>
+        <p:spPr>
+          <a:xfrm>
+            <a:off x="640080" y="2423160"/>
+            <a:ext cx="10881360" cy="1280160"/>
+          </a:xfrm>
+          <a:prstGeom prst="roundRect">
+            <a:avLst>
+              <a:gd name="adj" fmla="val 5000"/>
+            </a:avLst>
+          </a:prstGeom>
+          <a:solidFill>
+            <a:srgbClr val="FFFFFF"/>
+          </a:solidFill>
+          <a:ln w="12700">
+            <a:solidFill>
+              <a:srgbClr val="CFD6CB"/>
+            </a:solidFill>
+          </a:ln>
+          <a:effectLst/>
+        </p:spPr>
+        <p:style>
+          <a:lnRef idx="1">
+            <a:schemeClr val="accent1"/>
+          </a:lnRef>
+          <a:fillRef idx="3">
+            <a:schemeClr val="accent1"/>
+          </a:fillRef>
+          <a:effectRef idx="2">
+            <a:schemeClr val="accent1"/>
+          </a:effectRef>
+          <a:fontRef idx="minor">
+            <a:schemeClr val="lt1"/>
+          </a:fontRef>
+        </p:style>
+        <p:txBody>
+          <a:bodyPr rtlCol="0" anchor="ctr"/>
+          <a:lstStyle/>
+          <a:p>
+            <a:pPr algn="ctr"/>
+          </a:p>
+        </p:txBody>
+      </p:sp>
+      <p:sp>
+        <p:nvSpPr>
+          <p:cNvPr id="7" name="Rectangle 6"/>
+          <p:cNvSpPr/>
+          <p:nvPr/>
+        </p:nvSpPr>
+        <p:spPr>
+          <a:xfrm>
+            <a:off x="640080" y="2423160"/>
+            <a:ext cx="73152" cy="1280160"/>
+          </a:xfrm>
+          <a:prstGeom prst="rect">
+            <a:avLst/>
+          </a:prstGeom>
+          <a:solidFill>
+            <a:srgbClr val="146B62"/>
+          </a:solidFill>
+          <a:ln>
+            <a:noFill/>
+          </a:ln>
+          <a:effectLst/>
+        </p:spPr>
+        <p:style>
+          <a:lnRef idx="1">
+            <a:schemeClr val="accent1"/>
+          </a:lnRef>
+          <a:fillRef idx="3">
+            <a:schemeClr val="accent1"/>
+          </a:fillRef>
+          <a:effectRef idx="2">
+            <a:schemeClr val="accent1"/>
+          </a:effectRef>
+          <a:fontRef idx="minor">
+            <a:schemeClr val="lt1"/>
+          </a:fontRef>
+        </p:style>
+        <p:txBody>
+          <a:bodyPr rtlCol="0" anchor="ctr"/>
+          <a:lstStyle/>
+          <a:p>
+            <a:pPr algn="ctr"/>
+          </a:p>
+        </p:txBody>
+      </p:sp>
+      <p:sp>
+        <p:nvSpPr>
+          <p:cNvPr id="8" name="TextBox 7"/>
+          <p:cNvSpPr txBox="1"/>
+          <p:nvPr/>
+        </p:nvSpPr>
+        <p:spPr>
+          <a:xfrm>
+            <a:off x="914400" y="2560320"/>
+            <a:ext cx="10332720" cy="274320"/>
+          </a:xfrm>
+          <a:prstGeom prst="rect">
+            <a:avLst/>
+          </a:prstGeom>
+          <a:noFill/>
+        </p:spPr>
+        <p:txBody>
+          <a:bodyPr wrap="square" anchor="t">
+            <a:spAutoFit/>
+          </a:bodyPr>
+          <a:lstStyle/>
+          <a:p>
+            <a:pPr algn="l">
+              <a:lnSpc>
+                <a:spcPct val="115000"/>
+              </a:lnSpc>
+            </a:pPr>
+            <a:r>
+              <a:rPr sz="1200" b="1" i="0">
+                <a:solidFill>
+                  <a:srgbClr val="146B62"/>
+                </a:solidFill>
+                <a:latin typeface="Calibri"/>
+              </a:rPr>
+              <a:t>UNIT 1 — NETWORK EDGE, OSI LAYERS, PACKET SWITCHING</a:t>
+            </a:r>
+          </a:p>
+        </p:txBody>
+      </p:sp>
+      <p:sp>
+        <p:nvSpPr>
+          <p:cNvPr id="9" name="TextBox 8"/>
+          <p:cNvSpPr txBox="1"/>
+          <p:nvPr/>
+        </p:nvSpPr>
+        <p:spPr>
+          <a:xfrm>
+            <a:off x="914400" y="2880360"/>
+            <a:ext cx="10332720" cy="777240"/>
+          </a:xfrm>
+          <a:prstGeom prst="rect">
+            <a:avLst/>
+          </a:prstGeom>
+          <a:noFill/>
+        </p:spPr>
+        <p:txBody>
+          <a:bodyPr wrap="square" anchor="t">
+            <a:spAutoFit/>
+          </a:bodyPr>
+          <a:lstStyle/>
+          <a:p>
+            <a:pPr algn="l">
+              <a:lnSpc>
+                <a:spcPct val="115000"/>
+              </a:lnSpc>
+            </a:pPr>
+            <a:r>
+              <a:rPr sz="1250" b="0" i="0">
+                <a:solidFill>
+                  <a:srgbClr val="172420"/>
+                </a:solidFill>
+                <a:latin typeface="Calibri"/>
+              </a:rPr>
+              <a:t>Every FLNET2023 record is a network flow captured at a router: ports, packet counts and sizes, TCP flags, inter-arrival times. Our federated clients ARE routers — network edge nodes.</a:t>
+            </a:r>
+          </a:p>
+        </p:txBody>
+      </p:sp>
+      <p:sp>
+        <p:nvSpPr>
+          <p:cNvPr id="10" name="Rounded Rectangle 9"/>
+          <p:cNvSpPr/>
+          <p:nvPr/>
+        </p:nvSpPr>
+        <p:spPr>
+          <a:xfrm>
+            <a:off x="640080" y="3886200"/>
+            <a:ext cx="10881360" cy="1280160"/>
+          </a:xfrm>
+          <a:prstGeom prst="roundRect">
+            <a:avLst>
+              <a:gd name="adj" fmla="val 5000"/>
+            </a:avLst>
+          </a:prstGeom>
+          <a:solidFill>
+            <a:srgbClr val="FFFFFF"/>
+          </a:solidFill>
+          <a:ln w="12700">
+            <a:solidFill>
+              <a:srgbClr val="CFD6CB"/>
+            </a:solidFill>
+          </a:ln>
+          <a:effectLst/>
+        </p:spPr>
+        <p:style>
+          <a:lnRef idx="1">
+            <a:schemeClr val="accent1"/>
+          </a:lnRef>
+          <a:fillRef idx="3">
+            <a:schemeClr val="accent1"/>
+          </a:fillRef>
+          <a:effectRef idx="2">
+            <a:schemeClr val="accent1"/>
+          </a:effectRef>
+          <a:fontRef idx="minor">
+            <a:schemeClr val="lt1"/>
+          </a:fontRef>
+        </p:style>
+        <p:txBody>
+          <a:bodyPr rtlCol="0" anchor="ctr"/>
+          <a:lstStyle/>
+          <a:p>
+            <a:pPr algn="ctr"/>
+          </a:p>
+        </p:txBody>
+      </p:sp>
+      <p:sp>
+        <p:nvSpPr>
+          <p:cNvPr id="11" name="Rectangle 10"/>
+          <p:cNvSpPr/>
+          <p:nvPr/>
+        </p:nvSpPr>
+        <p:spPr>
+          <a:xfrm>
+            <a:off x="640080" y="3886200"/>
+            <a:ext cx="73152" cy="1280160"/>
+          </a:xfrm>
+          <a:prstGeom prst="rect">
+            <a:avLst/>
+          </a:prstGeom>
+          <a:solidFill>
+            <a:srgbClr val="146B62"/>
+          </a:solidFill>
+          <a:ln>
+            <a:noFill/>
+          </a:ln>
+          <a:effectLst/>
+        </p:spPr>
+        <p:style>
+          <a:lnRef idx="1">
+            <a:schemeClr val="accent1"/>
+          </a:lnRef>
+          <a:fillRef idx="3">
+            <a:schemeClr val="accent1"/>
+          </a:fillRef>
+          <a:effectRef idx="2">
+            <a:schemeClr val="accent1"/>
+          </a:effectRef>
+          <a:fontRef idx="minor">
+            <a:schemeClr val="lt1"/>
+          </a:fontRef>
+        </p:style>
+        <p:txBody>
+          <a:bodyPr rtlCol="0" anchor="ctr"/>
+          <a:lstStyle/>
+          <a:p>
+            <a:pPr algn="ctr"/>
+          </a:p>
+        </p:txBody>
+      </p:sp>
+      <p:sp>
+        <p:nvSpPr>
+          <p:cNvPr id="12" name="TextBox 11"/>
+          <p:cNvSpPr txBox="1"/>
+          <p:nvPr/>
+        </p:nvSpPr>
+        <p:spPr>
+          <a:xfrm>
+            <a:off x="914400" y="4023360"/>
+            <a:ext cx="10332720" cy="274320"/>
+          </a:xfrm>
+          <a:prstGeom prst="rect">
+            <a:avLst/>
+          </a:prstGeom>
+          <a:noFill/>
+        </p:spPr>
+        <p:txBody>
+          <a:bodyPr wrap="square" anchor="t">
+            <a:spAutoFit/>
+          </a:bodyPr>
+          <a:lstStyle/>
+          <a:p>
+            <a:pPr algn="l">
+              <a:lnSpc>
+                <a:spcPct val="115000"/>
+              </a:lnSpc>
+            </a:pPr>
+            <a:r>
+              <a:rPr sz="1200" b="1" i="0">
+                <a:solidFill>
+                  <a:srgbClr val="146B62"/>
+                </a:solidFill>
+                <a:latin typeface="Calibri"/>
+              </a:rPr>
+              <a:t>UNIT 2 — APPLICATION LAYER, TRANSPORT LAYER, SOCKETS, ROUTING</a:t>
+            </a:r>
+          </a:p>
+        </p:txBody>
+      </p:sp>
+      <p:sp>
+        <p:nvSpPr>
+          <p:cNvPr id="13" name="TextBox 12"/>
+          <p:cNvSpPr txBox="1"/>
+          <p:nvPr/>
+        </p:nvSpPr>
+        <p:spPr>
+          <a:xfrm>
+            <a:off x="914400" y="4343400"/>
+            <a:ext cx="10332720" cy="777240"/>
+          </a:xfrm>
+          <a:prstGeom prst="rect">
+            <a:avLst/>
+          </a:prstGeom>
+          <a:noFill/>
+        </p:spPr>
+        <p:txBody>
+          <a:bodyPr wrap="square" anchor="t">
+            <a:spAutoFit/>
+          </a:bodyPr>
+          <a:lstStyle/>
+          <a:p>
+            <a:pPr algn="l">
+              <a:lnSpc>
+                <a:spcPct val="115000"/>
+              </a:lnSpc>
+            </a:pPr>
+            <a:r>
+              <a:rPr sz="1250" b="0" i="0">
+                <a:solidFill>
+                  <a:srgbClr val="172420"/>
+                </a:solidFill>
+                <a:latin typeface="Calibri"/>
+              </a:rPr>
+              <a:t>Our custom protocol design is application-layer protocol design (vs. HTTP/gRPC). Client-server exchange mirrors socket-based communication. dst_host_count ties to routing/host addressing.</a:t>
+            </a:r>
+          </a:p>
+        </p:txBody>
+      </p:sp>
+      <p:sp>
+        <p:nvSpPr>
+          <p:cNvPr id="14" name="Rounded Rectangle 13"/>
+          <p:cNvSpPr/>
+          <p:nvPr/>
+        </p:nvSpPr>
+        <p:spPr>
+          <a:xfrm>
+            <a:off x="640080" y="5349240"/>
+            <a:ext cx="10881360" cy="1280160"/>
+          </a:xfrm>
+          <a:prstGeom prst="roundRect">
+            <a:avLst>
+              <a:gd name="adj" fmla="val 5000"/>
+            </a:avLst>
+          </a:prstGeom>
+          <a:solidFill>
+            <a:srgbClr val="FFFFFF"/>
+          </a:solidFill>
+          <a:ln w="12700">
+            <a:solidFill>
+              <a:srgbClr val="CFD6CB"/>
+            </a:solidFill>
+          </a:ln>
+          <a:effectLst/>
+        </p:spPr>
+        <p:style>
+          <a:lnRef idx="1">
+            <a:schemeClr val="accent1"/>
+          </a:lnRef>
+          <a:fillRef idx="3">
+            <a:schemeClr val="accent1"/>
+          </a:fillRef>
+          <a:effectRef idx="2">
+            <a:schemeClr val="accent1"/>
+          </a:effectRef>
+          <a:fontRef idx="minor">
+            <a:schemeClr val="lt1"/>
+          </a:fontRef>
+        </p:style>
+        <p:txBody>
+          <a:bodyPr rtlCol="0" anchor="ctr"/>
+          <a:lstStyle/>
+          <a:p>
+            <a:pPr algn="ctr"/>
+          </a:p>
+        </p:txBody>
+      </p:sp>
+      <p:sp>
+        <p:nvSpPr>
+          <p:cNvPr id="15" name="Rectangle 14"/>
+          <p:cNvSpPr/>
+          <p:nvPr/>
+        </p:nvSpPr>
+        <p:spPr>
+          <a:xfrm>
+            <a:off x="640080" y="5349240"/>
+            <a:ext cx="73152" cy="1280160"/>
+          </a:xfrm>
+          <a:prstGeom prst="rect">
+            <a:avLst/>
+          </a:prstGeom>
+          <a:solidFill>
+            <a:srgbClr val="146B62"/>
+          </a:solidFill>
+          <a:ln>
+            <a:noFill/>
+          </a:ln>
+          <a:effectLst/>
+        </p:spPr>
+        <p:style>
+          <a:lnRef idx="1">
+            <a:schemeClr val="accent1"/>
+          </a:lnRef>
+          <a:fillRef idx="3">
+            <a:schemeClr val="accent1"/>
+          </a:fillRef>
+          <a:effectRef idx="2">
+            <a:schemeClr val="accent1"/>
+          </a:effectRef>
+          <a:fontRef idx="minor">
+            <a:schemeClr val="lt1"/>
+          </a:fontRef>
+        </p:style>
+        <p:txBody>
+          <a:bodyPr rtlCol="0" anchor="ctr"/>
+          <a:lstStyle/>
+          <a:p>
+            <a:pPr algn="ctr"/>
+          </a:p>
+        </p:txBody>
+      </p:sp>
+      <p:sp>
+        <p:nvSpPr>
+          <p:cNvPr id="16" name="TextBox 15"/>
+          <p:cNvSpPr txBox="1"/>
+          <p:nvPr/>
+        </p:nvSpPr>
+        <p:spPr>
+          <a:xfrm>
+            <a:off x="914400" y="5486400"/>
+            <a:ext cx="10332720" cy="274320"/>
+          </a:xfrm>
+          <a:prstGeom prst="rect">
+            <a:avLst/>
+          </a:prstGeom>
+          <a:noFill/>
+        </p:spPr>
+        <p:txBody>
+          <a:bodyPr wrap="square" anchor="t">
+            <a:spAutoFit/>
+          </a:bodyPr>
+          <a:lstStyle/>
+          <a:p>
+            <a:pPr algn="l">
+              <a:lnSpc>
+                <a:spcPct val="115000"/>
+              </a:lnSpc>
+            </a:pPr>
+            <a:r>
+              <a:rPr sz="1200" b="1" i="0">
+                <a:solidFill>
+                  <a:srgbClr val="146B62"/>
+                </a:solidFill>
+                <a:latin typeface="Calibri"/>
+              </a:rPr>
+              <a:t>UNIT 3 — IOT, FOG/CLOUD COMPUTING, SDN</a:t>
+            </a:r>
+          </a:p>
+        </p:txBody>
+      </p:sp>
+      <p:sp>
+        <p:nvSpPr>
+          <p:cNvPr id="17" name="TextBox 16"/>
+          <p:cNvSpPr txBox="1"/>
+          <p:nvPr/>
+        </p:nvSpPr>
+        <p:spPr>
+          <a:xfrm>
+            <a:off x="914400" y="5806440"/>
+            <a:ext cx="10332720" cy="777240"/>
+          </a:xfrm>
+          <a:prstGeom prst="rect">
+            <a:avLst/>
+          </a:prstGeom>
+          <a:noFill/>
+        </p:spPr>
+        <p:txBody>
+          <a:bodyPr wrap="square" anchor="t">
+            <a:spAutoFit/>
+          </a:bodyPr>
+          <a:lstStyle/>
+          <a:p>
+            <a:pPr algn="l">
+              <a:lnSpc>
+                <a:spcPct val="115000"/>
+              </a:lnSpc>
+            </a:pPr>
+            <a:r>
+              <a:rPr sz="1250" b="0" i="0">
+                <a:solidFill>
+                  <a:srgbClr val="172420"/>
+                </a:solidFill>
+                <a:latin typeface="Calibri"/>
+              </a:rPr>
+              <a:t>Federated Learning's architecture IS fog computing: local processing at the edge, summarized results to a central aggregator. Our custom protocol mirrors SDN/OpenFlow — customizing behavior beyond fixed defaults.</a:t>
+            </a:r>
+          </a:p>
+        </p:txBody>
+      </p:sp>
+    </p:spTree>
+  </p:cSld>
+  <p:clrMapOvr>
+    <a:masterClrMapping/>
+  </p:clrMapOvr>
+</p:sld>
+</file>
+
+<file path=ppt/slides/slide11.xml><?xml version="1.0" encoding="utf-8"?>
+<p:sld xmlns:a="http://schemas.openxmlformats.org/drawingml/2006/main" xmlns:p="http://schemas.openxmlformats.org/presentationml/2006/main" xmlns:r="http://schemas.openxmlformats.org/officeDocument/2006/relationships">
+  <p:cSld>
+    <p:spTree>
+      <p:nvGrpSpPr>
+        <p:cNvPr id="1" name=""/>
+        <p:cNvGrpSpPr/>
+        <p:nvPr/>
+      </p:nvGrpSpPr>
+      <p:grpSpPr/>
+      <p:sp>
+        <p:nvSpPr>
+          <p:cNvPr id="2" name="Rectangle 1"/>
+          <p:cNvSpPr/>
+          <p:nvPr/>
+        </p:nvSpPr>
+        <p:spPr>
+          <a:xfrm>
+            <a:off x="0" y="0"/>
+            <a:ext cx="12191695" cy="6858000"/>
+          </a:xfrm>
+          <a:prstGeom prst="rect">
+            <a:avLst/>
+          </a:prstGeom>
+          <a:solidFill>
+            <a:srgbClr val="F2F4F0"/>
+          </a:solidFill>
+          <a:ln>
+            <a:noFill/>
+          </a:ln>
+          <a:effectLst/>
+        </p:spPr>
+        <p:style>
+          <a:lnRef idx="1">
+            <a:schemeClr val="accent1"/>
+          </a:lnRef>
+          <a:fillRef idx="3">
+            <a:schemeClr val="accent1"/>
+          </a:fillRef>
+          <a:effectRef idx="2">
+            <a:schemeClr val="accent1"/>
+          </a:effectRef>
+          <a:fontRef idx="minor">
+            <a:schemeClr val="lt1"/>
+          </a:fontRef>
+        </p:style>
+        <p:txBody>
+          <a:bodyPr rtlCol="0" anchor="ctr"/>
+          <a:lstStyle/>
+          <a:p>
+            <a:pPr algn="ctr"/>
+          </a:p>
+        </p:txBody>
+      </p:sp>
+      <p:sp>
+        <p:nvSpPr>
+          <p:cNvPr id="3" name="Rounded Rectangle 2"/>
+          <p:cNvSpPr/>
+          <p:nvPr/>
+        </p:nvSpPr>
+        <p:spPr>
+          <a:xfrm>
+            <a:off x="640080" y="502920"/>
+            <a:ext cx="2377440" cy="384048"/>
+          </a:xfrm>
+          <a:prstGeom prst="roundRect">
+            <a:avLst>
+              <a:gd name="adj" fmla="val 50000"/>
+            </a:avLst>
+          </a:prstGeom>
+          <a:solidFill>
+            <a:srgbClr val="D7EBE7"/>
+          </a:solidFill>
+          <a:ln>
+            <a:noFill/>
+          </a:ln>
+          <a:effectLst/>
+        </p:spPr>
+        <p:style>
+          <a:lnRef idx="1">
+            <a:schemeClr val="accent1"/>
+          </a:lnRef>
+          <a:fillRef idx="3">
+            <a:schemeClr val="accent1"/>
+          </a:fillRef>
+          <a:effectRef idx="2">
+            <a:schemeClr val="accent1"/>
+          </a:effectRef>
+          <a:fontRef idx="minor">
+            <a:schemeClr val="lt1"/>
+          </a:fontRef>
+        </p:style>
+        <p:txBody>
+          <a:bodyPr rtlCol="0" anchor="ctr" wrap="none"/>
+          <a:lstStyle/>
+          <a:p>
+            <a:pPr algn="ctr"/>
+            <a:r>
+              <a:rPr sz="1200" b="1">
+                <a:solidFill>
+                  <a:srgbClr val="146B62"/>
+                </a:solidFill>
+                <a:latin typeface="Calibri"/>
+              </a:rPr>
+              <a:t>10  FINDINGS</a:t>
             </a:r>
           </a:p>
         </p:txBody>
@@ -7466,7 +8172,7 @@
         <p:spPr>
           <a:xfrm>
             <a:off x="914400" y="3611880"/>
-            <a:ext cx="7772400" cy="457200"/>
+            <a:ext cx="7772400" cy="393192"/>
           </a:xfrm>
           <a:prstGeom prst="rect">
             <a:avLst/>
@@ -7505,7 +8211,7 @@
         <p:spPr>
           <a:xfrm>
             <a:off x="8869680" y="3611880"/>
-            <a:ext cx="2468880" cy="457200"/>
+            <a:ext cx="2468880" cy="393192"/>
           </a:xfrm>
           <a:prstGeom prst="rect">
             <a:avLst/>
@@ -7543,8 +8249,8 @@
         </p:nvSpPr>
         <p:spPr>
           <a:xfrm>
-            <a:off x="914400" y="4069080"/>
-            <a:ext cx="7772400" cy="457200"/>
+            <a:off x="914400" y="4005072"/>
+            <a:ext cx="7772400" cy="393192"/>
           </a:xfrm>
           <a:prstGeom prst="rect">
             <a:avLst/>
@@ -7582,8 +8288,8 @@
         </p:nvSpPr>
         <p:spPr>
           <a:xfrm>
-            <a:off x="8869680" y="4069080"/>
-            <a:ext cx="2468880" cy="457200"/>
+            <a:off x="8869680" y="4005072"/>
+            <a:ext cx="2468880" cy="393192"/>
           </a:xfrm>
           <a:prstGeom prst="rect">
             <a:avLst/>
@@ -7621,8 +8327,8 @@
         </p:nvSpPr>
         <p:spPr>
           <a:xfrm>
-            <a:off x="914400" y="4526280"/>
-            <a:ext cx="7772400" cy="457200"/>
+            <a:off x="914400" y="4398264"/>
+            <a:ext cx="7772400" cy="393192"/>
           </a:xfrm>
           <a:prstGeom prst="rect">
             <a:avLst/>
@@ -7660,8 +8366,8 @@
         </p:nvSpPr>
         <p:spPr>
           <a:xfrm>
-            <a:off x="8869680" y="4526280"/>
-            <a:ext cx="2468880" cy="457200"/>
+            <a:off x="8869680" y="4398264"/>
+            <a:ext cx="2468880" cy="393192"/>
           </a:xfrm>
           <a:prstGeom prst="rect">
             <a:avLst/>
@@ -7699,8 +8405,8 @@
         </p:nvSpPr>
         <p:spPr>
           <a:xfrm>
-            <a:off x="914400" y="4983480"/>
-            <a:ext cx="7772400" cy="457200"/>
+            <a:off x="914400" y="4791456"/>
+            <a:ext cx="7772400" cy="393192"/>
           </a:xfrm>
           <a:prstGeom prst="rect">
             <a:avLst/>
@@ -7738,8 +8444,8 @@
         </p:nvSpPr>
         <p:spPr>
           <a:xfrm>
-            <a:off x="8869680" y="4983480"/>
-            <a:ext cx="2468880" cy="457200"/>
+            <a:off x="8869680" y="4791456"/>
+            <a:ext cx="2468880" cy="393192"/>
           </a:xfrm>
           <a:prstGeom prst="rect">
             <a:avLst/>
@@ -7777,8 +8483,8 @@
         </p:nvSpPr>
         <p:spPr>
           <a:xfrm>
-            <a:off x="914400" y="5440680"/>
-            <a:ext cx="7772400" cy="457200"/>
+            <a:off x="914400" y="5184648"/>
+            <a:ext cx="7772400" cy="393192"/>
           </a:xfrm>
           <a:prstGeom prst="rect">
             <a:avLst/>
@@ -7816,8 +8522,8 @@
         </p:nvSpPr>
         <p:spPr>
           <a:xfrm>
-            <a:off x="8869680" y="5440680"/>
-            <a:ext cx="2468880" cy="457200"/>
+            <a:off x="8869680" y="5184648"/>
+            <a:ext cx="2468880" cy="393192"/>
           </a:xfrm>
           <a:prstGeom prst="rect">
             <a:avLst/>
@@ -7855,8 +8561,8 @@
         </p:nvSpPr>
         <p:spPr>
           <a:xfrm>
-            <a:off x="914400" y="5897880"/>
-            <a:ext cx="7772400" cy="457200"/>
+            <a:off x="914400" y="5577840"/>
+            <a:ext cx="7772400" cy="393192"/>
           </a:xfrm>
           <a:prstGeom prst="rect">
             <a:avLst/>
@@ -7881,6 +8587,84 @@
                 </a:solidFill>
                 <a:latin typeface="Calibri"/>
               </a:rPr>
+              <a:t>Robustness: client dropout, traffic shift, 10–40 clients</a:t>
+            </a:r>
+          </a:p>
+        </p:txBody>
+      </p:sp>
+      <p:sp>
+        <p:nvSpPr>
+          <p:cNvPr id="29" name="TextBox 28"/>
+          <p:cNvSpPr txBox="1"/>
+          <p:nvPr/>
+        </p:nvSpPr>
+        <p:spPr>
+          <a:xfrm>
+            <a:off x="8869680" y="5577840"/>
+            <a:ext cx="2468880" cy="393192"/>
+          </a:xfrm>
+          <a:prstGeom prst="rect">
+            <a:avLst/>
+          </a:prstGeom>
+          <a:noFill/>
+        </p:spPr>
+        <p:txBody>
+          <a:bodyPr wrap="square" anchor="t">
+            <a:spAutoFit/>
+          </a:bodyPr>
+          <a:lstStyle/>
+          <a:p>
+            <a:pPr algn="l">
+              <a:lnSpc>
+                <a:spcPct val="115000"/>
+              </a:lnSpc>
+            </a:pPr>
+            <a:r>
+              <a:rPr sz="1350" b="1" i="0">
+                <a:solidFill>
+                  <a:srgbClr val="2E7D4F"/>
+                </a:solidFill>
+                <a:latin typeface="Calibri"/>
+              </a:rPr>
+              <a:t>Complete</a:t>
+            </a:r>
+          </a:p>
+        </p:txBody>
+      </p:sp>
+      <p:sp>
+        <p:nvSpPr>
+          <p:cNvPr id="30" name="TextBox 29"/>
+          <p:cNvSpPr txBox="1"/>
+          <p:nvPr/>
+        </p:nvSpPr>
+        <p:spPr>
+          <a:xfrm>
+            <a:off x="914400" y="5971032"/>
+            <a:ext cx="7772400" cy="393192"/>
+          </a:xfrm>
+          <a:prstGeom prst="rect">
+            <a:avLst/>
+          </a:prstGeom>
+          <a:noFill/>
+        </p:spPr>
+        <p:txBody>
+          <a:bodyPr wrap="square" anchor="t">
+            <a:spAutoFit/>
+          </a:bodyPr>
+          <a:lstStyle/>
+          <a:p>
+            <a:pPr algn="l">
+              <a:lnSpc>
+                <a:spcPct val="115000"/>
+              </a:lnSpc>
+            </a:pPr>
+            <a:r>
+              <a:rPr sz="1350" b="0" i="0">
+                <a:solidFill>
+                  <a:srgbClr val="172420"/>
+                </a:solidFill>
+                <a:latin typeface="Calibri"/>
+              </a:rPr>
               <a:t>Multi-class detection (11 traffic types)</a:t>
             </a:r>
           </a:p>
@@ -7888,14 +8672,14 @@
       </p:sp>
       <p:sp>
         <p:nvSpPr>
-          <p:cNvPr id="29" name="TextBox 28"/>
-          <p:cNvSpPr txBox="1"/>
-          <p:nvPr/>
-        </p:nvSpPr>
-        <p:spPr>
-          <a:xfrm>
-            <a:off x="8869680" y="5897880"/>
-            <a:ext cx="2468880" cy="457200"/>
+          <p:cNvPr id="31" name="TextBox 30"/>
+          <p:cNvSpPr txBox="1"/>
+          <p:nvPr/>
+        </p:nvSpPr>
+        <p:spPr>
+          <a:xfrm>
+            <a:off x="8869680" y="5971032"/>
+            <a:ext cx="2468880" cy="393192"/>
           </a:xfrm>
           <a:prstGeom prst="rect">
             <a:avLst/>
@@ -10198,7 +10982,7 @@
                 </a:solidFill>
                 <a:latin typeface="Calibri"/>
               </a:rPr>
-              <a:t>08  LEARNING</a:t>
+              <a:t>08  ROBUSTNESS</a:t>
             </a:r>
           </a:p>
         </p:txBody>
@@ -10237,7 +11021,7 @@
                 </a:solidFill>
                 <a:latin typeface="Arial Black"/>
               </a:rPr>
-              <a:t>How this connects to our syllabus</a:t>
+              <a:t>Dropout, traffic shift, more clients</a:t>
             </a:r>
           </a:p>
         </p:txBody>
@@ -10276,7 +11060,7 @@
                 </a:solidFill>
                 <a:latin typeface="Calibri"/>
               </a:rPr>
-              <a:t>Every unit of this course shows up somewhere in this project — intrusion detection is fundamentally a networking problem.</a:t>
+              <a:t>FLNET2023 router split, protocol v2, 5 seeds per setting.</a:t>
             </a:r>
           </a:p>
         </p:txBody>
@@ -10289,8 +11073,8 @@
         </p:nvSpPr>
         <p:spPr>
           <a:xfrm>
-            <a:off x="640080" y="2423160"/>
-            <a:ext cx="10881360" cy="1280160"/>
+            <a:off x="640080" y="2286000"/>
+            <a:ext cx="6766560" cy="3108960"/>
           </a:xfrm>
           <a:prstGeom prst="roundRect">
             <a:avLst>
@@ -10329,138 +11113,40 @@
           </a:p>
         </p:txBody>
       </p:sp>
-      <p:sp>
-        <p:nvSpPr>
-          <p:cNvPr id="7" name="Rectangle 6"/>
+      <p:pic>
+        <p:nvPicPr>
+          <p:cNvPr id="7" name="Picture 6" descr="dropout_accuracy.png"/>
+          <p:cNvPicPr>
+            <a:picLocks noChangeAspect="1"/>
+          </p:cNvPicPr>
+          <p:nvPr/>
+        </p:nvPicPr>
+        <p:blipFill>
+          <a:blip r:embed="rId2"/>
+          <a:stretch>
+            <a:fillRect/>
+          </a:stretch>
+        </p:blipFill>
+        <p:spPr>
+          <a:xfrm>
+            <a:off x="731520" y="2377440"/>
+            <a:ext cx="6583680" cy="2839862"/>
+          </a:xfrm>
+          <a:prstGeom prst="rect">
+            <a:avLst/>
+          </a:prstGeom>
+        </p:spPr>
+      </p:pic>
+      <p:sp>
+        <p:nvSpPr>
+          <p:cNvPr id="8" name="Rounded Rectangle 7"/>
           <p:cNvSpPr/>
           <p:nvPr/>
         </p:nvSpPr>
         <p:spPr>
           <a:xfrm>
-            <a:off x="640080" y="2423160"/>
-            <a:ext cx="73152" cy="1280160"/>
-          </a:xfrm>
-          <a:prstGeom prst="rect">
-            <a:avLst/>
-          </a:prstGeom>
-          <a:solidFill>
-            <a:srgbClr val="146B62"/>
-          </a:solidFill>
-          <a:ln>
-            <a:noFill/>
-          </a:ln>
-          <a:effectLst/>
-        </p:spPr>
-        <p:style>
-          <a:lnRef idx="1">
-            <a:schemeClr val="accent1"/>
-          </a:lnRef>
-          <a:fillRef idx="3">
-            <a:schemeClr val="accent1"/>
-          </a:fillRef>
-          <a:effectRef idx="2">
-            <a:schemeClr val="accent1"/>
-          </a:effectRef>
-          <a:fontRef idx="minor">
-            <a:schemeClr val="lt1"/>
-          </a:fontRef>
-        </p:style>
-        <p:txBody>
-          <a:bodyPr rtlCol="0" anchor="ctr"/>
-          <a:lstStyle/>
-          <a:p>
-            <a:pPr algn="ctr"/>
-          </a:p>
-        </p:txBody>
-      </p:sp>
-      <p:sp>
-        <p:nvSpPr>
-          <p:cNvPr id="8" name="TextBox 7"/>
-          <p:cNvSpPr txBox="1"/>
-          <p:nvPr/>
-        </p:nvSpPr>
-        <p:spPr>
-          <a:xfrm>
-            <a:off x="914400" y="2560320"/>
-            <a:ext cx="10332720" cy="274320"/>
-          </a:xfrm>
-          <a:prstGeom prst="rect">
-            <a:avLst/>
-          </a:prstGeom>
-          <a:noFill/>
-        </p:spPr>
-        <p:txBody>
-          <a:bodyPr wrap="square" anchor="t">
-            <a:spAutoFit/>
-          </a:bodyPr>
-          <a:lstStyle/>
-          <a:p>
-            <a:pPr algn="l">
-              <a:lnSpc>
-                <a:spcPct val="115000"/>
-              </a:lnSpc>
-            </a:pPr>
-            <a:r>
-              <a:rPr sz="1200" b="1" i="0">
-                <a:solidFill>
-                  <a:srgbClr val="146B62"/>
-                </a:solidFill>
-                <a:latin typeface="Calibri"/>
-              </a:rPr>
-              <a:t>UNIT 1 — NETWORK EDGE, OSI LAYERS, PACKET SWITCHING</a:t>
-            </a:r>
-          </a:p>
-        </p:txBody>
-      </p:sp>
-      <p:sp>
-        <p:nvSpPr>
-          <p:cNvPr id="9" name="TextBox 8"/>
-          <p:cNvSpPr txBox="1"/>
-          <p:nvPr/>
-        </p:nvSpPr>
-        <p:spPr>
-          <a:xfrm>
-            <a:off x="914400" y="2880360"/>
-            <a:ext cx="10332720" cy="777240"/>
-          </a:xfrm>
-          <a:prstGeom prst="rect">
-            <a:avLst/>
-          </a:prstGeom>
-          <a:noFill/>
-        </p:spPr>
-        <p:txBody>
-          <a:bodyPr wrap="square" anchor="t">
-            <a:spAutoFit/>
-          </a:bodyPr>
-          <a:lstStyle/>
-          <a:p>
-            <a:pPr algn="l">
-              <a:lnSpc>
-                <a:spcPct val="115000"/>
-              </a:lnSpc>
-            </a:pPr>
-            <a:r>
-              <a:rPr sz="1250" b="0" i="0">
-                <a:solidFill>
-                  <a:srgbClr val="172420"/>
-                </a:solidFill>
-                <a:latin typeface="Calibri"/>
-              </a:rPr>
-              <a:t>Every FLNET2023 record is a network flow captured at a router: ports, packet counts and sizes, TCP flags, inter-arrival times. Our federated clients ARE routers — network edge nodes.</a:t>
-            </a:r>
-          </a:p>
-        </p:txBody>
-      </p:sp>
-      <p:sp>
-        <p:nvSpPr>
-          <p:cNvPr id="10" name="Rounded Rectangle 9"/>
-          <p:cNvSpPr/>
-          <p:nvPr/>
-        </p:nvSpPr>
-        <p:spPr>
-          <a:xfrm>
-            <a:off x="640080" y="3886200"/>
-            <a:ext cx="10881360" cy="1280160"/>
+            <a:off x="7589520" y="2286000"/>
+            <a:ext cx="3931920" cy="914400"/>
           </a:xfrm>
           <a:prstGeom prst="roundRect">
             <a:avLst>
@@ -10501,136 +11187,92 @@
       </p:sp>
       <p:sp>
         <p:nvSpPr>
-          <p:cNvPr id="11" name="Rectangle 10"/>
+          <p:cNvPr id="9" name="TextBox 8"/>
+          <p:cNvSpPr txBox="1"/>
+          <p:nvPr/>
+        </p:nvSpPr>
+        <p:spPr>
+          <a:xfrm>
+            <a:off x="7772400" y="2359152"/>
+            <a:ext cx="3566160" cy="274320"/>
+          </a:xfrm>
+          <a:prstGeom prst="rect">
+            <a:avLst/>
+          </a:prstGeom>
+          <a:noFill/>
+        </p:spPr>
+        <p:txBody>
+          <a:bodyPr wrap="square" anchor="t">
+            <a:spAutoFit/>
+          </a:bodyPr>
+          <a:lstStyle/>
+          <a:p>
+            <a:pPr algn="l">
+              <a:lnSpc>
+                <a:spcPct val="115000"/>
+              </a:lnSpc>
+            </a:pPr>
+            <a:r>
+              <a:rPr sz="1100" b="1" i="0">
+                <a:solidFill>
+                  <a:srgbClr val="146B62"/>
+                </a:solidFill>
+                <a:latin typeface="Calibri"/>
+              </a:rPr>
+              <a:t>CLIENT DROPOUT</a:t>
+            </a:r>
+          </a:p>
+        </p:txBody>
+      </p:sp>
+      <p:sp>
+        <p:nvSpPr>
+          <p:cNvPr id="10" name="TextBox 9"/>
+          <p:cNvSpPr txBox="1"/>
+          <p:nvPr/>
+        </p:nvSpPr>
+        <p:spPr>
+          <a:xfrm>
+            <a:off x="7772400" y="2633472"/>
+            <a:ext cx="3566160" cy="548640"/>
+          </a:xfrm>
+          <a:prstGeom prst="rect">
+            <a:avLst/>
+          </a:prstGeom>
+          <a:noFill/>
+        </p:spPr>
+        <p:txBody>
+          <a:bodyPr wrap="square" anchor="t">
+            <a:spAutoFit/>
+          </a:bodyPr>
+          <a:lstStyle/>
+          <a:p>
+            <a:pPr algn="l">
+              <a:lnSpc>
+                <a:spcPct val="115000"/>
+              </a:lnSpc>
+            </a:pPr>
+            <a:r>
+              <a:rPr sz="1100" b="0" i="0">
+                <a:solidFill>
+                  <a:srgbClr val="172420"/>
+                </a:solidFill>
+                <a:latin typeface="Calibri"/>
+              </a:rPr>
+              <a:t>Still helps at every level, but catches only 36% of poisoned updates when routers are offline 40% of the time.</a:t>
+            </a:r>
+          </a:p>
+        </p:txBody>
+      </p:sp>
+      <p:sp>
+        <p:nvSpPr>
+          <p:cNvPr id="11" name="Rounded Rectangle 10"/>
           <p:cNvSpPr/>
           <p:nvPr/>
         </p:nvSpPr>
         <p:spPr>
           <a:xfrm>
-            <a:off x="640080" y="3886200"/>
-            <a:ext cx="73152" cy="1280160"/>
-          </a:xfrm>
-          <a:prstGeom prst="rect">
-            <a:avLst/>
-          </a:prstGeom>
-          <a:solidFill>
-            <a:srgbClr val="146B62"/>
-          </a:solidFill>
-          <a:ln>
-            <a:noFill/>
-          </a:ln>
-          <a:effectLst/>
-        </p:spPr>
-        <p:style>
-          <a:lnRef idx="1">
-            <a:schemeClr val="accent1"/>
-          </a:lnRef>
-          <a:fillRef idx="3">
-            <a:schemeClr val="accent1"/>
-          </a:fillRef>
-          <a:effectRef idx="2">
-            <a:schemeClr val="accent1"/>
-          </a:effectRef>
-          <a:fontRef idx="minor">
-            <a:schemeClr val="lt1"/>
-          </a:fontRef>
-        </p:style>
-        <p:txBody>
-          <a:bodyPr rtlCol="0" anchor="ctr"/>
-          <a:lstStyle/>
-          <a:p>
-            <a:pPr algn="ctr"/>
-          </a:p>
-        </p:txBody>
-      </p:sp>
-      <p:sp>
-        <p:nvSpPr>
-          <p:cNvPr id="12" name="TextBox 11"/>
-          <p:cNvSpPr txBox="1"/>
-          <p:nvPr/>
-        </p:nvSpPr>
-        <p:spPr>
-          <a:xfrm>
-            <a:off x="914400" y="4023360"/>
-            <a:ext cx="10332720" cy="274320"/>
-          </a:xfrm>
-          <a:prstGeom prst="rect">
-            <a:avLst/>
-          </a:prstGeom>
-          <a:noFill/>
-        </p:spPr>
-        <p:txBody>
-          <a:bodyPr wrap="square" anchor="t">
-            <a:spAutoFit/>
-          </a:bodyPr>
-          <a:lstStyle/>
-          <a:p>
-            <a:pPr algn="l">
-              <a:lnSpc>
-                <a:spcPct val="115000"/>
-              </a:lnSpc>
-            </a:pPr>
-            <a:r>
-              <a:rPr sz="1200" b="1" i="0">
-                <a:solidFill>
-                  <a:srgbClr val="146B62"/>
-                </a:solidFill>
-                <a:latin typeface="Calibri"/>
-              </a:rPr>
-              <a:t>UNIT 2 — APPLICATION LAYER, TRANSPORT LAYER, SOCKETS, ROUTING</a:t>
-            </a:r>
-          </a:p>
-        </p:txBody>
-      </p:sp>
-      <p:sp>
-        <p:nvSpPr>
-          <p:cNvPr id="13" name="TextBox 12"/>
-          <p:cNvSpPr txBox="1"/>
-          <p:nvPr/>
-        </p:nvSpPr>
-        <p:spPr>
-          <a:xfrm>
-            <a:off x="914400" y="4343400"/>
-            <a:ext cx="10332720" cy="777240"/>
-          </a:xfrm>
-          <a:prstGeom prst="rect">
-            <a:avLst/>
-          </a:prstGeom>
-          <a:noFill/>
-        </p:spPr>
-        <p:txBody>
-          <a:bodyPr wrap="square" anchor="t">
-            <a:spAutoFit/>
-          </a:bodyPr>
-          <a:lstStyle/>
-          <a:p>
-            <a:pPr algn="l">
-              <a:lnSpc>
-                <a:spcPct val="115000"/>
-              </a:lnSpc>
-            </a:pPr>
-            <a:r>
-              <a:rPr sz="1250" b="0" i="0">
-                <a:solidFill>
-                  <a:srgbClr val="172420"/>
-                </a:solidFill>
-                <a:latin typeface="Calibri"/>
-              </a:rPr>
-              <a:t>Our custom protocol design is application-layer protocol design (vs. HTTP/gRPC). Client-server exchange mirrors socket-based communication. dst_host_count ties to routing/host addressing.</a:t>
-            </a:r>
-          </a:p>
-        </p:txBody>
-      </p:sp>
-      <p:sp>
-        <p:nvSpPr>
-          <p:cNvPr id="14" name="Rounded Rectangle 13"/>
-          <p:cNvSpPr/>
-          <p:nvPr/>
-        </p:nvSpPr>
-        <p:spPr>
-          <a:xfrm>
-            <a:off x="640080" y="5349240"/>
-            <a:ext cx="10881360" cy="1280160"/>
+            <a:off x="7589520" y="3383280"/>
+            <a:ext cx="3931920" cy="914400"/>
           </a:xfrm>
           <a:prstGeom prst="roundRect">
             <a:avLst>
@@ -10671,23 +11313,105 @@
       </p:sp>
       <p:sp>
         <p:nvSpPr>
-          <p:cNvPr id="15" name="Rectangle 14"/>
+          <p:cNvPr id="12" name="TextBox 11"/>
+          <p:cNvSpPr txBox="1"/>
+          <p:nvPr/>
+        </p:nvSpPr>
+        <p:spPr>
+          <a:xfrm>
+            <a:off x="7772400" y="3456432"/>
+            <a:ext cx="3566160" cy="274320"/>
+          </a:xfrm>
+          <a:prstGeom prst="rect">
+            <a:avLst/>
+          </a:prstGeom>
+          <a:noFill/>
+        </p:spPr>
+        <p:txBody>
+          <a:bodyPr wrap="square" anchor="t">
+            <a:spAutoFit/>
+          </a:bodyPr>
+          <a:lstStyle/>
+          <a:p>
+            <a:pPr algn="l">
+              <a:lnSpc>
+                <a:spcPct val="115000"/>
+              </a:lnSpc>
+            </a:pPr>
+            <a:r>
+              <a:rPr sz="1100" b="1" i="0">
+                <a:solidFill>
+                  <a:srgbClr val="146B62"/>
+                </a:solidFill>
+                <a:latin typeface="Calibri"/>
+              </a:rPr>
+              <a:t>TRAFFIC SHIFT</a:t>
+            </a:r>
+          </a:p>
+        </p:txBody>
+      </p:sp>
+      <p:sp>
+        <p:nvSpPr>
+          <p:cNvPr id="13" name="TextBox 12"/>
+          <p:cNvSpPr txBox="1"/>
+          <p:nvPr/>
+        </p:nvSpPr>
+        <p:spPr>
+          <a:xfrm>
+            <a:off x="7772400" y="3730752"/>
+            <a:ext cx="3566160" cy="548640"/>
+          </a:xfrm>
+          <a:prstGeom prst="rect">
+            <a:avLst/>
+          </a:prstGeom>
+          <a:noFill/>
+        </p:spPr>
+        <p:txBody>
+          <a:bodyPr wrap="square" anchor="t">
+            <a:spAutoFit/>
+          </a:bodyPr>
+          <a:lstStyle/>
+          <a:p>
+            <a:pPr algn="l">
+              <a:lnSpc>
+                <a:spcPct val="115000"/>
+              </a:lnSpc>
+            </a:pPr>
+            <a:r>
+              <a:rPr sz="1100" b="0" i="0">
+                <a:solidFill>
+                  <a:srgbClr val="172420"/>
+                </a:solidFill>
+                <a:latin typeface="Calibri"/>
+              </a:rPr>
+              <a:t>A router suddenly seeing new DDoS traffic was wrongly excluded 0% of the time.</a:t>
+            </a:r>
+          </a:p>
+        </p:txBody>
+      </p:sp>
+      <p:sp>
+        <p:nvSpPr>
+          <p:cNvPr id="14" name="Rounded Rectangle 13"/>
           <p:cNvSpPr/>
           <p:nvPr/>
         </p:nvSpPr>
         <p:spPr>
           <a:xfrm>
-            <a:off x="640080" y="5349240"/>
-            <a:ext cx="73152" cy="1280160"/>
-          </a:xfrm>
-          <a:prstGeom prst="rect">
-            <a:avLst/>
+            <a:off x="7589520" y="4480560"/>
+            <a:ext cx="3931920" cy="914400"/>
+          </a:xfrm>
+          <a:prstGeom prst="roundRect">
+            <a:avLst>
+              <a:gd name="adj" fmla="val 5000"/>
+            </a:avLst>
           </a:prstGeom>
           <a:solidFill>
-            <a:srgbClr val="146B62"/>
+            <a:srgbClr val="FFFFFF"/>
           </a:solidFill>
-          <a:ln>
-            <a:noFill/>
+          <a:ln w="12700">
+            <a:solidFill>
+              <a:srgbClr val="CFD6CB"/>
+            </a:solidFill>
           </a:ln>
           <a:effectLst/>
         </p:spPr>
@@ -10715,39 +11439,78 @@
       </p:sp>
       <p:sp>
         <p:nvSpPr>
+          <p:cNvPr id="15" name="TextBox 14"/>
+          <p:cNvSpPr txBox="1"/>
+          <p:nvPr/>
+        </p:nvSpPr>
+        <p:spPr>
+          <a:xfrm>
+            <a:off x="7772400" y="4553712"/>
+            <a:ext cx="3566160" cy="274320"/>
+          </a:xfrm>
+          <a:prstGeom prst="rect">
+            <a:avLst/>
+          </a:prstGeom>
+          <a:noFill/>
+        </p:spPr>
+        <p:txBody>
+          <a:bodyPr wrap="square" anchor="t">
+            <a:spAutoFit/>
+          </a:bodyPr>
+          <a:lstStyle/>
+          <a:p>
+            <a:pPr algn="l">
+              <a:lnSpc>
+                <a:spcPct val="115000"/>
+              </a:lnSpc>
+            </a:pPr>
+            <a:r>
+              <a:rPr sz="1100" b="1" i="0">
+                <a:solidFill>
+                  <a:srgbClr val="146B62"/>
+                </a:solidFill>
+                <a:latin typeface="Calibri"/>
+              </a:rPr>
+              <a:t>10 → 20 → 40 CLIENTS</a:t>
+            </a:r>
+          </a:p>
+        </p:txBody>
+      </p:sp>
+      <p:sp>
+        <p:nvSpPr>
           <p:cNvPr id="16" name="TextBox 15"/>
           <p:cNvSpPr txBox="1"/>
           <p:nvPr/>
         </p:nvSpPr>
         <p:spPr>
           <a:xfrm>
-            <a:off x="914400" y="5486400"/>
-            <a:ext cx="10332720" cy="274320"/>
-          </a:xfrm>
-          <a:prstGeom prst="rect">
-            <a:avLst/>
-          </a:prstGeom>
-          <a:noFill/>
-        </p:spPr>
-        <p:txBody>
-          <a:bodyPr wrap="square" anchor="t">
-            <a:spAutoFit/>
-          </a:bodyPr>
-          <a:lstStyle/>
-          <a:p>
-            <a:pPr algn="l">
-              <a:lnSpc>
-                <a:spcPct val="115000"/>
-              </a:lnSpc>
-            </a:pPr>
-            <a:r>
-              <a:rPr sz="1200" b="1" i="0">
-                <a:solidFill>
-                  <a:srgbClr val="146B62"/>
-                </a:solidFill>
-                <a:latin typeface="Calibri"/>
-              </a:rPr>
-              <a:t>UNIT 3 — IOT, FOG/CLOUD COMPUTING, SDN</a:t>
+            <a:off x="7772400" y="4828032"/>
+            <a:ext cx="3566160" cy="548640"/>
+          </a:xfrm>
+          <a:prstGeom prst="rect">
+            <a:avLst/>
+          </a:prstGeom>
+          <a:noFill/>
+        </p:spPr>
+        <p:txBody>
+          <a:bodyPr wrap="square" anchor="t">
+            <a:spAutoFit/>
+          </a:bodyPr>
+          <a:lstStyle/>
+          <a:p>
+            <a:pPr algn="l">
+              <a:lnSpc>
+                <a:spcPct val="115000"/>
+              </a:lnSpc>
+            </a:pPr>
+            <a:r>
+              <a:rPr sz="1100" b="0" i="0">
+                <a:solidFill>
+                  <a:srgbClr val="172420"/>
+                </a:solidFill>
+                <a:latin typeface="Calibri"/>
+              </a:rPr>
+              <a:t>Catches 71% → 89% → 84%; server time 24 → 37 → 73 ms per round.</a:t>
             </a:r>
           </a:p>
         </p:txBody>
@@ -10760,33 +11523,33 @@
         </p:nvSpPr>
         <p:spPr>
           <a:xfrm>
-            <a:off x="914400" y="5806440"/>
-            <a:ext cx="10332720" cy="777240"/>
-          </a:xfrm>
-          <a:prstGeom prst="rect">
-            <a:avLst/>
-          </a:prstGeom>
-          <a:noFill/>
-        </p:spPr>
-        <p:txBody>
-          <a:bodyPr wrap="square" anchor="t">
-            <a:spAutoFit/>
-          </a:bodyPr>
-          <a:lstStyle/>
-          <a:p>
-            <a:pPr algn="l">
-              <a:lnSpc>
-                <a:spcPct val="115000"/>
-              </a:lnSpc>
-            </a:pPr>
-            <a:r>
-              <a:rPr sz="1250" b="0" i="0">
+            <a:off x="640080" y="5623560"/>
+            <a:ext cx="10881360" cy="822960"/>
+          </a:xfrm>
+          <a:prstGeom prst="rect">
+            <a:avLst/>
+          </a:prstGeom>
+          <a:noFill/>
+        </p:spPr>
+        <p:txBody>
+          <a:bodyPr wrap="square" anchor="t">
+            <a:spAutoFit/>
+          </a:bodyPr>
+          <a:lstStyle/>
+          <a:p>
+            <a:pPr algn="l">
+              <a:lnSpc>
+                <a:spcPct val="115000"/>
+              </a:lnSpc>
+            </a:pPr>
+            <a:r>
+              <a:rPr sz="1300" b="0" i="0">
                 <a:solidFill>
                   <a:srgbClr val="172420"/>
                 </a:solidFill>
                 <a:latin typeface="Calibri"/>
               </a:rPr>
-              <a:t>Federated Learning's architecture IS fog computing: local processing at the edge, summarized results to a central aggregator. Our custom protocol mirrors SDN/OpenFlow — customizing behavior beyond fixed defaults.</a:t>
+              <a:t>More clients make the protocol stronger; heavy dropout makes it weaker. Mondrian thresholds still showed no significant gain over a global threshold, even at 40 clients.</a:t>
             </a:r>
           </a:p>
         </p:txBody>

</xml_diff>